<commit_message>
docs: record 1.3.1 symposium evidence
</commit_message>
<xml_diff>
--- a/docs/presentations/literate-ai-1.3.1-release-briefing/literate-ai-1.3.1-release-briefing.pptx
+++ b/docs/presentations/literate-ai-1.3.1-release-briefing/literate-ai-1.3.1-release-briefing.pptx
@@ -2,24 +2,24 @@
 <file path=ppt/presentation.xml><?xml version="1.0" encoding="utf-8"?>
 <p:presentation xmlns:p="http://schemas.openxmlformats.org/presentationml/2006/main">
   <p:sldMasterIdLst>
-    <p:sldMasterId xmlns:r="http://schemas.openxmlformats.org/officeDocument/2006/relationships" id="2147483648" r:id="R1ff1baa50f55421f"/>
+    <p:sldMasterId xmlns:r="http://schemas.openxmlformats.org/officeDocument/2006/relationships" id="2147483648" r:id="Rf6d6896b1bff4154"/>
   </p:sldMasterIdLst>
   <p:notesMasterIdLst>
-    <p:notesMasterId xmlns:r="http://schemas.openxmlformats.org/officeDocument/2006/relationships" r:id="R66852164c2f548c5"/>
+    <p:notesMasterId xmlns:r="http://schemas.openxmlformats.org/officeDocument/2006/relationships" r:id="R150e57fd073a4308"/>
   </p:notesMasterIdLst>
   <p:sldIdLst>
-    <p:sldId xmlns:r="http://schemas.openxmlformats.org/officeDocument/2006/relationships" id="256" r:id="Ra3aaa659c1c7463b"/>
-    <p:sldId xmlns:r="http://schemas.openxmlformats.org/officeDocument/2006/relationships" id="257" r:id="R24534d66584a4f78"/>
-    <p:sldId xmlns:r="http://schemas.openxmlformats.org/officeDocument/2006/relationships" id="258" r:id="R36ac7cde5b744961"/>
-    <p:sldId xmlns:r="http://schemas.openxmlformats.org/officeDocument/2006/relationships" id="259" r:id="R76df46a092b24dc2"/>
-    <p:sldId xmlns:r="http://schemas.openxmlformats.org/officeDocument/2006/relationships" id="260" r:id="Rb20aae990120476d"/>
-    <p:sldId xmlns:r="http://schemas.openxmlformats.org/officeDocument/2006/relationships" id="261" r:id="R5093c6fd29914375"/>
-    <p:sldId xmlns:r="http://schemas.openxmlformats.org/officeDocument/2006/relationships" id="262" r:id="Rc179d09ba98e413f"/>
-    <p:sldId xmlns:r="http://schemas.openxmlformats.org/officeDocument/2006/relationships" id="263" r:id="Re48a79f59a8145d1"/>
-    <p:sldId xmlns:r="http://schemas.openxmlformats.org/officeDocument/2006/relationships" id="264" r:id="R2f0e1dd320ac479e"/>
-    <p:sldId xmlns:r="http://schemas.openxmlformats.org/officeDocument/2006/relationships" id="265" r:id="Ra9af08fb2cf14228"/>
-    <p:sldId xmlns:r="http://schemas.openxmlformats.org/officeDocument/2006/relationships" id="266" r:id="R5ed6842b164d4134"/>
-    <p:sldId xmlns:r="http://schemas.openxmlformats.org/officeDocument/2006/relationships" id="267" r:id="R966fcf292294440c"/>
+    <p:sldId xmlns:r="http://schemas.openxmlformats.org/officeDocument/2006/relationships" id="256" r:id="R7ca1c48a9a4540cb"/>
+    <p:sldId xmlns:r="http://schemas.openxmlformats.org/officeDocument/2006/relationships" id="257" r:id="R741c874282ca41c1"/>
+    <p:sldId xmlns:r="http://schemas.openxmlformats.org/officeDocument/2006/relationships" id="258" r:id="R7f592f592af641a7"/>
+    <p:sldId xmlns:r="http://schemas.openxmlformats.org/officeDocument/2006/relationships" id="259" r:id="R4e06290cf2f64214"/>
+    <p:sldId xmlns:r="http://schemas.openxmlformats.org/officeDocument/2006/relationships" id="260" r:id="Ra197f686748c4e38"/>
+    <p:sldId xmlns:r="http://schemas.openxmlformats.org/officeDocument/2006/relationships" id="261" r:id="R571c839857884aa2"/>
+    <p:sldId xmlns:r="http://schemas.openxmlformats.org/officeDocument/2006/relationships" id="262" r:id="Re2af2dd7eb7b4c6e"/>
+    <p:sldId xmlns:r="http://schemas.openxmlformats.org/officeDocument/2006/relationships" id="263" r:id="Rcebfe6c4fb1243c4"/>
+    <p:sldId xmlns:r="http://schemas.openxmlformats.org/officeDocument/2006/relationships" id="264" r:id="R73152583f5994182"/>
+    <p:sldId xmlns:r="http://schemas.openxmlformats.org/officeDocument/2006/relationships" id="265" r:id="R691ff1342d09403c"/>
+    <p:sldId xmlns:r="http://schemas.openxmlformats.org/officeDocument/2006/relationships" id="266" r:id="R096f61bb65644b2b"/>
+    <p:sldId xmlns:r="http://schemas.openxmlformats.org/officeDocument/2006/relationships" id="267" r:id="R6da2764162424227"/>
   </p:sldIdLst>
   <p:sldSz cx="12192000" cy="6858000"/>
   <p:notesSz cx="6858000" cy="9144000"/>
@@ -468,7 +468,7 @@
           </a:p>
           <a:p xmlns:a="http://schemas.openxmlformats.org/drawingml/2006/main">
             <a:r>
-              <a:t>GitHub Actions run 40460869302</a:t>
+              <a:t>GitHub Actions run 40494175198</a:t>
             </a:r>
           </a:p>
         </p:txBody>
@@ -558,7 +558,7 @@
           </a:p>
           <a:p xmlns:a="http://schemas.openxmlformats.org/drawingml/2006/main">
             <a:r>
-              <a:t>GitHub Actions run 40460869302</a:t>
+              <a:t>GitHub Actions run 40494175198</a:t>
             </a:r>
           </a:p>
         </p:txBody>
@@ -1445,7 +1445,7 @@
           <p:cNvPr id="3" name="Title">
             <a:extLst xmlns:a="http://schemas.openxmlformats.org/drawingml/2006/main">
               <a:ext uri="{FF2B5EF4-FFF2-40B4-BE49-F238E27FC236}">
-                <a16:creationId xmlns:a16="http://schemas.microsoft.com/office/drawing/2014/main" id="{0A50010E-DBCE-4F34-A630-FCC4B9973120}"/>
+                <a16:creationId xmlns:a16="http://schemas.microsoft.com/office/drawing/2014/main" id="{DDE92EF8-4A98-4F30-817C-D5CE1FC3B866}"/>
               </a:ext>
             </a:extLst>
           </p:cNvPr>
@@ -1674,7 +1674,7 @@
           <p:cNvPr id="2" name="Subtitle">
             <a:extLst xmlns:a="http://schemas.openxmlformats.org/drawingml/2006/main">
               <a:ext uri="{FF2B5EF4-FFF2-40B4-BE49-F238E27FC236}">
-                <a16:creationId xmlns:a16="http://schemas.microsoft.com/office/drawing/2014/main" id="{6C4C6B22-AB6F-4EDC-9753-4F577A0B7797}"/>
+                <a16:creationId xmlns:a16="http://schemas.microsoft.com/office/drawing/2014/main" id="{5F9BE146-7367-411F-A9A7-55C16494C058}"/>
               </a:ext>
             </a:extLst>
           </p:cNvPr>
@@ -1920,7 +1920,7 @@
           <p:cNvPr id="2" name="Section title">
             <a:extLst xmlns:a="http://schemas.openxmlformats.org/drawingml/2006/main">
               <a:ext uri="{FF2B5EF4-FFF2-40B4-BE49-F238E27FC236}">
-                <a16:creationId xmlns:a16="http://schemas.microsoft.com/office/drawing/2014/main" id="{A740D502-FFFE-4A56-9CCB-37BEDFDBCA99}"/>
+                <a16:creationId xmlns:a16="http://schemas.microsoft.com/office/drawing/2014/main" id="{DB6CD05D-806C-4787-9457-42FBBED625B7}"/>
               </a:ext>
             </a:extLst>
           </p:cNvPr>
@@ -2166,7 +2166,7 @@
           <p:cNvPr id="3" name="Title">
             <a:extLst xmlns:a="http://schemas.openxmlformats.org/drawingml/2006/main">
               <a:ext uri="{FF2B5EF4-FFF2-40B4-BE49-F238E27FC236}">
-                <a16:creationId xmlns:a16="http://schemas.microsoft.com/office/drawing/2014/main" id="{A8B638F8-75E1-4B0D-AD56-403B0BD6F4B6}"/>
+                <a16:creationId xmlns:a16="http://schemas.microsoft.com/office/drawing/2014/main" id="{9083E8FE-AF0C-4416-9E6E-F7E00D80A32F}"/>
               </a:ext>
             </a:extLst>
           </p:cNvPr>
@@ -2395,7 +2395,7 @@
           <p:cNvPr id="2" name="Body">
             <a:extLst xmlns:a="http://schemas.openxmlformats.org/drawingml/2006/main">
               <a:ext uri="{FF2B5EF4-FFF2-40B4-BE49-F238E27FC236}">
-                <a16:creationId xmlns:a16="http://schemas.microsoft.com/office/drawing/2014/main" id="{C42C7964-8B68-4B97-A765-385CA18065E6}"/>
+                <a16:creationId xmlns:a16="http://schemas.microsoft.com/office/drawing/2014/main" id="{F413BEE0-B441-4987-9049-E159FD074DA4}"/>
               </a:ext>
             </a:extLst>
           </p:cNvPr>
@@ -2641,7 +2641,7 @@
           <p:cNvPr id="4" name="Title">
             <a:extLst xmlns:a="http://schemas.openxmlformats.org/drawingml/2006/main">
               <a:ext uri="{FF2B5EF4-FFF2-40B4-BE49-F238E27FC236}">
-                <a16:creationId xmlns:a16="http://schemas.microsoft.com/office/drawing/2014/main" id="{928F7787-E603-405A-BCBF-F31658BE8CA2}"/>
+                <a16:creationId xmlns:a16="http://schemas.microsoft.com/office/drawing/2014/main" id="{23E5C8C1-6620-4AEA-9AA0-559270DA2179}"/>
               </a:ext>
             </a:extLst>
           </p:cNvPr>
@@ -2870,7 +2870,7 @@
           <p:cNvPr id="2" name="Left column">
             <a:extLst xmlns:a="http://schemas.openxmlformats.org/drawingml/2006/main">
               <a:ext uri="{FF2B5EF4-FFF2-40B4-BE49-F238E27FC236}">
-                <a16:creationId xmlns:a16="http://schemas.microsoft.com/office/drawing/2014/main" id="{A59219EC-D0C6-417C-BA23-047D9DC3049E}"/>
+                <a16:creationId xmlns:a16="http://schemas.microsoft.com/office/drawing/2014/main" id="{91DAB65F-639F-496A-9737-334BBE0D547C}"/>
               </a:ext>
             </a:extLst>
           </p:cNvPr>
@@ -3099,7 +3099,7 @@
           <p:cNvPr id="3" name="Right column">
             <a:extLst xmlns:a="http://schemas.openxmlformats.org/drawingml/2006/main">
               <a:ext uri="{FF2B5EF4-FFF2-40B4-BE49-F238E27FC236}">
-                <a16:creationId xmlns:a16="http://schemas.microsoft.com/office/drawing/2014/main" id="{0ADD8123-42B6-4828-A503-CB037430F96C}"/>
+                <a16:creationId xmlns:a16="http://schemas.microsoft.com/office/drawing/2014/main" id="{21CC8D0C-E456-4233-A8CB-F1F2C835BA85}"/>
               </a:ext>
             </a:extLst>
           </p:cNvPr>
@@ -3345,7 +3345,7 @@
           <p:cNvPr id="3" name="Title">
             <a:extLst xmlns:a="http://schemas.openxmlformats.org/drawingml/2006/main">
               <a:ext uri="{FF2B5EF4-FFF2-40B4-BE49-F238E27FC236}">
-                <a16:creationId xmlns:a16="http://schemas.microsoft.com/office/drawing/2014/main" id="{0FF04D7F-98CB-4047-852F-38AFCDC0AFD2}"/>
+                <a16:creationId xmlns:a16="http://schemas.microsoft.com/office/drawing/2014/main" id="{4B9864E9-B09B-4893-B6C3-D9EB81FD9A64}"/>
               </a:ext>
             </a:extLst>
           </p:cNvPr>
@@ -3574,7 +3574,7 @@
           <p:cNvPr id="2" name="Left column">
             <a:extLst xmlns:a="http://schemas.openxmlformats.org/drawingml/2006/main">
               <a:ext uri="{FF2B5EF4-FFF2-40B4-BE49-F238E27FC236}">
-                <a16:creationId xmlns:a16="http://schemas.microsoft.com/office/drawing/2014/main" id="{BC6693EA-1A98-4147-AA84-D59141360270}"/>
+                <a16:creationId xmlns:a16="http://schemas.microsoft.com/office/drawing/2014/main" id="{44CBA301-BB81-4873-ADDC-8E9C35085031}"/>
               </a:ext>
             </a:extLst>
           </p:cNvPr>
@@ -3841,12 +3841,12 @@
   </p:cSld>
   <p:clrMap bg1="lt1" tx1="dk1" bg2="lt2" tx2="dk2" accent1="accent1" accent2="accent2" accent3="accent3" accent4="accent4" accent5="accent5" accent6="accent6" hlink="hlink" folHlink="folHlink"/>
   <p:sldLayoutIdLst>
-    <p:sldLayoutId xmlns:r="http://schemas.openxmlformats.org/officeDocument/2006/relationships" id="2147483649" r:id="R196eab4a2af64364"/>
-    <p:sldLayoutId xmlns:r="http://schemas.openxmlformats.org/officeDocument/2006/relationships" id="2147483650" r:id="Rdcd679d18f8b429d"/>
-    <p:sldLayoutId xmlns:r="http://schemas.openxmlformats.org/officeDocument/2006/relationships" id="2147483651" r:id="R417c8fa1799f4455"/>
-    <p:sldLayoutId xmlns:r="http://schemas.openxmlformats.org/officeDocument/2006/relationships" id="2147483652" r:id="R60ec0d18276e45fe"/>
-    <p:sldLayoutId xmlns:r="http://schemas.openxmlformats.org/officeDocument/2006/relationships" id="2147483653" r:id="R14c1b7ec6bee4586"/>
-    <p:sldLayoutId xmlns:r="http://schemas.openxmlformats.org/officeDocument/2006/relationships" id="2147483654" r:id="R17fbb1bc322a431c"/>
+    <p:sldLayoutId xmlns:r="http://schemas.openxmlformats.org/officeDocument/2006/relationships" id="2147483649" r:id="Rdb3b80484d0d4f91"/>
+    <p:sldLayoutId xmlns:r="http://schemas.openxmlformats.org/officeDocument/2006/relationships" id="2147483650" r:id="R64a7923c0c384229"/>
+    <p:sldLayoutId xmlns:r="http://schemas.openxmlformats.org/officeDocument/2006/relationships" id="2147483651" r:id="R7ab3fe4c2e7f4eec"/>
+    <p:sldLayoutId xmlns:r="http://schemas.openxmlformats.org/officeDocument/2006/relationships" id="2147483652" r:id="R27857689a15c4294"/>
+    <p:sldLayoutId xmlns:r="http://schemas.openxmlformats.org/officeDocument/2006/relationships" id="2147483653" r:id="Rabe94947ce974977"/>
+    <p:sldLayoutId xmlns:r="http://schemas.openxmlformats.org/officeDocument/2006/relationships" id="2147483654" r:id="Red30f33f24b24ad9"/>
   </p:sldLayoutIdLst>
   <p:txStyles>
     <p:titleStyle>
@@ -4397,7 +4397,7 @@
           <p:cNvPr id="7" name="">
             <a:extLst xmlns:a="http://schemas.openxmlformats.org/drawingml/2006/main">
               <a:ext uri="{FF2B5EF4-FFF2-40B4-BE49-F238E27FC236}">
-                <a16:creationId xmlns:a16="http://schemas.microsoft.com/office/drawing/2014/main" id="{A3B79BE9-A32C-4E58-B3A4-6E7FAA863856}"/>
+                <a16:creationId xmlns:a16="http://schemas.microsoft.com/office/drawing/2014/main" id="{DE4310EA-B76A-4CAC-BD7D-D163CCBACD9D}"/>
               </a:ext>
             </a:extLst>
           </p:cNvPr>
@@ -4427,7 +4427,7 @@
           <p:cNvPr id="2" name="">
             <a:extLst xmlns:a="http://schemas.openxmlformats.org/drawingml/2006/main">
               <a:ext uri="{FF2B5EF4-FFF2-40B4-BE49-F238E27FC236}">
-                <a16:creationId xmlns:a16="http://schemas.microsoft.com/office/drawing/2014/main" id="{367767E4-93ED-4D25-9DBC-C81CBD1F03B2}"/>
+                <a16:creationId xmlns:a16="http://schemas.microsoft.com/office/drawing/2014/main" id="{C335D77F-905E-4BA8-8421-360ED846CEAB}"/>
               </a:ext>
             </a:extLst>
           </p:cNvPr>
@@ -4547,7 +4547,7 @@
           <p:cNvPr id="3" name="">
             <a:extLst xmlns:a="http://schemas.openxmlformats.org/drawingml/2006/main">
               <a:ext uri="{FF2B5EF4-FFF2-40B4-BE49-F238E27FC236}">
-                <a16:creationId xmlns:a16="http://schemas.microsoft.com/office/drawing/2014/main" id="{7F2EF420-AC49-4056-9940-8C80DB101235}"/>
+                <a16:creationId xmlns:a16="http://schemas.microsoft.com/office/drawing/2014/main" id="{EB9D66D4-F87F-43E7-9F9E-CA7163AA9F01}"/>
               </a:ext>
             </a:extLst>
           </p:cNvPr>
@@ -4667,7 +4667,7 @@
           <p:cNvPr id="4" name="">
             <a:extLst xmlns:a="http://schemas.openxmlformats.org/drawingml/2006/main">
               <a:ext uri="{FF2B5EF4-FFF2-40B4-BE49-F238E27FC236}">
-                <a16:creationId xmlns:a16="http://schemas.microsoft.com/office/drawing/2014/main" id="{4FBCD5AD-9507-4972-A818-B9CA8458C27A}"/>
+                <a16:creationId xmlns:a16="http://schemas.microsoft.com/office/drawing/2014/main" id="{C31EBF20-BEDF-4DF8-B2CB-83AC5630B83E}"/>
               </a:ext>
             </a:extLst>
           </p:cNvPr>
@@ -4787,7 +4787,7 @@
           <p:cNvPr id="5" name="">
             <a:extLst xmlns:a="http://schemas.openxmlformats.org/drawingml/2006/main">
               <a:ext uri="{FF2B5EF4-FFF2-40B4-BE49-F238E27FC236}">
-                <a16:creationId xmlns:a16="http://schemas.microsoft.com/office/drawing/2014/main" id="{1F1A36F1-1571-4E79-822C-B9790141D3F1}"/>
+                <a16:creationId xmlns:a16="http://schemas.microsoft.com/office/drawing/2014/main" id="{DF16B940-F900-4A22-845D-09B3E2DB9132}"/>
               </a:ext>
             </a:extLst>
           </p:cNvPr>
@@ -4907,7 +4907,7 @@
           <p:cNvPr id="6" name="">
             <a:extLst xmlns:a="http://schemas.openxmlformats.org/drawingml/2006/main">
               <a:ext uri="{FF2B5EF4-FFF2-40B4-BE49-F238E27FC236}">
-                <a16:creationId xmlns:a16="http://schemas.microsoft.com/office/drawing/2014/main" id="{A64092C6-464C-4FFF-9C62-5CB3D1ED8010}"/>
+                <a16:creationId xmlns:a16="http://schemas.microsoft.com/office/drawing/2014/main" id="{FDAF8693-F6A1-4D60-B3B6-B16A409618EA}"/>
               </a:ext>
             </a:extLst>
           </p:cNvPr>
@@ -5042,7 +5042,7 @@
     </p:spTree>
     <p:extLst>
       <p:ext uri="{BB962C8B-B14F-4D97-AF65-F5344CB8AC3E}">
-        <p14:creationId xmlns:p14="http://schemas.microsoft.com/office/powerpoint/2010/main" val="1780365847"/>
+        <p14:creationId xmlns:p14="http://schemas.microsoft.com/office/powerpoint/2010/main" val="1726154670"/>
       </p:ext>
     </p:extLst>
   </p:cSld>
@@ -5073,7 +5073,7 @@
           <p:cNvPr id="23" name="">
             <a:extLst xmlns:a="http://schemas.openxmlformats.org/drawingml/2006/main">
               <a:ext uri="{FF2B5EF4-FFF2-40B4-BE49-F238E27FC236}">
-                <a16:creationId xmlns:a16="http://schemas.microsoft.com/office/drawing/2014/main" id="{29034A76-8DE5-4D54-B305-9747266A4069}"/>
+                <a16:creationId xmlns:a16="http://schemas.microsoft.com/office/drawing/2014/main" id="{1B0B9A98-FE0E-4B04-B238-AF47175F6152}"/>
               </a:ext>
             </a:extLst>
           </p:cNvPr>
@@ -5193,7 +5193,7 @@
           <p:cNvPr id="2" name="">
             <a:extLst xmlns:a="http://schemas.openxmlformats.org/drawingml/2006/main">
               <a:ext uri="{FF2B5EF4-FFF2-40B4-BE49-F238E27FC236}">
-                <a16:creationId xmlns:a16="http://schemas.microsoft.com/office/drawing/2014/main" id="{BE16E97B-87A3-401D-B817-B8B61752591D}"/>
+                <a16:creationId xmlns:a16="http://schemas.microsoft.com/office/drawing/2014/main" id="{3D021B9A-ACEE-40BD-836E-60417A5888D6}"/>
               </a:ext>
             </a:extLst>
           </p:cNvPr>
@@ -5313,7 +5313,7 @@
           <p:cNvPr id="3" name="">
             <a:extLst xmlns:a="http://schemas.openxmlformats.org/drawingml/2006/main">
               <a:ext uri="{FF2B5EF4-FFF2-40B4-BE49-F238E27FC236}">
-                <a16:creationId xmlns:a16="http://schemas.microsoft.com/office/drawing/2014/main" id="{1388B7D7-A240-4E8C-BD67-2558048FDF4D}"/>
+                <a16:creationId xmlns:a16="http://schemas.microsoft.com/office/drawing/2014/main" id="{54F1B68C-16B9-4CBC-A13F-BD5F1A5B4A93}"/>
               </a:ext>
             </a:extLst>
           </p:cNvPr>
@@ -5343,7 +5343,7 @@
           <p:cNvPr id="4" name="">
             <a:extLst xmlns:a="http://schemas.openxmlformats.org/drawingml/2006/main">
               <a:ext uri="{FF2B5EF4-FFF2-40B4-BE49-F238E27FC236}">
-                <a16:creationId xmlns:a16="http://schemas.microsoft.com/office/drawing/2014/main" id="{EA62461D-B6F6-4DF4-AF03-76A3B13F0098}"/>
+                <a16:creationId xmlns:a16="http://schemas.microsoft.com/office/drawing/2014/main" id="{F003FBAB-33A1-4477-952E-FE791D48349B}"/>
               </a:ext>
             </a:extLst>
           </p:cNvPr>
@@ -5463,7 +5463,7 @@
           <p:cNvPr id="5" name="">
             <a:extLst xmlns:a="http://schemas.openxmlformats.org/drawingml/2006/main">
               <a:ext uri="{FF2B5EF4-FFF2-40B4-BE49-F238E27FC236}">
-                <a16:creationId xmlns:a16="http://schemas.microsoft.com/office/drawing/2014/main" id="{2E23EAB0-CB83-4E6B-B3FD-6B1A8221CB8F}"/>
+                <a16:creationId xmlns:a16="http://schemas.microsoft.com/office/drawing/2014/main" id="{83FDC33A-82EE-4166-BCE2-F6C4535B583A}"/>
               </a:ext>
             </a:extLst>
           </p:cNvPr>
@@ -5583,7 +5583,7 @@
           <p:cNvPr id="6" name="">
             <a:extLst xmlns:a="http://schemas.openxmlformats.org/drawingml/2006/main">
               <a:ext uri="{FF2B5EF4-FFF2-40B4-BE49-F238E27FC236}">
-                <a16:creationId xmlns:a16="http://schemas.microsoft.com/office/drawing/2014/main" id="{D9075278-3D16-4607-ABC6-4D6A0A926E44}"/>
+                <a16:creationId xmlns:a16="http://schemas.microsoft.com/office/drawing/2014/main" id="{826828F9-139B-459C-80C5-4DE070116A6E}"/>
               </a:ext>
             </a:extLst>
           </p:cNvPr>
@@ -5693,7 +5693,7 @@
                   <a:srgbClr val="536675"/>
                 </a:solidFill>
               </a:rPr>
-              <a:t>Merge commit 3b606d42c; run 40460869302 completed successfully</a:t>
+              <a:t>Merge commit 8f93802a; run 40494175198 completed successfully</a:t>
             </a:r>
           </a:p>
         </p:txBody>
@@ -5703,7 +5703,7 @@
           <p:cNvPr id="7" name="">
             <a:extLst xmlns:a="http://schemas.openxmlformats.org/drawingml/2006/main">
               <a:ext uri="{FF2B5EF4-FFF2-40B4-BE49-F238E27FC236}">
-                <a16:creationId xmlns:a16="http://schemas.microsoft.com/office/drawing/2014/main" id="{A8D22BCC-252D-4B1D-BE11-63C1C14BE744}"/>
+                <a16:creationId xmlns:a16="http://schemas.microsoft.com/office/drawing/2014/main" id="{2767094C-5B6D-4DF4-921C-1400C4E0D7F4}"/>
               </a:ext>
             </a:extLst>
           </p:cNvPr>
@@ -5733,7 +5733,7 @@
           <p:cNvPr id="8" name="">
             <a:extLst xmlns:a="http://schemas.openxmlformats.org/drawingml/2006/main">
               <a:ext uri="{FF2B5EF4-FFF2-40B4-BE49-F238E27FC236}">
-                <a16:creationId xmlns:a16="http://schemas.microsoft.com/office/drawing/2014/main" id="{DBF4565D-E144-4538-9494-F2BF56656388}"/>
+                <a16:creationId xmlns:a16="http://schemas.microsoft.com/office/drawing/2014/main" id="{2EA49196-F6E6-4A22-9061-2F6574332687}"/>
               </a:ext>
             </a:extLst>
           </p:cNvPr>
@@ -5853,7 +5853,7 @@
           <p:cNvPr id="9" name="">
             <a:extLst xmlns:a="http://schemas.openxmlformats.org/drawingml/2006/main">
               <a:ext uri="{FF2B5EF4-FFF2-40B4-BE49-F238E27FC236}">
-                <a16:creationId xmlns:a16="http://schemas.microsoft.com/office/drawing/2014/main" id="{373F33EB-E9F9-43AB-81F1-1EF99B0D0798}"/>
+                <a16:creationId xmlns:a16="http://schemas.microsoft.com/office/drawing/2014/main" id="{707E0130-FF4A-4F6B-BC10-CB6646C6C143}"/>
               </a:ext>
             </a:extLst>
           </p:cNvPr>
@@ -5963,7 +5963,7 @@
                   <a:srgbClr val="B6463A"/>
                 </a:solidFill>
               </a:rPr>
-              <a:t>1 OF 18 COMPLETE</a:t>
+              <a:t>3 OF 18 COMPLETE</a:t>
             </a:r>
           </a:p>
         </p:txBody>
@@ -5973,7 +5973,7 @@
           <p:cNvPr id="10" name="">
             <a:extLst xmlns:a="http://schemas.openxmlformats.org/drawingml/2006/main">
               <a:ext uri="{FF2B5EF4-FFF2-40B4-BE49-F238E27FC236}">
-                <a16:creationId xmlns:a16="http://schemas.microsoft.com/office/drawing/2014/main" id="{26CDAE89-C62D-430C-BC2D-6E6637C34F62}"/>
+                <a16:creationId xmlns:a16="http://schemas.microsoft.com/office/drawing/2014/main" id="{C3EB7DFE-5693-4627-8640-71A3EF1B5755}"/>
               </a:ext>
             </a:extLst>
           </p:cNvPr>
@@ -6083,7 +6083,7 @@
                   <a:srgbClr val="536675"/>
                 </a:solidFill>
               </a:rPr>
-              <a:t>Seventeen declared goals remain blocking until their recorded acceptance is complete</a:t>
+              <a:t>Fifteen declared goals remain blocking until their recorded acceptance is complete</a:t>
             </a:r>
           </a:p>
         </p:txBody>
@@ -6093,7 +6093,7 @@
           <p:cNvPr id="11" name="">
             <a:extLst xmlns:a="http://schemas.openxmlformats.org/drawingml/2006/main">
               <a:ext uri="{FF2B5EF4-FFF2-40B4-BE49-F238E27FC236}">
-                <a16:creationId xmlns:a16="http://schemas.microsoft.com/office/drawing/2014/main" id="{C1A876D1-F370-43E0-BF63-190AD7BF5F2B}"/>
+                <a16:creationId xmlns:a16="http://schemas.microsoft.com/office/drawing/2014/main" id="{040E23D9-E1EC-4553-9461-08954C2454B5}"/>
               </a:ext>
             </a:extLst>
           </p:cNvPr>
@@ -6123,7 +6123,7 @@
           <p:cNvPr id="12" name="">
             <a:extLst xmlns:a="http://schemas.openxmlformats.org/drawingml/2006/main">
               <a:ext uri="{FF2B5EF4-FFF2-40B4-BE49-F238E27FC236}">
-                <a16:creationId xmlns:a16="http://schemas.microsoft.com/office/drawing/2014/main" id="{EC658995-CF3C-47C4-8D6F-B529972047F9}"/>
+                <a16:creationId xmlns:a16="http://schemas.microsoft.com/office/drawing/2014/main" id="{CD012A4E-30A8-443B-9BB0-DFAB415446C3}"/>
               </a:ext>
             </a:extLst>
           </p:cNvPr>
@@ -6243,7 +6243,7 @@
           <p:cNvPr id="13" name="">
             <a:extLst xmlns:a="http://schemas.openxmlformats.org/drawingml/2006/main">
               <a:ext uri="{FF2B5EF4-FFF2-40B4-BE49-F238E27FC236}">
-                <a16:creationId xmlns:a16="http://schemas.microsoft.com/office/drawing/2014/main" id="{3A05551F-C320-4D52-9DDC-101DAB819149}"/>
+                <a16:creationId xmlns:a16="http://schemas.microsoft.com/office/drawing/2014/main" id="{433DBD2F-145A-474B-8CB1-40C681A1E3A3}"/>
               </a:ext>
             </a:extLst>
           </p:cNvPr>
@@ -6363,7 +6363,7 @@
           <p:cNvPr id="14" name="">
             <a:extLst xmlns:a="http://schemas.openxmlformats.org/drawingml/2006/main">
               <a:ext uri="{FF2B5EF4-FFF2-40B4-BE49-F238E27FC236}">
-                <a16:creationId xmlns:a16="http://schemas.microsoft.com/office/drawing/2014/main" id="{0D52224E-1FD2-484E-B227-CD5CCF6A36FC}"/>
+                <a16:creationId xmlns:a16="http://schemas.microsoft.com/office/drawing/2014/main" id="{6641FD26-724A-4577-928E-8578E1349F70}"/>
               </a:ext>
             </a:extLst>
           </p:cNvPr>
@@ -6483,7 +6483,7 @@
           <p:cNvPr id="15" name="">
             <a:extLst xmlns:a="http://schemas.openxmlformats.org/drawingml/2006/main">
               <a:ext uri="{FF2B5EF4-FFF2-40B4-BE49-F238E27FC236}">
-                <a16:creationId xmlns:a16="http://schemas.microsoft.com/office/drawing/2014/main" id="{D15309B3-971C-40E2-ADFA-22424A1A054C}"/>
+                <a16:creationId xmlns:a16="http://schemas.microsoft.com/office/drawing/2014/main" id="{BA866E9E-09FD-4DF1-AC88-1E69BB790FF4}"/>
               </a:ext>
             </a:extLst>
           </p:cNvPr>
@@ -6513,7 +6513,7 @@
           <p:cNvPr id="16" name="">
             <a:extLst xmlns:a="http://schemas.openxmlformats.org/drawingml/2006/main">
               <a:ext uri="{FF2B5EF4-FFF2-40B4-BE49-F238E27FC236}">
-                <a16:creationId xmlns:a16="http://schemas.microsoft.com/office/drawing/2014/main" id="{366DC294-2AE8-427D-B40B-01A63C58B4C0}"/>
+                <a16:creationId xmlns:a16="http://schemas.microsoft.com/office/drawing/2014/main" id="{43FA480F-683E-4F90-BA0D-0EB0E07A4234}"/>
               </a:ext>
             </a:extLst>
           </p:cNvPr>
@@ -6633,7 +6633,7 @@
           <p:cNvPr id="17" name="">
             <a:extLst xmlns:a="http://schemas.openxmlformats.org/drawingml/2006/main">
               <a:ext uri="{FF2B5EF4-FFF2-40B4-BE49-F238E27FC236}">
-                <a16:creationId xmlns:a16="http://schemas.microsoft.com/office/drawing/2014/main" id="{58F1E4EC-C494-49C7-A001-BFA976C424DC}"/>
+                <a16:creationId xmlns:a16="http://schemas.microsoft.com/office/drawing/2014/main" id="{2ECB87EC-649E-4DD3-B944-A3B55D237489}"/>
               </a:ext>
             </a:extLst>
           </p:cNvPr>
@@ -6753,7 +6753,7 @@
           <p:cNvPr id="18" name="">
             <a:extLst xmlns:a="http://schemas.openxmlformats.org/drawingml/2006/main">
               <a:ext uri="{FF2B5EF4-FFF2-40B4-BE49-F238E27FC236}">
-                <a16:creationId xmlns:a16="http://schemas.microsoft.com/office/drawing/2014/main" id="{179F2C1F-D778-44D1-BEED-67D62A626E49}"/>
+                <a16:creationId xmlns:a16="http://schemas.microsoft.com/office/drawing/2014/main" id="{8AAEAB7F-91B5-4379-BFB2-3823392A652C}"/>
               </a:ext>
             </a:extLst>
           </p:cNvPr>
@@ -6873,7 +6873,7 @@
           <p:cNvPr id="19" name="">
             <a:extLst xmlns:a="http://schemas.openxmlformats.org/drawingml/2006/main">
               <a:ext uri="{FF2B5EF4-FFF2-40B4-BE49-F238E27FC236}">
-                <a16:creationId xmlns:a16="http://schemas.microsoft.com/office/drawing/2014/main" id="{07FB1422-06A2-4F79-8824-9C6C3F40A979}"/>
+                <a16:creationId xmlns:a16="http://schemas.microsoft.com/office/drawing/2014/main" id="{7CDDD0E0-1E8D-4A40-A97A-5A1ED293FAC3}"/>
               </a:ext>
             </a:extLst>
           </p:cNvPr>
@@ -6903,7 +6903,7 @@
           <p:cNvPr id="20" name="">
             <a:extLst xmlns:a="http://schemas.openxmlformats.org/drawingml/2006/main">
               <a:ext uri="{FF2B5EF4-FFF2-40B4-BE49-F238E27FC236}">
-                <a16:creationId xmlns:a16="http://schemas.microsoft.com/office/drawing/2014/main" id="{B43870A9-6F31-4080-8493-12D81F34CF95}"/>
+                <a16:creationId xmlns:a16="http://schemas.microsoft.com/office/drawing/2014/main" id="{00EEAC3D-875E-4A54-8A4A-24D5E797833E}"/>
               </a:ext>
             </a:extLst>
           </p:cNvPr>
@@ -7013,7 +7013,7 @@
                   <a:srgbClr val="17242E"/>
                 </a:solidFill>
               </a:rPr>
-              <a:t>Exact-main success closes the Windows observation goal. It does not close the other roadmap goals or milestone scope.</a:t>
+              <a:t>Exact-main success also closes the symposium documentation and release-deck goals. Fifteen roadmap goals remain open.</a:t>
             </a:r>
           </a:p>
         </p:txBody>
@@ -7023,7 +7023,7 @@
           <p:cNvPr id="21" name="">
             <a:extLst xmlns:a="http://schemas.openxmlformats.org/drawingml/2006/main">
               <a:ext uri="{FF2B5EF4-FFF2-40B4-BE49-F238E27FC236}">
-                <a16:creationId xmlns:a16="http://schemas.microsoft.com/office/drawing/2014/main" id="{C29BA261-C79D-4069-B7CE-A9538BA41F89}"/>
+                <a16:creationId xmlns:a16="http://schemas.microsoft.com/office/drawing/2014/main" id="{1DE08A7E-BEB4-4732-9C2F-A3A447E8DDCA}"/>
               </a:ext>
             </a:extLst>
           </p:cNvPr>
@@ -7143,7 +7143,7 @@
           <p:cNvPr id="22" name="">
             <a:extLst xmlns:a="http://schemas.openxmlformats.org/drawingml/2006/main">
               <a:ext uri="{FF2B5EF4-FFF2-40B4-BE49-F238E27FC236}">
-                <a16:creationId xmlns:a16="http://schemas.microsoft.com/office/drawing/2014/main" id="{411895CF-BB66-4AA8-BEBD-15860785A74A}"/>
+                <a16:creationId xmlns:a16="http://schemas.microsoft.com/office/drawing/2014/main" id="{D104DDAD-42F9-4300-BA09-7418C78116B3}"/>
               </a:ext>
             </a:extLst>
           </p:cNvPr>
@@ -7261,7 +7261,7 @@
     </p:spTree>
     <p:extLst>
       <p:ext uri="{BB962C8B-B14F-4D97-AF65-F5344CB8AC3E}">
-        <p14:creationId xmlns:p14="http://schemas.microsoft.com/office/powerpoint/2010/main" val="385425845"/>
+        <p14:creationId xmlns:p14="http://schemas.microsoft.com/office/powerpoint/2010/main" val="564951960"/>
       </p:ext>
     </p:extLst>
   </p:cSld>
@@ -7292,7 +7292,7 @@
           <p:cNvPr id="15" name="">
             <a:extLst xmlns:a="http://schemas.openxmlformats.org/drawingml/2006/main">
               <a:ext uri="{FF2B5EF4-FFF2-40B4-BE49-F238E27FC236}">
-                <a16:creationId xmlns:a16="http://schemas.microsoft.com/office/drawing/2014/main" id="{E04A730F-AB0E-4BC4-9B2A-8036A36712C1}"/>
+                <a16:creationId xmlns:a16="http://schemas.microsoft.com/office/drawing/2014/main" id="{2041015D-C55B-4F5E-A7E1-87208DBB6BEB}"/>
               </a:ext>
             </a:extLst>
           </p:cNvPr>
@@ -7412,7 +7412,7 @@
           <p:cNvPr id="2" name="">
             <a:extLst xmlns:a="http://schemas.openxmlformats.org/drawingml/2006/main">
               <a:ext uri="{FF2B5EF4-FFF2-40B4-BE49-F238E27FC236}">
-                <a16:creationId xmlns:a16="http://schemas.microsoft.com/office/drawing/2014/main" id="{133C9E2A-1438-4358-B4C8-3DDF4F8949F7}"/>
+                <a16:creationId xmlns:a16="http://schemas.microsoft.com/office/drawing/2014/main" id="{6DBF5295-3AAF-42AA-A7CA-20C15D622E95}"/>
               </a:ext>
             </a:extLst>
           </p:cNvPr>
@@ -7532,7 +7532,7 @@
           <p:cNvPr id="3" name="">
             <a:extLst xmlns:a="http://schemas.openxmlformats.org/drawingml/2006/main">
               <a:ext uri="{FF2B5EF4-FFF2-40B4-BE49-F238E27FC236}">
-                <a16:creationId xmlns:a16="http://schemas.microsoft.com/office/drawing/2014/main" id="{5877B4FA-EA25-4546-A415-41411D877DFC}"/>
+                <a16:creationId xmlns:a16="http://schemas.microsoft.com/office/drawing/2014/main" id="{6B9E34B7-EB66-4C31-BC31-8E7227598DC7}"/>
               </a:ext>
             </a:extLst>
           </p:cNvPr>
@@ -7652,7 +7652,7 @@
           <p:cNvPr id="4" name="">
             <a:extLst xmlns:a="http://schemas.openxmlformats.org/drawingml/2006/main">
               <a:ext uri="{FF2B5EF4-FFF2-40B4-BE49-F238E27FC236}">
-                <a16:creationId xmlns:a16="http://schemas.microsoft.com/office/drawing/2014/main" id="{E9B28453-F360-4592-80FF-72EBE3E7EB66}"/>
+                <a16:creationId xmlns:a16="http://schemas.microsoft.com/office/drawing/2014/main" id="{99488E44-5009-4056-891C-6F5F40661F3B}"/>
               </a:ext>
             </a:extLst>
           </p:cNvPr>
@@ -7772,7 +7772,7 @@
           <p:cNvPr id="5" name="">
             <a:extLst xmlns:a="http://schemas.openxmlformats.org/drawingml/2006/main">
               <a:ext uri="{FF2B5EF4-FFF2-40B4-BE49-F238E27FC236}">
-                <a16:creationId xmlns:a16="http://schemas.microsoft.com/office/drawing/2014/main" id="{76DB98D8-97DC-497B-A1D0-81B32F5BB2C7}"/>
+                <a16:creationId xmlns:a16="http://schemas.microsoft.com/office/drawing/2014/main" id="{EEA3A0AC-F6A7-453E-8CD0-6DC87C664ABD}"/>
               </a:ext>
             </a:extLst>
           </p:cNvPr>
@@ -7892,7 +7892,7 @@
           <p:cNvPr id="6" name="">
             <a:extLst xmlns:a="http://schemas.openxmlformats.org/drawingml/2006/main">
               <a:ext uri="{FF2B5EF4-FFF2-40B4-BE49-F238E27FC236}">
-                <a16:creationId xmlns:a16="http://schemas.microsoft.com/office/drawing/2014/main" id="{BDEC459C-666B-438B-9210-469FE5173113}"/>
+                <a16:creationId xmlns:a16="http://schemas.microsoft.com/office/drawing/2014/main" id="{EB4B02EC-3ADA-48A9-8D00-4C57076C1ED9}"/>
               </a:ext>
             </a:extLst>
           </p:cNvPr>
@@ -8012,7 +8012,7 @@
           <p:cNvPr id="7" name="">
             <a:extLst xmlns:a="http://schemas.openxmlformats.org/drawingml/2006/main">
               <a:ext uri="{FF2B5EF4-FFF2-40B4-BE49-F238E27FC236}">
-                <a16:creationId xmlns:a16="http://schemas.microsoft.com/office/drawing/2014/main" id="{65372AF2-E598-463B-84CF-B422CCE5D2E3}"/>
+                <a16:creationId xmlns:a16="http://schemas.microsoft.com/office/drawing/2014/main" id="{C9D379F8-DCB9-4708-8ABC-E67657439383}"/>
               </a:ext>
             </a:extLst>
           </p:cNvPr>
@@ -8132,7 +8132,7 @@
           <p:cNvPr id="8" name="">
             <a:extLst xmlns:a="http://schemas.openxmlformats.org/drawingml/2006/main">
               <a:ext uri="{FF2B5EF4-FFF2-40B4-BE49-F238E27FC236}">
-                <a16:creationId xmlns:a16="http://schemas.microsoft.com/office/drawing/2014/main" id="{42B9B2B6-4145-4082-86EB-C71CF3796ECD}"/>
+                <a16:creationId xmlns:a16="http://schemas.microsoft.com/office/drawing/2014/main" id="{65720CE5-B134-4EA3-BD0D-9C0761CE321F}"/>
               </a:ext>
             </a:extLst>
           </p:cNvPr>
@@ -8242,7 +8242,7 @@
                   <a:srgbClr val="D7E0E8"/>
                 </a:solidFill>
               </a:rPr>
-              <a:t>Possible only if the seventeen remaining goals close through existing evidence and require no additional implementation or CI restart.</a:t>
+              <a:t>Possible only if the fifteen remaining goals close through existing evidence and require no additional implementation or CI restart.</a:t>
             </a:r>
           </a:p>
         </p:txBody>
@@ -8252,7 +8252,7 @@
           <p:cNvPr id="9" name="">
             <a:extLst xmlns:a="http://schemas.openxmlformats.org/drawingml/2006/main">
               <a:ext uri="{FF2B5EF4-FFF2-40B4-BE49-F238E27FC236}">
-                <a16:creationId xmlns:a16="http://schemas.microsoft.com/office/drawing/2014/main" id="{DE37FF43-213B-49ED-9024-8C72F59BB989}"/>
+                <a16:creationId xmlns:a16="http://schemas.microsoft.com/office/drawing/2014/main" id="{B2985E43-E45C-439C-8F77-DF7E10B92D79}"/>
               </a:ext>
             </a:extLst>
           </p:cNvPr>
@@ -8372,7 +8372,7 @@
           <p:cNvPr id="10" name="">
             <a:extLst xmlns:a="http://schemas.openxmlformats.org/drawingml/2006/main">
               <a:ext uri="{FF2B5EF4-FFF2-40B4-BE49-F238E27FC236}">
-                <a16:creationId xmlns:a16="http://schemas.microsoft.com/office/drawing/2014/main" id="{3D8E0C39-9F9D-426A-844F-2366DFC80025}"/>
+                <a16:creationId xmlns:a16="http://schemas.microsoft.com/office/drawing/2014/main" id="{9DEB7DED-89E1-424B-B4EA-678AAC7DA8FE}"/>
               </a:ext>
             </a:extLst>
           </p:cNvPr>
@@ -8492,7 +8492,7 @@
           <p:cNvPr id="11" name="">
             <a:extLst xmlns:a="http://schemas.openxmlformats.org/drawingml/2006/main">
               <a:ext uri="{FF2B5EF4-FFF2-40B4-BE49-F238E27FC236}">
-                <a16:creationId xmlns:a16="http://schemas.microsoft.com/office/drawing/2014/main" id="{A2733DCA-CD90-460E-9956-C69C5227F48E}"/>
+                <a16:creationId xmlns:a16="http://schemas.microsoft.com/office/drawing/2014/main" id="{79A425C9-2892-480D-A770-FBC59B06C366}"/>
               </a:ext>
             </a:extLst>
           </p:cNvPr>
@@ -8612,7 +8612,7 @@
           <p:cNvPr id="12" name="">
             <a:extLst xmlns:a="http://schemas.openxmlformats.org/drawingml/2006/main">
               <a:ext uri="{FF2B5EF4-FFF2-40B4-BE49-F238E27FC236}">
-                <a16:creationId xmlns:a16="http://schemas.microsoft.com/office/drawing/2014/main" id="{17B7CEE0-71AC-4118-9207-272760DE68D4}"/>
+                <a16:creationId xmlns:a16="http://schemas.microsoft.com/office/drawing/2014/main" id="{6A04774A-5269-489D-9E22-21FAE0EFDFA1}"/>
               </a:ext>
             </a:extLst>
           </p:cNvPr>
@@ -8642,7 +8642,7 @@
           <p:cNvPr id="13" name="">
             <a:extLst xmlns:a="http://schemas.openxmlformats.org/drawingml/2006/main">
               <a:ext uri="{FF2B5EF4-FFF2-40B4-BE49-F238E27FC236}">
-                <a16:creationId xmlns:a16="http://schemas.microsoft.com/office/drawing/2014/main" id="{9D9593C4-1B4E-46C6-A77E-946E0E72F4F2}"/>
+                <a16:creationId xmlns:a16="http://schemas.microsoft.com/office/drawing/2014/main" id="{7A22C93C-70A6-4242-A7B5-FC7FF420340E}"/>
               </a:ext>
             </a:extLst>
           </p:cNvPr>
@@ -8762,7 +8762,7 @@
           <p:cNvPr id="14" name="">
             <a:extLst xmlns:a="http://schemas.openxmlformats.org/drawingml/2006/main">
               <a:ext uri="{FF2B5EF4-FFF2-40B4-BE49-F238E27FC236}">
-                <a16:creationId xmlns:a16="http://schemas.microsoft.com/office/drawing/2014/main" id="{EDDE34F8-7C6E-41A8-8030-2ECD14AA5E47}"/>
+                <a16:creationId xmlns:a16="http://schemas.microsoft.com/office/drawing/2014/main" id="{72347DC3-5641-4B4F-A5B0-BD1655E87694}"/>
               </a:ext>
             </a:extLst>
           </p:cNvPr>
@@ -8880,7 +8880,7 @@
     </p:spTree>
     <p:extLst>
       <p:ext uri="{BB962C8B-B14F-4D97-AF65-F5344CB8AC3E}">
-        <p14:creationId xmlns:p14="http://schemas.microsoft.com/office/powerpoint/2010/main" val="1222192040"/>
+        <p14:creationId xmlns:p14="http://schemas.microsoft.com/office/powerpoint/2010/main" val="878797063"/>
       </p:ext>
     </p:extLst>
   </p:cSld>
@@ -8911,7 +8911,7 @@
           <p:cNvPr id="22" name="">
             <a:extLst xmlns:a="http://schemas.openxmlformats.org/drawingml/2006/main">
               <a:ext uri="{FF2B5EF4-FFF2-40B4-BE49-F238E27FC236}">
-                <a16:creationId xmlns:a16="http://schemas.microsoft.com/office/drawing/2014/main" id="{C6A923DE-A89C-4050-BD64-27BB9502FEC4}"/>
+                <a16:creationId xmlns:a16="http://schemas.microsoft.com/office/drawing/2014/main" id="{ED3177B9-ED92-439A-B6B8-6F173204DCA8}"/>
               </a:ext>
             </a:extLst>
           </p:cNvPr>
@@ -9031,7 +9031,7 @@
           <p:cNvPr id="2" name="">
             <a:extLst xmlns:a="http://schemas.openxmlformats.org/drawingml/2006/main">
               <a:ext uri="{FF2B5EF4-FFF2-40B4-BE49-F238E27FC236}">
-                <a16:creationId xmlns:a16="http://schemas.microsoft.com/office/drawing/2014/main" id="{0C520EF1-5EB7-4408-91A0-919E366B1566}"/>
+                <a16:creationId xmlns:a16="http://schemas.microsoft.com/office/drawing/2014/main" id="{BD089E4B-9E25-44DB-8AE2-37F794CF7A07}"/>
               </a:ext>
             </a:extLst>
           </p:cNvPr>
@@ -9151,7 +9151,7 @@
           <p:cNvPr id="3" name="">
             <a:extLst xmlns:a="http://schemas.openxmlformats.org/drawingml/2006/main">
               <a:ext uri="{FF2B5EF4-FFF2-40B4-BE49-F238E27FC236}">
-                <a16:creationId xmlns:a16="http://schemas.microsoft.com/office/drawing/2014/main" id="{D553D1BE-B82A-4E42-BACB-586A44E7BA4D}"/>
+                <a16:creationId xmlns:a16="http://schemas.microsoft.com/office/drawing/2014/main" id="{7784D3B1-CB6A-4808-BE21-965E344BC1D6}"/>
               </a:ext>
             </a:extLst>
           </p:cNvPr>
@@ -9181,7 +9181,7 @@
           <p:cNvPr id="4" name="">
             <a:extLst xmlns:a="http://schemas.openxmlformats.org/drawingml/2006/main">
               <a:ext uri="{FF2B5EF4-FFF2-40B4-BE49-F238E27FC236}">
-                <a16:creationId xmlns:a16="http://schemas.microsoft.com/office/drawing/2014/main" id="{FF1CD919-028D-442C-A89E-A27191A1732D}"/>
+                <a16:creationId xmlns:a16="http://schemas.microsoft.com/office/drawing/2014/main" id="{D9CF8F34-248A-4212-A4C3-3689E073BED4}"/>
               </a:ext>
             </a:extLst>
           </p:cNvPr>
@@ -9301,7 +9301,7 @@
           <p:cNvPr id="5" name="">
             <a:extLst xmlns:a="http://schemas.openxmlformats.org/drawingml/2006/main">
               <a:ext uri="{FF2B5EF4-FFF2-40B4-BE49-F238E27FC236}">
-                <a16:creationId xmlns:a16="http://schemas.microsoft.com/office/drawing/2014/main" id="{5A1DDECA-BEBC-4F6C-81B4-58532CB10CFB}"/>
+                <a16:creationId xmlns:a16="http://schemas.microsoft.com/office/drawing/2014/main" id="{C8CBB65F-4DA7-41EF-88B1-7B0FAAF0EA57}"/>
               </a:ext>
             </a:extLst>
           </p:cNvPr>
@@ -9421,7 +9421,7 @@
           <p:cNvPr id="6" name="">
             <a:extLst xmlns:a="http://schemas.openxmlformats.org/drawingml/2006/main">
               <a:ext uri="{FF2B5EF4-FFF2-40B4-BE49-F238E27FC236}">
-                <a16:creationId xmlns:a16="http://schemas.microsoft.com/office/drawing/2014/main" id="{8E331CF8-8AC9-4B86-8C5E-4AF133876EA8}"/>
+                <a16:creationId xmlns:a16="http://schemas.microsoft.com/office/drawing/2014/main" id="{53EDC72B-6A10-4A6B-AF46-EF936CA16DB9}"/>
               </a:ext>
             </a:extLst>
           </p:cNvPr>
@@ -9531,7 +9531,7 @@
                   <a:srgbClr val="536675"/>
                 </a:solidFill>
               </a:rPr>
-              <a:t>All 26 exact-main jobs pass on 3b606d42c, including isolated Windows receiver proof</a:t>
+              <a:t>All 26 exact-main jobs pass on 8f93802a in run 40494175198, including isolated Windows receiver proof</a:t>
             </a:r>
           </a:p>
         </p:txBody>
@@ -9541,7 +9541,7 @@
           <p:cNvPr id="7" name="">
             <a:extLst xmlns:a="http://schemas.openxmlformats.org/drawingml/2006/main">
               <a:ext uri="{FF2B5EF4-FFF2-40B4-BE49-F238E27FC236}">
-                <a16:creationId xmlns:a16="http://schemas.microsoft.com/office/drawing/2014/main" id="{7A4F4639-BF34-41ED-9098-AA0CBE768FDB}"/>
+                <a16:creationId xmlns:a16="http://schemas.microsoft.com/office/drawing/2014/main" id="{C76663E9-9AF6-40CF-9800-F92052B0FE47}"/>
               </a:ext>
             </a:extLst>
           </p:cNvPr>
@@ -9571,7 +9571,7 @@
           <p:cNvPr id="8" name="">
             <a:extLst xmlns:a="http://schemas.openxmlformats.org/drawingml/2006/main">
               <a:ext uri="{FF2B5EF4-FFF2-40B4-BE49-F238E27FC236}">
-                <a16:creationId xmlns:a16="http://schemas.microsoft.com/office/drawing/2014/main" id="{291EB772-8EEF-495E-BC31-C1C0AF41A25D}"/>
+                <a16:creationId xmlns:a16="http://schemas.microsoft.com/office/drawing/2014/main" id="{856E554C-131F-4630-8E7A-3A3CA8BA0478}"/>
               </a:ext>
             </a:extLst>
           </p:cNvPr>
@@ -9681,7 +9681,7 @@
                   <a:srgbClr val="2A9D8F"/>
                 </a:solidFill>
               </a:rPr>
-              <a:t>NOW</a:t>
+              <a:t>COMPLETE</a:t>
             </a:r>
           </a:p>
         </p:txBody>
@@ -9691,7 +9691,7 @@
           <p:cNvPr id="9" name="">
             <a:extLst xmlns:a="http://schemas.openxmlformats.org/drawingml/2006/main">
               <a:ext uri="{FF2B5EF4-FFF2-40B4-BE49-F238E27FC236}">
-                <a16:creationId xmlns:a16="http://schemas.microsoft.com/office/drawing/2014/main" id="{4683FDC7-8C5D-4A55-A24F-F99C032EDCBF}"/>
+                <a16:creationId xmlns:a16="http://schemas.microsoft.com/office/drawing/2014/main" id="{BFD64F1D-EBF7-41AB-9CE3-F7725C40D691}"/>
               </a:ext>
             </a:extLst>
           </p:cNvPr>
@@ -9811,7 +9811,7 @@
           <p:cNvPr id="10" name="">
             <a:extLst xmlns:a="http://schemas.openxmlformats.org/drawingml/2006/main">
               <a:ext uri="{FF2B5EF4-FFF2-40B4-BE49-F238E27FC236}">
-                <a16:creationId xmlns:a16="http://schemas.microsoft.com/office/drawing/2014/main" id="{2074A90B-714F-4145-9A1E-CEDADF4B828F}"/>
+                <a16:creationId xmlns:a16="http://schemas.microsoft.com/office/drawing/2014/main" id="{2DF66F8C-3C4E-4D42-A6D4-E9CF59DDCC3E}"/>
               </a:ext>
             </a:extLst>
           </p:cNvPr>
@@ -9921,7 +9921,7 @@
                   <a:srgbClr val="536675"/>
                 </a:solidFill>
               </a:rPr>
-              <a:t>Merge the 18-goal milestone reconciliation, scoped documentation CI and this exact release briefing on green CI</a:t>
+              <a:t>PR #154 and the latest exact-main run publish the 18-goal scope, scoped documentation CI and release briefing</a:t>
             </a:r>
           </a:p>
         </p:txBody>
@@ -9931,7 +9931,7 @@
           <p:cNvPr id="11" name="">
             <a:extLst xmlns:a="http://schemas.openxmlformats.org/drawingml/2006/main">
               <a:ext uri="{FF2B5EF4-FFF2-40B4-BE49-F238E27FC236}">
-                <a16:creationId xmlns:a16="http://schemas.microsoft.com/office/drawing/2014/main" id="{54CE9821-F023-4707-8B4D-6A75D747BD94}"/>
+                <a16:creationId xmlns:a16="http://schemas.microsoft.com/office/drawing/2014/main" id="{719A00BB-5709-4C9C-859A-351E1E36A587}"/>
               </a:ext>
             </a:extLst>
           </p:cNvPr>
@@ -9961,7 +9961,7 @@
           <p:cNvPr id="12" name="">
             <a:extLst xmlns:a="http://schemas.openxmlformats.org/drawingml/2006/main">
               <a:ext uri="{FF2B5EF4-FFF2-40B4-BE49-F238E27FC236}">
-                <a16:creationId xmlns:a16="http://schemas.microsoft.com/office/drawing/2014/main" id="{249998D9-0537-4109-ADF9-1F90F76A2FCC}"/>
+                <a16:creationId xmlns:a16="http://schemas.microsoft.com/office/drawing/2014/main" id="{BCA6FB2B-005C-4E0A-9B82-773C0BA47454}"/>
               </a:ext>
             </a:extLst>
           </p:cNvPr>
@@ -10081,7 +10081,7 @@
           <p:cNvPr id="13" name="">
             <a:extLst xmlns:a="http://schemas.openxmlformats.org/drawingml/2006/main">
               <a:ext uri="{FF2B5EF4-FFF2-40B4-BE49-F238E27FC236}">
-                <a16:creationId xmlns:a16="http://schemas.microsoft.com/office/drawing/2014/main" id="{B1371F25-E24E-4C37-8179-D28EFED4FEB0}"/>
+                <a16:creationId xmlns:a16="http://schemas.microsoft.com/office/drawing/2014/main" id="{C16E17F0-B0C6-470F-A8F5-0B038677329A}"/>
               </a:ext>
             </a:extLst>
           </p:cNvPr>
@@ -10191,7 +10191,7 @@
                   <a:srgbClr val="17242E"/>
                 </a:solidFill>
               </a:rPr>
-              <a:t>Close seventeen goals</a:t>
+              <a:t>Close fifteen goals</a:t>
             </a:r>
           </a:p>
         </p:txBody>
@@ -10201,7 +10201,7 @@
           <p:cNvPr id="14" name="">
             <a:extLst xmlns:a="http://schemas.openxmlformats.org/drawingml/2006/main">
               <a:ext uri="{FF2B5EF4-FFF2-40B4-BE49-F238E27FC236}">
-                <a16:creationId xmlns:a16="http://schemas.microsoft.com/office/drawing/2014/main" id="{B7B1F679-5699-441C-8B88-F6362DDFD7C7}"/>
+                <a16:creationId xmlns:a16="http://schemas.microsoft.com/office/drawing/2014/main" id="{159CD4A1-969F-46F7-A406-A8C1F123B495}"/>
               </a:ext>
             </a:extLst>
           </p:cNvPr>
@@ -10321,7 +10321,7 @@
           <p:cNvPr id="15" name="">
             <a:extLst xmlns:a="http://schemas.openxmlformats.org/drawingml/2006/main">
               <a:ext uri="{FF2B5EF4-FFF2-40B4-BE49-F238E27FC236}">
-                <a16:creationId xmlns:a16="http://schemas.microsoft.com/office/drawing/2014/main" id="{98B019BC-0D2D-4955-8307-C0FF248636D6}"/>
+                <a16:creationId xmlns:a16="http://schemas.microsoft.com/office/drawing/2014/main" id="{98C523F3-551C-488F-86FD-33298A50FED5}"/>
               </a:ext>
             </a:extLst>
           </p:cNvPr>
@@ -10351,7 +10351,7 @@
           <p:cNvPr id="16" name="">
             <a:extLst xmlns:a="http://schemas.openxmlformats.org/drawingml/2006/main">
               <a:ext uri="{FF2B5EF4-FFF2-40B4-BE49-F238E27FC236}">
-                <a16:creationId xmlns:a16="http://schemas.microsoft.com/office/drawing/2014/main" id="{2437831A-53F9-4ED4-ACEC-154A4D3A0CC4}"/>
+                <a16:creationId xmlns:a16="http://schemas.microsoft.com/office/drawing/2014/main" id="{A1E0069A-D989-48BD-95CD-C28FC88434EE}"/>
               </a:ext>
             </a:extLst>
           </p:cNvPr>
@@ -10471,7 +10471,7 @@
           <p:cNvPr id="17" name="">
             <a:extLst xmlns:a="http://schemas.openxmlformats.org/drawingml/2006/main">
               <a:ext uri="{FF2B5EF4-FFF2-40B4-BE49-F238E27FC236}">
-                <a16:creationId xmlns:a16="http://schemas.microsoft.com/office/drawing/2014/main" id="{C60AD887-28F1-48E8-84BF-EACA098BB9A4}"/>
+                <a16:creationId xmlns:a16="http://schemas.microsoft.com/office/drawing/2014/main" id="{C531106C-34E7-4AD6-AC06-E031D88FCED7}"/>
               </a:ext>
             </a:extLst>
           </p:cNvPr>
@@ -10591,7 +10591,7 @@
           <p:cNvPr id="18" name="">
             <a:extLst xmlns:a="http://schemas.openxmlformats.org/drawingml/2006/main">
               <a:ext uri="{FF2B5EF4-FFF2-40B4-BE49-F238E27FC236}">
-                <a16:creationId xmlns:a16="http://schemas.microsoft.com/office/drawing/2014/main" id="{CD62D6E2-6370-4968-81EB-9C830AD19F94}"/>
+                <a16:creationId xmlns:a16="http://schemas.microsoft.com/office/drawing/2014/main" id="{72741B9B-76EC-4DDA-A1EC-3A596E6CB2AF}"/>
               </a:ext>
             </a:extLst>
           </p:cNvPr>
@@ -10711,7 +10711,7 @@
           <p:cNvPr id="19" name="">
             <a:extLst xmlns:a="http://schemas.openxmlformats.org/drawingml/2006/main">
               <a:ext uri="{FF2B5EF4-FFF2-40B4-BE49-F238E27FC236}">
-                <a16:creationId xmlns:a16="http://schemas.microsoft.com/office/drawing/2014/main" id="{64EF3B37-CD53-4FDD-9221-205DA202F9D5}"/>
+                <a16:creationId xmlns:a16="http://schemas.microsoft.com/office/drawing/2014/main" id="{E4948447-26BA-4FCD-8087-48795A5F71E1}"/>
               </a:ext>
             </a:extLst>
           </p:cNvPr>
@@ -10831,7 +10831,7 @@
           <p:cNvPr id="20" name="">
             <a:extLst xmlns:a="http://schemas.openxmlformats.org/drawingml/2006/main">
               <a:ext uri="{FF2B5EF4-FFF2-40B4-BE49-F238E27FC236}">
-                <a16:creationId xmlns:a16="http://schemas.microsoft.com/office/drawing/2014/main" id="{EDFF9ACA-8EC1-4F43-B6C7-2E8FCDDBFD67}"/>
+                <a16:creationId xmlns:a16="http://schemas.microsoft.com/office/drawing/2014/main" id="{1021FD22-E05C-42F1-B76A-B40035C4285F}"/>
               </a:ext>
             </a:extLst>
           </p:cNvPr>
@@ -10951,7 +10951,7 @@
           <p:cNvPr id="21" name="">
             <a:extLst xmlns:a="http://schemas.openxmlformats.org/drawingml/2006/main">
               <a:ext uri="{FF2B5EF4-FFF2-40B4-BE49-F238E27FC236}">
-                <a16:creationId xmlns:a16="http://schemas.microsoft.com/office/drawing/2014/main" id="{BA1DED0F-5C01-41EF-8BDF-D1A5AEDE6850}"/>
+                <a16:creationId xmlns:a16="http://schemas.microsoft.com/office/drawing/2014/main" id="{65925FA7-2D65-47F8-9AA0-357E2F309720}"/>
               </a:ext>
             </a:extLst>
           </p:cNvPr>
@@ -11069,7 +11069,7 @@
     </p:spTree>
     <p:extLst>
       <p:ext uri="{BB962C8B-B14F-4D97-AF65-F5344CB8AC3E}">
-        <p14:creationId xmlns:p14="http://schemas.microsoft.com/office/powerpoint/2010/main" val="1526547665"/>
+        <p14:creationId xmlns:p14="http://schemas.microsoft.com/office/powerpoint/2010/main" val="361995797"/>
       </p:ext>
     </p:extLst>
   </p:cSld>
@@ -11100,7 +11100,7 @@
           <p:cNvPr id="14" name="">
             <a:extLst xmlns:a="http://schemas.openxmlformats.org/drawingml/2006/main">
               <a:ext uri="{FF2B5EF4-FFF2-40B4-BE49-F238E27FC236}">
-                <a16:creationId xmlns:a16="http://schemas.microsoft.com/office/drawing/2014/main" id="{87E98E23-E7EA-4E16-9CDA-BB2501F7F525}"/>
+                <a16:creationId xmlns:a16="http://schemas.microsoft.com/office/drawing/2014/main" id="{684EF837-9C70-4366-A2E0-F6FC9EE2D4D3}"/>
               </a:ext>
             </a:extLst>
           </p:cNvPr>
@@ -11220,7 +11220,7 @@
           <p:cNvPr id="2" name="">
             <a:extLst xmlns:a="http://schemas.openxmlformats.org/drawingml/2006/main">
               <a:ext uri="{FF2B5EF4-FFF2-40B4-BE49-F238E27FC236}">
-                <a16:creationId xmlns:a16="http://schemas.microsoft.com/office/drawing/2014/main" id="{ABE7EA21-B397-4F08-BF90-41BFECB3C293}"/>
+                <a16:creationId xmlns:a16="http://schemas.microsoft.com/office/drawing/2014/main" id="{F1D758A2-F6DF-47D3-AF7B-9790D2DB54C4}"/>
               </a:ext>
             </a:extLst>
           </p:cNvPr>
@@ -11340,7 +11340,7 @@
           <p:cNvPr id="3" name="">
             <a:extLst xmlns:a="http://schemas.openxmlformats.org/drawingml/2006/main">
               <a:ext uri="{FF2B5EF4-FFF2-40B4-BE49-F238E27FC236}">
-                <a16:creationId xmlns:a16="http://schemas.microsoft.com/office/drawing/2014/main" id="{7EE7B8C8-5590-4429-AFDF-C6C9A502D27E}"/>
+                <a16:creationId xmlns:a16="http://schemas.microsoft.com/office/drawing/2014/main" id="{50D5C2B5-B369-4EAE-B4E7-EDD65757721E}"/>
               </a:ext>
             </a:extLst>
           </p:cNvPr>
@@ -11370,7 +11370,7 @@
           <p:cNvPr id="4" name="">
             <a:extLst xmlns:a="http://schemas.openxmlformats.org/drawingml/2006/main">
               <a:ext uri="{FF2B5EF4-FFF2-40B4-BE49-F238E27FC236}">
-                <a16:creationId xmlns:a16="http://schemas.microsoft.com/office/drawing/2014/main" id="{9625DDCC-44ED-47DF-AA8E-5BEB10D8AC7D}"/>
+                <a16:creationId xmlns:a16="http://schemas.microsoft.com/office/drawing/2014/main" id="{99F637DF-2D0B-419F-870E-018C4A2C9EC6}"/>
               </a:ext>
             </a:extLst>
           </p:cNvPr>
@@ -11490,7 +11490,7 @@
           <p:cNvPr id="5" name="">
             <a:extLst xmlns:a="http://schemas.openxmlformats.org/drawingml/2006/main">
               <a:ext uri="{FF2B5EF4-FFF2-40B4-BE49-F238E27FC236}">
-                <a16:creationId xmlns:a16="http://schemas.microsoft.com/office/drawing/2014/main" id="{43E17E35-EB36-46D3-8C90-7F93E90B2AFD}"/>
+                <a16:creationId xmlns:a16="http://schemas.microsoft.com/office/drawing/2014/main" id="{488E61F1-74DD-4BEF-BFE0-5955BB57E481}"/>
               </a:ext>
             </a:extLst>
           </p:cNvPr>
@@ -11610,7 +11610,7 @@
           <p:cNvPr id="6" name="">
             <a:extLst xmlns:a="http://schemas.openxmlformats.org/drawingml/2006/main">
               <a:ext uri="{FF2B5EF4-FFF2-40B4-BE49-F238E27FC236}">
-                <a16:creationId xmlns:a16="http://schemas.microsoft.com/office/drawing/2014/main" id="{63C54677-1022-4A05-AEB3-D7AA05C93480}"/>
+                <a16:creationId xmlns:a16="http://schemas.microsoft.com/office/drawing/2014/main" id="{7A3D2B6C-D9E9-4726-B9D2-238D3E820027}"/>
               </a:ext>
             </a:extLst>
           </p:cNvPr>
@@ -11730,7 +11730,7 @@
           <p:cNvPr id="7" name="">
             <a:extLst xmlns:a="http://schemas.openxmlformats.org/drawingml/2006/main">
               <a:ext uri="{FF2B5EF4-FFF2-40B4-BE49-F238E27FC236}">
-                <a16:creationId xmlns:a16="http://schemas.microsoft.com/office/drawing/2014/main" id="{ECD69795-74CD-494A-BFB6-570C755C7922}"/>
+                <a16:creationId xmlns:a16="http://schemas.microsoft.com/office/drawing/2014/main" id="{E03BCA90-D87F-42C3-B503-C5B941C05903}"/>
               </a:ext>
             </a:extLst>
           </p:cNvPr>
@@ -11850,7 +11850,7 @@
           <p:cNvPr id="8" name="">
             <a:extLst xmlns:a="http://schemas.openxmlformats.org/drawingml/2006/main">
               <a:ext uri="{FF2B5EF4-FFF2-40B4-BE49-F238E27FC236}">
-                <a16:creationId xmlns:a16="http://schemas.microsoft.com/office/drawing/2014/main" id="{87DA66AC-4F67-4EC6-B590-CEAF4693B546}"/>
+                <a16:creationId xmlns:a16="http://schemas.microsoft.com/office/drawing/2014/main" id="{AE9B0658-8A77-4554-BA26-35CF3F9036CB}"/>
               </a:ext>
             </a:extLst>
           </p:cNvPr>
@@ -11970,7 +11970,7 @@
           <p:cNvPr id="9" name="">
             <a:extLst xmlns:a="http://schemas.openxmlformats.org/drawingml/2006/main">
               <a:ext uri="{FF2B5EF4-FFF2-40B4-BE49-F238E27FC236}">
-                <a16:creationId xmlns:a16="http://schemas.microsoft.com/office/drawing/2014/main" id="{6B018244-7CB7-46CD-9D9D-071EB7714B9B}"/>
+                <a16:creationId xmlns:a16="http://schemas.microsoft.com/office/drawing/2014/main" id="{0C4E40E6-9116-4C1D-A1BD-77301300A5C5}"/>
               </a:ext>
             </a:extLst>
           </p:cNvPr>
@@ -12080,7 +12080,7 @@
                   <a:srgbClr val="17242E"/>
                 </a:solidFill>
               </a:rPr>
-              <a:t>Exact-main CI is green. Publication waits on the seventeen remaining goals covering all thirteen open milestone issues, discoverable symposium documentation and this deck.</a:t>
+              <a:t>Exact-main CI is green. Fifteen goals and all thirteen milestone issues remain open; symposium documentation and the release deck are published.</a:t>
             </a:r>
           </a:p>
         </p:txBody>
@@ -12090,7 +12090,7 @@
           <p:cNvPr id="10" name="">
             <a:extLst xmlns:a="http://schemas.openxmlformats.org/drawingml/2006/main">
               <a:ext uri="{FF2B5EF4-FFF2-40B4-BE49-F238E27FC236}">
-                <a16:creationId xmlns:a16="http://schemas.microsoft.com/office/drawing/2014/main" id="{C1DE16CE-5987-4EE4-B634-332636EE428A}"/>
+                <a16:creationId xmlns:a16="http://schemas.microsoft.com/office/drawing/2014/main" id="{D94D5EB5-0C33-41C7-83FB-A9E10B1658A4}"/>
               </a:ext>
             </a:extLst>
           </p:cNvPr>
@@ -12120,7 +12120,7 @@
           <p:cNvPr id="11" name="">
             <a:extLst xmlns:a="http://schemas.openxmlformats.org/drawingml/2006/main">
               <a:ext uri="{FF2B5EF4-FFF2-40B4-BE49-F238E27FC236}">
-                <a16:creationId xmlns:a16="http://schemas.microsoft.com/office/drawing/2014/main" id="{F878EA84-80AF-4C99-9D1C-51A4EBD43567}"/>
+                <a16:creationId xmlns:a16="http://schemas.microsoft.com/office/drawing/2014/main" id="{67F57911-C904-4538-AB95-82026F10218F}"/>
               </a:ext>
             </a:extLst>
           </p:cNvPr>
@@ -12240,7 +12240,7 @@
           <p:cNvPr id="12" name="">
             <a:extLst xmlns:a="http://schemas.openxmlformats.org/drawingml/2006/main">
               <a:ext uri="{FF2B5EF4-FFF2-40B4-BE49-F238E27FC236}">
-                <a16:creationId xmlns:a16="http://schemas.microsoft.com/office/drawing/2014/main" id="{50200DF6-DDCD-4BE6-8637-C6B2C01EF000}"/>
+                <a16:creationId xmlns:a16="http://schemas.microsoft.com/office/drawing/2014/main" id="{9D74B755-310F-4481-A12A-31C09591825A}"/>
               </a:ext>
             </a:extLst>
           </p:cNvPr>
@@ -12360,7 +12360,7 @@
           <p:cNvPr id="13" name="">
             <a:extLst xmlns:a="http://schemas.openxmlformats.org/drawingml/2006/main">
               <a:ext uri="{FF2B5EF4-FFF2-40B4-BE49-F238E27FC236}">
-                <a16:creationId xmlns:a16="http://schemas.microsoft.com/office/drawing/2014/main" id="{BF13DC8E-D5D8-4353-BE27-9FDDAE2A7733}"/>
+                <a16:creationId xmlns:a16="http://schemas.microsoft.com/office/drawing/2014/main" id="{E5F86491-C9B4-4603-87C3-C80051F739FA}"/>
               </a:ext>
             </a:extLst>
           </p:cNvPr>
@@ -12478,7 +12478,7 @@
     </p:spTree>
     <p:extLst>
       <p:ext uri="{BB962C8B-B14F-4D97-AF65-F5344CB8AC3E}">
-        <p14:creationId xmlns:p14="http://schemas.microsoft.com/office/powerpoint/2010/main" val="306241195"/>
+        <p14:creationId xmlns:p14="http://schemas.microsoft.com/office/powerpoint/2010/main" val="2135359248"/>
       </p:ext>
     </p:extLst>
   </p:cSld>
@@ -12509,7 +12509,7 @@
           <p:cNvPr id="26" name="">
             <a:extLst xmlns:a="http://schemas.openxmlformats.org/drawingml/2006/main">
               <a:ext uri="{FF2B5EF4-FFF2-40B4-BE49-F238E27FC236}">
-                <a16:creationId xmlns:a16="http://schemas.microsoft.com/office/drawing/2014/main" id="{788A4FEB-4BB5-4BF0-99F4-0BCDFCFA5E80}"/>
+                <a16:creationId xmlns:a16="http://schemas.microsoft.com/office/drawing/2014/main" id="{799AA9FD-4F34-417B-AB8A-1767805D2A19}"/>
               </a:ext>
             </a:extLst>
           </p:cNvPr>
@@ -12629,7 +12629,7 @@
           <p:cNvPr id="2" name="">
             <a:extLst xmlns:a="http://schemas.openxmlformats.org/drawingml/2006/main">
               <a:ext uri="{FF2B5EF4-FFF2-40B4-BE49-F238E27FC236}">
-                <a16:creationId xmlns:a16="http://schemas.microsoft.com/office/drawing/2014/main" id="{7C1E3D59-F292-4D9D-B71E-8198916E0F8C}"/>
+                <a16:creationId xmlns:a16="http://schemas.microsoft.com/office/drawing/2014/main" id="{3137EB71-549D-4CE5-9667-9B5172BFD101}"/>
               </a:ext>
             </a:extLst>
           </p:cNvPr>
@@ -12749,7 +12749,7 @@
           <p:cNvPr id="3" name="">
             <a:extLst xmlns:a="http://schemas.openxmlformats.org/drawingml/2006/main">
               <a:ext uri="{FF2B5EF4-FFF2-40B4-BE49-F238E27FC236}">
-                <a16:creationId xmlns:a16="http://schemas.microsoft.com/office/drawing/2014/main" id="{079057D4-E869-4C71-A17B-45E0BDEBAE34}"/>
+                <a16:creationId xmlns:a16="http://schemas.microsoft.com/office/drawing/2014/main" id="{7AAC0E5F-DB5C-403D-9024-C24989C0E87E}"/>
               </a:ext>
             </a:extLst>
           </p:cNvPr>
@@ -12779,7 +12779,7 @@
           <p:cNvPr id="4" name="">
             <a:extLst xmlns:a="http://schemas.openxmlformats.org/drawingml/2006/main">
               <a:ext uri="{FF2B5EF4-FFF2-40B4-BE49-F238E27FC236}">
-                <a16:creationId xmlns:a16="http://schemas.microsoft.com/office/drawing/2014/main" id="{73D3D502-9DD3-44E9-BB43-1E413348B8D4}"/>
+                <a16:creationId xmlns:a16="http://schemas.microsoft.com/office/drawing/2014/main" id="{BA38EB92-CC16-4C12-8D28-3429077F8C3B}"/>
               </a:ext>
             </a:extLst>
           </p:cNvPr>
@@ -12809,7 +12809,7 @@
           <p:cNvPr id="5" name="">
             <a:extLst xmlns:a="http://schemas.openxmlformats.org/drawingml/2006/main">
               <a:ext uri="{FF2B5EF4-FFF2-40B4-BE49-F238E27FC236}">
-                <a16:creationId xmlns:a16="http://schemas.microsoft.com/office/drawing/2014/main" id="{5C01B246-23F1-45E0-82D0-D7DAE4D4F39A}"/>
+                <a16:creationId xmlns:a16="http://schemas.microsoft.com/office/drawing/2014/main" id="{8F01043E-5B1B-4193-8D7F-1DB02EB25C52}"/>
               </a:ext>
             </a:extLst>
           </p:cNvPr>
@@ -12929,7 +12929,7 @@
           <p:cNvPr id="6" name="">
             <a:extLst xmlns:a="http://schemas.openxmlformats.org/drawingml/2006/main">
               <a:ext uri="{FF2B5EF4-FFF2-40B4-BE49-F238E27FC236}">
-                <a16:creationId xmlns:a16="http://schemas.microsoft.com/office/drawing/2014/main" id="{16AD022A-265A-4C5B-AFAE-FA9889E0FB9E}"/>
+                <a16:creationId xmlns:a16="http://schemas.microsoft.com/office/drawing/2014/main" id="{9556F1B4-B4F4-4FB6-B96A-719577369956}"/>
               </a:ext>
             </a:extLst>
           </p:cNvPr>
@@ -13100,7 +13100,7 @@
           <p:cNvPr id="7" name="">
             <a:extLst xmlns:a="http://schemas.openxmlformats.org/drawingml/2006/main">
               <a:ext uri="{FF2B5EF4-FFF2-40B4-BE49-F238E27FC236}">
-                <a16:creationId xmlns:a16="http://schemas.microsoft.com/office/drawing/2014/main" id="{4217FB3C-C0A2-49E3-A443-07AFA8315E68}"/>
+                <a16:creationId xmlns:a16="http://schemas.microsoft.com/office/drawing/2014/main" id="{EF5B9A91-91AA-46AD-BB5D-DF67F8321430}"/>
               </a:ext>
             </a:extLst>
           </p:cNvPr>
@@ -13130,7 +13130,7 @@
           <p:cNvPr id="8" name="">
             <a:extLst xmlns:a="http://schemas.openxmlformats.org/drawingml/2006/main">
               <a:ext uri="{FF2B5EF4-FFF2-40B4-BE49-F238E27FC236}">
-                <a16:creationId xmlns:a16="http://schemas.microsoft.com/office/drawing/2014/main" id="{1723C465-5E0C-450B-895B-C31181F02200}"/>
+                <a16:creationId xmlns:a16="http://schemas.microsoft.com/office/drawing/2014/main" id="{65790B4E-2DC0-4FA0-8C15-6E569EB4469A}"/>
               </a:ext>
             </a:extLst>
           </p:cNvPr>
@@ -13160,7 +13160,7 @@
           <p:cNvPr id="9" name="">
             <a:extLst xmlns:a="http://schemas.openxmlformats.org/drawingml/2006/main">
               <a:ext uri="{FF2B5EF4-FFF2-40B4-BE49-F238E27FC236}">
-                <a16:creationId xmlns:a16="http://schemas.microsoft.com/office/drawing/2014/main" id="{7F113351-2E29-45D8-8A7D-52D347A33E53}"/>
+                <a16:creationId xmlns:a16="http://schemas.microsoft.com/office/drawing/2014/main" id="{0AB359AF-A990-4688-B46D-903BB1C03E70}"/>
               </a:ext>
             </a:extLst>
           </p:cNvPr>
@@ -13280,7 +13280,7 @@
           <p:cNvPr id="10" name="">
             <a:extLst xmlns:a="http://schemas.openxmlformats.org/drawingml/2006/main">
               <a:ext uri="{FF2B5EF4-FFF2-40B4-BE49-F238E27FC236}">
-                <a16:creationId xmlns:a16="http://schemas.microsoft.com/office/drawing/2014/main" id="{E7F95D04-1552-4241-9463-9B512E4ACF23}"/>
+                <a16:creationId xmlns:a16="http://schemas.microsoft.com/office/drawing/2014/main" id="{7E7041B8-69E5-487A-9781-B73189AC0AD6}"/>
               </a:ext>
             </a:extLst>
           </p:cNvPr>
@@ -13434,7 +13434,7 @@
           <p:cNvPr id="11" name="">
             <a:extLst xmlns:a="http://schemas.openxmlformats.org/drawingml/2006/main">
               <a:ext uri="{FF2B5EF4-FFF2-40B4-BE49-F238E27FC236}">
-                <a16:creationId xmlns:a16="http://schemas.microsoft.com/office/drawing/2014/main" id="{B6AA0146-5ED9-473D-8839-C088271566AD}"/>
+                <a16:creationId xmlns:a16="http://schemas.microsoft.com/office/drawing/2014/main" id="{DAF487E1-266E-40B9-8448-8C75D3E04244}"/>
               </a:ext>
             </a:extLst>
           </p:cNvPr>
@@ -13464,7 +13464,7 @@
           <p:cNvPr id="12" name="">
             <a:extLst xmlns:a="http://schemas.openxmlformats.org/drawingml/2006/main">
               <a:ext uri="{FF2B5EF4-FFF2-40B4-BE49-F238E27FC236}">
-                <a16:creationId xmlns:a16="http://schemas.microsoft.com/office/drawing/2014/main" id="{10F348E1-6116-4C8A-A8B0-DD6F23700A58}"/>
+                <a16:creationId xmlns:a16="http://schemas.microsoft.com/office/drawing/2014/main" id="{69A3424F-B554-4003-9F1E-8983F7930DD1}"/>
               </a:ext>
             </a:extLst>
           </p:cNvPr>
@@ -13494,7 +13494,7 @@
           <p:cNvPr id="13" name="">
             <a:extLst xmlns:a="http://schemas.openxmlformats.org/drawingml/2006/main">
               <a:ext uri="{FF2B5EF4-FFF2-40B4-BE49-F238E27FC236}">
-                <a16:creationId xmlns:a16="http://schemas.microsoft.com/office/drawing/2014/main" id="{BC2B3014-0876-48BB-B9D6-D2536AD0F8C4}"/>
+                <a16:creationId xmlns:a16="http://schemas.microsoft.com/office/drawing/2014/main" id="{D494E1FC-0707-462E-9961-ACE42945368C}"/>
               </a:ext>
             </a:extLst>
           </p:cNvPr>
@@ -13614,7 +13614,7 @@
           <p:cNvPr id="14" name="">
             <a:extLst xmlns:a="http://schemas.openxmlformats.org/drawingml/2006/main">
               <a:ext uri="{FF2B5EF4-FFF2-40B4-BE49-F238E27FC236}">
-                <a16:creationId xmlns:a16="http://schemas.microsoft.com/office/drawing/2014/main" id="{267CED7E-B7A7-46BB-9638-1A0370F32DC5}"/>
+                <a16:creationId xmlns:a16="http://schemas.microsoft.com/office/drawing/2014/main" id="{C9626819-2001-47C2-82D0-9CF0C1F23F3F}"/>
               </a:ext>
             </a:extLst>
           </p:cNvPr>
@@ -13768,7 +13768,7 @@
           <p:cNvPr id="15" name="">
             <a:extLst xmlns:a="http://schemas.openxmlformats.org/drawingml/2006/main">
               <a:ext uri="{FF2B5EF4-FFF2-40B4-BE49-F238E27FC236}">
-                <a16:creationId xmlns:a16="http://schemas.microsoft.com/office/drawing/2014/main" id="{AC180602-18F1-42C9-8D69-4E5A0114CE90}"/>
+                <a16:creationId xmlns:a16="http://schemas.microsoft.com/office/drawing/2014/main" id="{68B0C17C-95D7-43D0-B1D4-768E4BE4F18A}"/>
               </a:ext>
             </a:extLst>
           </p:cNvPr>
@@ -13798,7 +13798,7 @@
           <p:cNvPr id="16" name="">
             <a:extLst xmlns:a="http://schemas.openxmlformats.org/drawingml/2006/main">
               <a:ext uri="{FF2B5EF4-FFF2-40B4-BE49-F238E27FC236}">
-                <a16:creationId xmlns:a16="http://schemas.microsoft.com/office/drawing/2014/main" id="{E10E1D08-BF84-4EEB-B961-C536E883CDB0}"/>
+                <a16:creationId xmlns:a16="http://schemas.microsoft.com/office/drawing/2014/main" id="{6C851A57-2216-4064-BF57-9D7EEF5D882E}"/>
               </a:ext>
             </a:extLst>
           </p:cNvPr>
@@ -13828,7 +13828,7 @@
           <p:cNvPr id="17" name="">
             <a:extLst xmlns:a="http://schemas.openxmlformats.org/drawingml/2006/main">
               <a:ext uri="{FF2B5EF4-FFF2-40B4-BE49-F238E27FC236}">
-                <a16:creationId xmlns:a16="http://schemas.microsoft.com/office/drawing/2014/main" id="{0070D351-D4EC-4063-84A2-152AE601831C}"/>
+                <a16:creationId xmlns:a16="http://schemas.microsoft.com/office/drawing/2014/main" id="{DEC666DA-0F85-4228-8709-93F7D27CC1E7}"/>
               </a:ext>
             </a:extLst>
           </p:cNvPr>
@@ -13948,7 +13948,7 @@
           <p:cNvPr id="18" name="">
             <a:extLst xmlns:a="http://schemas.openxmlformats.org/drawingml/2006/main">
               <a:ext uri="{FF2B5EF4-FFF2-40B4-BE49-F238E27FC236}">
-                <a16:creationId xmlns:a16="http://schemas.microsoft.com/office/drawing/2014/main" id="{374C3085-6628-49DC-A1A7-9DAC811432B6}"/>
+                <a16:creationId xmlns:a16="http://schemas.microsoft.com/office/drawing/2014/main" id="{7C4CA390-0984-4B26-BF96-AD4CCE014CCB}"/>
               </a:ext>
             </a:extLst>
           </p:cNvPr>
@@ -14102,7 +14102,7 @@
           <p:cNvPr id="19" name="">
             <a:extLst xmlns:a="http://schemas.openxmlformats.org/drawingml/2006/main">
               <a:ext uri="{FF2B5EF4-FFF2-40B4-BE49-F238E27FC236}">
-                <a16:creationId xmlns:a16="http://schemas.microsoft.com/office/drawing/2014/main" id="{35791D8B-D7BD-44E0-9A50-6344F775B30C}"/>
+                <a16:creationId xmlns:a16="http://schemas.microsoft.com/office/drawing/2014/main" id="{1850F72B-5A30-46B7-9074-CA92D6B5E679}"/>
               </a:ext>
             </a:extLst>
           </p:cNvPr>
@@ -14132,7 +14132,7 @@
           <p:cNvPr id="20" name="">
             <a:extLst xmlns:a="http://schemas.openxmlformats.org/drawingml/2006/main">
               <a:ext uri="{FF2B5EF4-FFF2-40B4-BE49-F238E27FC236}">
-                <a16:creationId xmlns:a16="http://schemas.microsoft.com/office/drawing/2014/main" id="{B72E2F60-2296-41D9-B011-A79BF95BC933}"/>
+                <a16:creationId xmlns:a16="http://schemas.microsoft.com/office/drawing/2014/main" id="{6FE71284-11EF-48F4-A7EE-3B99F27FD50E}"/>
               </a:ext>
             </a:extLst>
           </p:cNvPr>
@@ -14162,7 +14162,7 @@
           <p:cNvPr id="21" name="">
             <a:extLst xmlns:a="http://schemas.openxmlformats.org/drawingml/2006/main">
               <a:ext uri="{FF2B5EF4-FFF2-40B4-BE49-F238E27FC236}">
-                <a16:creationId xmlns:a16="http://schemas.microsoft.com/office/drawing/2014/main" id="{7DB6CC9D-744F-462F-962E-7E4D893D0A55}"/>
+                <a16:creationId xmlns:a16="http://schemas.microsoft.com/office/drawing/2014/main" id="{59557A1E-43F9-44FE-8F5F-ACAA2B52165E}"/>
               </a:ext>
             </a:extLst>
           </p:cNvPr>
@@ -14282,7 +14282,7 @@
           <p:cNvPr id="22" name="">
             <a:extLst xmlns:a="http://schemas.openxmlformats.org/drawingml/2006/main">
               <a:ext uri="{FF2B5EF4-FFF2-40B4-BE49-F238E27FC236}">
-                <a16:creationId xmlns:a16="http://schemas.microsoft.com/office/drawing/2014/main" id="{DE1AE6F8-E134-4172-9B32-6540E11C4736}"/>
+                <a16:creationId xmlns:a16="http://schemas.microsoft.com/office/drawing/2014/main" id="{39E435AA-FBAE-4551-BBF7-3AA29073A805}"/>
               </a:ext>
             </a:extLst>
           </p:cNvPr>
@@ -14436,7 +14436,7 @@
           <p:cNvPr id="23" name="">
             <a:extLst xmlns:a="http://schemas.openxmlformats.org/drawingml/2006/main">
               <a:ext uri="{FF2B5EF4-FFF2-40B4-BE49-F238E27FC236}">
-                <a16:creationId xmlns:a16="http://schemas.microsoft.com/office/drawing/2014/main" id="{C5F0F23B-D73D-4176-ADE2-C975A7BEA508}"/>
+                <a16:creationId xmlns:a16="http://schemas.microsoft.com/office/drawing/2014/main" id="{27F41A9F-0AD0-491F-B04B-3AD0E1C1E1EA}"/>
               </a:ext>
             </a:extLst>
           </p:cNvPr>
@@ -14556,7 +14556,7 @@
           <p:cNvPr id="24" name="">
             <a:extLst xmlns:a="http://schemas.openxmlformats.org/drawingml/2006/main">
               <a:ext uri="{FF2B5EF4-FFF2-40B4-BE49-F238E27FC236}">
-                <a16:creationId xmlns:a16="http://schemas.microsoft.com/office/drawing/2014/main" id="{421A2FA9-B4E7-4A0B-A933-0433A52B1F69}"/>
+                <a16:creationId xmlns:a16="http://schemas.microsoft.com/office/drawing/2014/main" id="{7B5FA6FC-DB70-4A01-81AD-B7B96E972F00}"/>
               </a:ext>
             </a:extLst>
           </p:cNvPr>
@@ -14676,7 +14676,7 @@
           <p:cNvPr id="25" name="">
             <a:extLst xmlns:a="http://schemas.openxmlformats.org/drawingml/2006/main">
               <a:ext uri="{FF2B5EF4-FFF2-40B4-BE49-F238E27FC236}">
-                <a16:creationId xmlns:a16="http://schemas.microsoft.com/office/drawing/2014/main" id="{76158DBB-6DAC-4C0F-818B-C7AC7EAD08BE}"/>
+                <a16:creationId xmlns:a16="http://schemas.microsoft.com/office/drawing/2014/main" id="{2666D524-4B19-4E86-A0DF-CA0AB01BA537}"/>
               </a:ext>
             </a:extLst>
           </p:cNvPr>
@@ -14794,7 +14794,7 @@
     </p:spTree>
     <p:extLst>
       <p:ext uri="{BB962C8B-B14F-4D97-AF65-F5344CB8AC3E}">
-        <p14:creationId xmlns:p14="http://schemas.microsoft.com/office/powerpoint/2010/main" val="1265605175"/>
+        <p14:creationId xmlns:p14="http://schemas.microsoft.com/office/powerpoint/2010/main" val="939048894"/>
       </p:ext>
     </p:extLst>
   </p:cSld>
@@ -14825,7 +14825,7 @@
           <p:cNvPr id="24" name="">
             <a:extLst xmlns:a="http://schemas.openxmlformats.org/drawingml/2006/main">
               <a:ext uri="{FF2B5EF4-FFF2-40B4-BE49-F238E27FC236}">
-                <a16:creationId xmlns:a16="http://schemas.microsoft.com/office/drawing/2014/main" id="{9FB528DE-3EDD-4DFE-93C4-57C29E3C6F06}"/>
+                <a16:creationId xmlns:a16="http://schemas.microsoft.com/office/drawing/2014/main" id="{2C0E7787-18DD-44F6-B500-F5779741BE72}"/>
               </a:ext>
             </a:extLst>
           </p:cNvPr>
@@ -14945,7 +14945,7 @@
           <p:cNvPr id="2" name="">
             <a:extLst xmlns:a="http://schemas.openxmlformats.org/drawingml/2006/main">
               <a:ext uri="{FF2B5EF4-FFF2-40B4-BE49-F238E27FC236}">
-                <a16:creationId xmlns:a16="http://schemas.microsoft.com/office/drawing/2014/main" id="{0DE504B9-F9E2-42D7-AF7F-A63ED88FD4D7}"/>
+                <a16:creationId xmlns:a16="http://schemas.microsoft.com/office/drawing/2014/main" id="{B2C1A021-93B9-4208-9259-6DE19CC7D01E}"/>
               </a:ext>
             </a:extLst>
           </p:cNvPr>
@@ -15065,7 +15065,7 @@
           <p:cNvPr id="3" name="">
             <a:extLst xmlns:a="http://schemas.openxmlformats.org/drawingml/2006/main">
               <a:ext uri="{FF2B5EF4-FFF2-40B4-BE49-F238E27FC236}">
-                <a16:creationId xmlns:a16="http://schemas.microsoft.com/office/drawing/2014/main" id="{1E708406-F8F3-4A90-9226-3B08C218763D}"/>
+                <a16:creationId xmlns:a16="http://schemas.microsoft.com/office/drawing/2014/main" id="{BC8E7565-64AC-4BAB-B3A1-C98F89F4198E}"/>
               </a:ext>
             </a:extLst>
           </p:cNvPr>
@@ -15095,7 +15095,7 @@
           <p:cNvPr id="4" name="">
             <a:extLst xmlns:a="http://schemas.openxmlformats.org/drawingml/2006/main">
               <a:ext uri="{FF2B5EF4-FFF2-40B4-BE49-F238E27FC236}">
-                <a16:creationId xmlns:a16="http://schemas.microsoft.com/office/drawing/2014/main" id="{766A9E9D-AC05-48F3-87DF-AA2122456E81}"/>
+                <a16:creationId xmlns:a16="http://schemas.microsoft.com/office/drawing/2014/main" id="{8CEECDB9-18D6-452B-B74D-4A27C5BAFD1B}"/>
               </a:ext>
             </a:extLst>
           </p:cNvPr>
@@ -15215,7 +15215,7 @@
           <p:cNvPr id="5" name="">
             <a:extLst xmlns:a="http://schemas.openxmlformats.org/drawingml/2006/main">
               <a:ext uri="{FF2B5EF4-FFF2-40B4-BE49-F238E27FC236}">
-                <a16:creationId xmlns:a16="http://schemas.microsoft.com/office/drawing/2014/main" id="{39A067E0-77C1-447A-BA9F-B18C0DC391C2}"/>
+                <a16:creationId xmlns:a16="http://schemas.microsoft.com/office/drawing/2014/main" id="{FE17F3F3-D4DB-4BF1-88FD-AB1C927C12A2}"/>
               </a:ext>
             </a:extLst>
           </p:cNvPr>
@@ -15245,7 +15245,7 @@
           <p:cNvPr id="6" name="">
             <a:extLst xmlns:a="http://schemas.openxmlformats.org/drawingml/2006/main">
               <a:ext uri="{FF2B5EF4-FFF2-40B4-BE49-F238E27FC236}">
-                <a16:creationId xmlns:a16="http://schemas.microsoft.com/office/drawing/2014/main" id="{FF78B13C-663A-40D8-9555-DDEDAE38448A}"/>
+                <a16:creationId xmlns:a16="http://schemas.microsoft.com/office/drawing/2014/main" id="{523BC716-3CF4-419F-B416-15D3ED8CD468}"/>
               </a:ext>
             </a:extLst>
           </p:cNvPr>
@@ -15365,7 +15365,7 @@
           <p:cNvPr id="7" name="">
             <a:extLst xmlns:a="http://schemas.openxmlformats.org/drawingml/2006/main">
               <a:ext uri="{FF2B5EF4-FFF2-40B4-BE49-F238E27FC236}">
-                <a16:creationId xmlns:a16="http://schemas.microsoft.com/office/drawing/2014/main" id="{D41C2D5D-9159-4A25-91FF-A29B9C9ACD68}"/>
+                <a16:creationId xmlns:a16="http://schemas.microsoft.com/office/drawing/2014/main" id="{737AD63C-BF6F-4500-886C-5F020A2B4D5D}"/>
               </a:ext>
             </a:extLst>
           </p:cNvPr>
@@ -15485,7 +15485,7 @@
           <p:cNvPr id="8" name="">
             <a:extLst xmlns:a="http://schemas.openxmlformats.org/drawingml/2006/main">
               <a:ext uri="{FF2B5EF4-FFF2-40B4-BE49-F238E27FC236}">
-                <a16:creationId xmlns:a16="http://schemas.microsoft.com/office/drawing/2014/main" id="{B083495F-F753-4B1B-9EAA-716DE38EE527}"/>
+                <a16:creationId xmlns:a16="http://schemas.microsoft.com/office/drawing/2014/main" id="{6CB4137B-7E5D-4B2E-ADC8-14530D3F70F8}"/>
               </a:ext>
             </a:extLst>
           </p:cNvPr>
@@ -15515,7 +15515,7 @@
           <p:cNvPr id="9" name="">
             <a:extLst xmlns:a="http://schemas.openxmlformats.org/drawingml/2006/main">
               <a:ext uri="{FF2B5EF4-FFF2-40B4-BE49-F238E27FC236}">
-                <a16:creationId xmlns:a16="http://schemas.microsoft.com/office/drawing/2014/main" id="{4E529BDC-DB4B-4658-9EC0-C8663CAFDD22}"/>
+                <a16:creationId xmlns:a16="http://schemas.microsoft.com/office/drawing/2014/main" id="{74A8A6D4-54F8-4F36-B997-C15956A9B2BD}"/>
               </a:ext>
             </a:extLst>
           </p:cNvPr>
@@ -15635,7 +15635,7 @@
           <p:cNvPr id="10" name="">
             <a:extLst xmlns:a="http://schemas.openxmlformats.org/drawingml/2006/main">
               <a:ext uri="{FF2B5EF4-FFF2-40B4-BE49-F238E27FC236}">
-                <a16:creationId xmlns:a16="http://schemas.microsoft.com/office/drawing/2014/main" id="{796BE628-0336-4324-A00E-E4AE3494159F}"/>
+                <a16:creationId xmlns:a16="http://schemas.microsoft.com/office/drawing/2014/main" id="{098700F2-0340-4D2B-BCF0-832AEDBCC8BC}"/>
               </a:ext>
             </a:extLst>
           </p:cNvPr>
@@ -15755,7 +15755,7 @@
           <p:cNvPr id="11" name="">
             <a:extLst xmlns:a="http://schemas.openxmlformats.org/drawingml/2006/main">
               <a:ext uri="{FF2B5EF4-FFF2-40B4-BE49-F238E27FC236}">
-                <a16:creationId xmlns:a16="http://schemas.microsoft.com/office/drawing/2014/main" id="{A2B1C667-8B45-4297-9508-8E1BA4D90D3B}"/>
+                <a16:creationId xmlns:a16="http://schemas.microsoft.com/office/drawing/2014/main" id="{435C8606-8F75-4748-9B90-09C4D8ED545C}"/>
               </a:ext>
             </a:extLst>
           </p:cNvPr>
@@ -15785,7 +15785,7 @@
           <p:cNvPr id="12" name="">
             <a:extLst xmlns:a="http://schemas.openxmlformats.org/drawingml/2006/main">
               <a:ext uri="{FF2B5EF4-FFF2-40B4-BE49-F238E27FC236}">
-                <a16:creationId xmlns:a16="http://schemas.microsoft.com/office/drawing/2014/main" id="{6E90BCA6-3705-4FDA-8F0E-832E00871ED7}"/>
+                <a16:creationId xmlns:a16="http://schemas.microsoft.com/office/drawing/2014/main" id="{A375C276-751B-4C59-ABED-E4CFC0184E78}"/>
               </a:ext>
             </a:extLst>
           </p:cNvPr>
@@ -15905,7 +15905,7 @@
           <p:cNvPr id="13" name="">
             <a:extLst xmlns:a="http://schemas.openxmlformats.org/drawingml/2006/main">
               <a:ext uri="{FF2B5EF4-FFF2-40B4-BE49-F238E27FC236}">
-                <a16:creationId xmlns:a16="http://schemas.microsoft.com/office/drawing/2014/main" id="{E77C87CF-FD33-4536-9DC4-519EE37A8AED}"/>
+                <a16:creationId xmlns:a16="http://schemas.microsoft.com/office/drawing/2014/main" id="{2C9A97C9-4895-4026-B508-B4422518EEAE}"/>
               </a:ext>
             </a:extLst>
           </p:cNvPr>
@@ -16025,7 +16025,7 @@
           <p:cNvPr id="14" name="">
             <a:extLst xmlns:a="http://schemas.openxmlformats.org/drawingml/2006/main">
               <a:ext uri="{FF2B5EF4-FFF2-40B4-BE49-F238E27FC236}">
-                <a16:creationId xmlns:a16="http://schemas.microsoft.com/office/drawing/2014/main" id="{C910A44D-F1BB-4A09-BC71-D1B271D3EA70}"/>
+                <a16:creationId xmlns:a16="http://schemas.microsoft.com/office/drawing/2014/main" id="{15AE2C7F-3FEE-4856-A4BC-4A1B39ABFBCC}"/>
               </a:ext>
             </a:extLst>
           </p:cNvPr>
@@ -16055,7 +16055,7 @@
           <p:cNvPr id="15" name="">
             <a:extLst xmlns:a="http://schemas.openxmlformats.org/drawingml/2006/main">
               <a:ext uri="{FF2B5EF4-FFF2-40B4-BE49-F238E27FC236}">
-                <a16:creationId xmlns:a16="http://schemas.microsoft.com/office/drawing/2014/main" id="{647D687A-333E-4617-A9D3-E5D96B070620}"/>
+                <a16:creationId xmlns:a16="http://schemas.microsoft.com/office/drawing/2014/main" id="{6443D75E-B41B-4F81-A6B4-5AB443604583}"/>
               </a:ext>
             </a:extLst>
           </p:cNvPr>
@@ -16175,7 +16175,7 @@
           <p:cNvPr id="16" name="">
             <a:extLst xmlns:a="http://schemas.openxmlformats.org/drawingml/2006/main">
               <a:ext uri="{FF2B5EF4-FFF2-40B4-BE49-F238E27FC236}">
-                <a16:creationId xmlns:a16="http://schemas.microsoft.com/office/drawing/2014/main" id="{F8AD0C03-213E-4E78-B5C3-4989CE7527F4}"/>
+                <a16:creationId xmlns:a16="http://schemas.microsoft.com/office/drawing/2014/main" id="{D7FE57B8-19DD-4EC7-B5CE-0873E3DA4E61}"/>
               </a:ext>
             </a:extLst>
           </p:cNvPr>
@@ -16295,7 +16295,7 @@
           <p:cNvPr id="17" name="">
             <a:extLst xmlns:a="http://schemas.openxmlformats.org/drawingml/2006/main">
               <a:ext uri="{FF2B5EF4-FFF2-40B4-BE49-F238E27FC236}">
-                <a16:creationId xmlns:a16="http://schemas.microsoft.com/office/drawing/2014/main" id="{17CD3516-96AA-4146-A8F0-83DCF92EFFA2}"/>
+                <a16:creationId xmlns:a16="http://schemas.microsoft.com/office/drawing/2014/main" id="{FE77DABE-40D4-45D5-B97F-41E483B02843}"/>
               </a:ext>
             </a:extLst>
           </p:cNvPr>
@@ -16325,7 +16325,7 @@
           <p:cNvPr id="18" name="">
             <a:extLst xmlns:a="http://schemas.openxmlformats.org/drawingml/2006/main">
               <a:ext uri="{FF2B5EF4-FFF2-40B4-BE49-F238E27FC236}">
-                <a16:creationId xmlns:a16="http://schemas.microsoft.com/office/drawing/2014/main" id="{D179E884-21C4-4701-9D10-624C58C0A4D1}"/>
+                <a16:creationId xmlns:a16="http://schemas.microsoft.com/office/drawing/2014/main" id="{7ADBCDBF-EF09-4A10-A269-089E698655BC}"/>
               </a:ext>
             </a:extLst>
           </p:cNvPr>
@@ -16445,7 +16445,7 @@
           <p:cNvPr id="19" name="">
             <a:extLst xmlns:a="http://schemas.openxmlformats.org/drawingml/2006/main">
               <a:ext uri="{FF2B5EF4-FFF2-40B4-BE49-F238E27FC236}">
-                <a16:creationId xmlns:a16="http://schemas.microsoft.com/office/drawing/2014/main" id="{22469502-E5AE-4952-B987-98CB77B9F760}"/>
+                <a16:creationId xmlns:a16="http://schemas.microsoft.com/office/drawing/2014/main" id="{17BC9F63-73F9-4EF4-A2E0-C14F2059ACFA}"/>
               </a:ext>
             </a:extLst>
           </p:cNvPr>
@@ -16565,7 +16565,7 @@
           <p:cNvPr id="20" name="">
             <a:extLst xmlns:a="http://schemas.openxmlformats.org/drawingml/2006/main">
               <a:ext uri="{FF2B5EF4-FFF2-40B4-BE49-F238E27FC236}">
-                <a16:creationId xmlns:a16="http://schemas.microsoft.com/office/drawing/2014/main" id="{507A1617-8AFA-48B0-B624-572795D39712}"/>
+                <a16:creationId xmlns:a16="http://schemas.microsoft.com/office/drawing/2014/main" id="{5759A69B-FA7C-4974-A11D-D00750DC57BD}"/>
               </a:ext>
             </a:extLst>
           </p:cNvPr>
@@ -16595,7 +16595,7 @@
           <p:cNvPr id="21" name="">
             <a:extLst xmlns:a="http://schemas.openxmlformats.org/drawingml/2006/main">
               <a:ext uri="{FF2B5EF4-FFF2-40B4-BE49-F238E27FC236}">
-                <a16:creationId xmlns:a16="http://schemas.microsoft.com/office/drawing/2014/main" id="{16151112-386F-4046-B900-3EEDD982FD52}"/>
+                <a16:creationId xmlns:a16="http://schemas.microsoft.com/office/drawing/2014/main" id="{BF56E061-25BD-4398-8764-B688D6FEE0D2}"/>
               </a:ext>
             </a:extLst>
           </p:cNvPr>
@@ -16715,7 +16715,7 @@
           <p:cNvPr id="22" name="">
             <a:extLst xmlns:a="http://schemas.openxmlformats.org/drawingml/2006/main">
               <a:ext uri="{FF2B5EF4-FFF2-40B4-BE49-F238E27FC236}">
-                <a16:creationId xmlns:a16="http://schemas.microsoft.com/office/drawing/2014/main" id="{BA49B33D-D3BF-4F5C-B862-DA840F0F88B9}"/>
+                <a16:creationId xmlns:a16="http://schemas.microsoft.com/office/drawing/2014/main" id="{F43F1AB8-F41D-4A01-A4D1-5C6E9A5B1B3C}"/>
               </a:ext>
             </a:extLst>
           </p:cNvPr>
@@ -16835,7 +16835,7 @@
           <p:cNvPr id="23" name="">
             <a:extLst xmlns:a="http://schemas.openxmlformats.org/drawingml/2006/main">
               <a:ext uri="{FF2B5EF4-FFF2-40B4-BE49-F238E27FC236}">
-                <a16:creationId xmlns:a16="http://schemas.microsoft.com/office/drawing/2014/main" id="{D457FF78-6F49-4EB3-9084-C107949CADEE}"/>
+                <a16:creationId xmlns:a16="http://schemas.microsoft.com/office/drawing/2014/main" id="{47DEE214-D55E-400C-B19D-9DDB20F6B1DB}"/>
               </a:ext>
             </a:extLst>
           </p:cNvPr>
@@ -16953,7 +16953,7 @@
     </p:spTree>
     <p:extLst>
       <p:ext uri="{BB962C8B-B14F-4D97-AF65-F5344CB8AC3E}">
-        <p14:creationId xmlns:p14="http://schemas.microsoft.com/office/powerpoint/2010/main" val="1844521575"/>
+        <p14:creationId xmlns:p14="http://schemas.microsoft.com/office/powerpoint/2010/main" val="1185087491"/>
       </p:ext>
     </p:extLst>
   </p:cSld>
@@ -16984,7 +16984,7 @@
           <p:cNvPr id="34" name="">
             <a:extLst xmlns:a="http://schemas.openxmlformats.org/drawingml/2006/main">
               <a:ext uri="{FF2B5EF4-FFF2-40B4-BE49-F238E27FC236}">
-                <a16:creationId xmlns:a16="http://schemas.microsoft.com/office/drawing/2014/main" id="{551F9181-9B4B-460E-8181-188B587A964F}"/>
+                <a16:creationId xmlns:a16="http://schemas.microsoft.com/office/drawing/2014/main" id="{CD855B00-BD79-4C81-B15E-CA398301C7BF}"/>
               </a:ext>
             </a:extLst>
           </p:cNvPr>
@@ -17104,7 +17104,7 @@
           <p:cNvPr id="2" name="">
             <a:extLst xmlns:a="http://schemas.openxmlformats.org/drawingml/2006/main">
               <a:ext uri="{FF2B5EF4-FFF2-40B4-BE49-F238E27FC236}">
-                <a16:creationId xmlns:a16="http://schemas.microsoft.com/office/drawing/2014/main" id="{DC138CF4-39C6-4A2F-A80C-7E1998D0A8C7}"/>
+                <a16:creationId xmlns:a16="http://schemas.microsoft.com/office/drawing/2014/main" id="{F8D1F026-FF58-44D6-932B-1DDDE9C3B342}"/>
               </a:ext>
             </a:extLst>
           </p:cNvPr>
@@ -17224,7 +17224,7 @@
           <p:cNvPr id="3" name="">
             <a:extLst xmlns:a="http://schemas.openxmlformats.org/drawingml/2006/main">
               <a:ext uri="{FF2B5EF4-FFF2-40B4-BE49-F238E27FC236}">
-                <a16:creationId xmlns:a16="http://schemas.microsoft.com/office/drawing/2014/main" id="{78E5F154-6335-4DF5-8128-88CFE65E9587}"/>
+                <a16:creationId xmlns:a16="http://schemas.microsoft.com/office/drawing/2014/main" id="{7E9C87B4-091F-4D9A-BF9C-D362B3B404A3}"/>
               </a:ext>
             </a:extLst>
           </p:cNvPr>
@@ -17254,7 +17254,7 @@
           <p:cNvPr id="4" name="">
             <a:extLst xmlns:a="http://schemas.openxmlformats.org/drawingml/2006/main">
               <a:ext uri="{FF2B5EF4-FFF2-40B4-BE49-F238E27FC236}">
-                <a16:creationId xmlns:a16="http://schemas.microsoft.com/office/drawing/2014/main" id="{6CDAD5A6-EC5B-4BC8-A448-C225BC59B48D}"/>
+                <a16:creationId xmlns:a16="http://schemas.microsoft.com/office/drawing/2014/main" id="{5856BAC1-89AA-4258-8673-863DA1090EB2}"/>
               </a:ext>
             </a:extLst>
           </p:cNvPr>
@@ -17284,7 +17284,7 @@
           <p:cNvPr id="5" name="">
             <a:extLst xmlns:a="http://schemas.openxmlformats.org/drawingml/2006/main">
               <a:ext uri="{FF2B5EF4-FFF2-40B4-BE49-F238E27FC236}">
-                <a16:creationId xmlns:a16="http://schemas.microsoft.com/office/drawing/2014/main" id="{D2B5EC99-59A5-49A0-8D15-B5E92233303A}"/>
+                <a16:creationId xmlns:a16="http://schemas.microsoft.com/office/drawing/2014/main" id="{075F95C2-127A-4847-BF63-1638E6372E7E}"/>
               </a:ext>
             </a:extLst>
           </p:cNvPr>
@@ -17404,7 +17404,7 @@
           <p:cNvPr id="6" name="">
             <a:extLst xmlns:a="http://schemas.openxmlformats.org/drawingml/2006/main">
               <a:ext uri="{FF2B5EF4-FFF2-40B4-BE49-F238E27FC236}">
-                <a16:creationId xmlns:a16="http://schemas.microsoft.com/office/drawing/2014/main" id="{C72CFDA5-6335-4705-B8F4-7FD9C3D06F30}"/>
+                <a16:creationId xmlns:a16="http://schemas.microsoft.com/office/drawing/2014/main" id="{A101D092-E46D-4D40-9709-95122FB1CB3D}"/>
               </a:ext>
             </a:extLst>
           </p:cNvPr>
@@ -17524,7 +17524,7 @@
           <p:cNvPr id="7" name="">
             <a:extLst xmlns:a="http://schemas.openxmlformats.org/drawingml/2006/main">
               <a:ext uri="{FF2B5EF4-FFF2-40B4-BE49-F238E27FC236}">
-                <a16:creationId xmlns:a16="http://schemas.microsoft.com/office/drawing/2014/main" id="{BC3DC79D-DB00-46E1-B6C9-A43A34E7A968}"/>
+                <a16:creationId xmlns:a16="http://schemas.microsoft.com/office/drawing/2014/main" id="{AF52C822-6933-49C7-9239-4208D72BB1B7}"/>
               </a:ext>
             </a:extLst>
           </p:cNvPr>
@@ -17661,7 +17661,7 @@
           <p:cNvPr id="8" name="">
             <a:extLst xmlns:a="http://schemas.openxmlformats.org/drawingml/2006/main">
               <a:ext uri="{FF2B5EF4-FFF2-40B4-BE49-F238E27FC236}">
-                <a16:creationId xmlns:a16="http://schemas.microsoft.com/office/drawing/2014/main" id="{617763A8-E903-4715-A7A9-D3E3316BCC84}"/>
+                <a16:creationId xmlns:a16="http://schemas.microsoft.com/office/drawing/2014/main" id="{23ED84B7-0972-41A4-ACBF-FDFFFC8A0A8D}"/>
               </a:ext>
             </a:extLst>
           </p:cNvPr>
@@ -17691,7 +17691,7 @@
           <p:cNvPr id="9" name="">
             <a:extLst xmlns:a="http://schemas.openxmlformats.org/drawingml/2006/main">
               <a:ext uri="{FF2B5EF4-FFF2-40B4-BE49-F238E27FC236}">
-                <a16:creationId xmlns:a16="http://schemas.microsoft.com/office/drawing/2014/main" id="{B9E77227-830B-4C0F-BBAA-22EB4938BBC3}"/>
+                <a16:creationId xmlns:a16="http://schemas.microsoft.com/office/drawing/2014/main" id="{B4FF232E-D3E2-4A29-81E8-AFD860997BDA}"/>
               </a:ext>
             </a:extLst>
           </p:cNvPr>
@@ -17811,7 +17811,7 @@
           <p:cNvPr id="10" name="">
             <a:extLst xmlns:a="http://schemas.openxmlformats.org/drawingml/2006/main">
               <a:ext uri="{FF2B5EF4-FFF2-40B4-BE49-F238E27FC236}">
-                <a16:creationId xmlns:a16="http://schemas.microsoft.com/office/drawing/2014/main" id="{7851DB40-0775-468A-BF62-90CA365EC73B}"/>
+                <a16:creationId xmlns:a16="http://schemas.microsoft.com/office/drawing/2014/main" id="{7F86BC5C-E9D2-410B-BB45-5EF354CE01A5}"/>
               </a:ext>
             </a:extLst>
           </p:cNvPr>
@@ -17931,7 +17931,7 @@
           <p:cNvPr id="11" name="">
             <a:extLst xmlns:a="http://schemas.openxmlformats.org/drawingml/2006/main">
               <a:ext uri="{FF2B5EF4-FFF2-40B4-BE49-F238E27FC236}">
-                <a16:creationId xmlns:a16="http://schemas.microsoft.com/office/drawing/2014/main" id="{CAC059C1-E7F8-4F44-93FE-2AB3097D2CC6}"/>
+                <a16:creationId xmlns:a16="http://schemas.microsoft.com/office/drawing/2014/main" id="{C89C9C48-8D03-4B0B-A500-12ED7262BBBE}"/>
               </a:ext>
             </a:extLst>
           </p:cNvPr>
@@ -18068,7 +18068,7 @@
           <p:cNvPr id="12" name="">
             <a:extLst xmlns:a="http://schemas.openxmlformats.org/drawingml/2006/main">
               <a:ext uri="{FF2B5EF4-FFF2-40B4-BE49-F238E27FC236}">
-                <a16:creationId xmlns:a16="http://schemas.microsoft.com/office/drawing/2014/main" id="{D29E83CD-4855-4069-917A-C58C349ED4A8}"/>
+                <a16:creationId xmlns:a16="http://schemas.microsoft.com/office/drawing/2014/main" id="{EDEBF5E5-4F39-4986-BC44-83311CC4E940}"/>
               </a:ext>
             </a:extLst>
           </p:cNvPr>
@@ -18098,7 +18098,7 @@
           <p:cNvPr id="13" name="">
             <a:extLst xmlns:a="http://schemas.openxmlformats.org/drawingml/2006/main">
               <a:ext uri="{FF2B5EF4-FFF2-40B4-BE49-F238E27FC236}">
-                <a16:creationId xmlns:a16="http://schemas.microsoft.com/office/drawing/2014/main" id="{65150BB2-F022-4394-885B-DCA29C9A4706}"/>
+                <a16:creationId xmlns:a16="http://schemas.microsoft.com/office/drawing/2014/main" id="{99818C82-6E7D-4192-A560-A2084FE58CE1}"/>
               </a:ext>
             </a:extLst>
           </p:cNvPr>
@@ -18218,7 +18218,7 @@
           <p:cNvPr id="14" name="">
             <a:extLst xmlns:a="http://schemas.openxmlformats.org/drawingml/2006/main">
               <a:ext uri="{FF2B5EF4-FFF2-40B4-BE49-F238E27FC236}">
-                <a16:creationId xmlns:a16="http://schemas.microsoft.com/office/drawing/2014/main" id="{62B31098-51F1-44AE-A5B4-833629F2CD00}"/>
+                <a16:creationId xmlns:a16="http://schemas.microsoft.com/office/drawing/2014/main" id="{D8F9CE6E-4504-4C05-9168-B11D35707D68}"/>
               </a:ext>
             </a:extLst>
           </p:cNvPr>
@@ -18338,7 +18338,7 @@
           <p:cNvPr id="15" name="">
             <a:extLst xmlns:a="http://schemas.openxmlformats.org/drawingml/2006/main">
               <a:ext uri="{FF2B5EF4-FFF2-40B4-BE49-F238E27FC236}">
-                <a16:creationId xmlns:a16="http://schemas.microsoft.com/office/drawing/2014/main" id="{271DB29F-46C9-4421-84D3-62BBB04D11BD}"/>
+                <a16:creationId xmlns:a16="http://schemas.microsoft.com/office/drawing/2014/main" id="{65730126-BB44-4FAF-A472-B465D93BDF72}"/>
               </a:ext>
             </a:extLst>
           </p:cNvPr>
@@ -18475,7 +18475,7 @@
           <p:cNvPr id="16" name="">
             <a:extLst xmlns:a="http://schemas.openxmlformats.org/drawingml/2006/main">
               <a:ext uri="{FF2B5EF4-FFF2-40B4-BE49-F238E27FC236}">
-                <a16:creationId xmlns:a16="http://schemas.microsoft.com/office/drawing/2014/main" id="{7B222E3E-96BB-4632-8671-56100CDCB844}"/>
+                <a16:creationId xmlns:a16="http://schemas.microsoft.com/office/drawing/2014/main" id="{394FE9A3-8B6F-4CDB-995A-607DE47D84BD}"/>
               </a:ext>
             </a:extLst>
           </p:cNvPr>
@@ -18505,7 +18505,7 @@
           <p:cNvPr id="17" name="">
             <a:extLst xmlns:a="http://schemas.openxmlformats.org/drawingml/2006/main">
               <a:ext uri="{FF2B5EF4-FFF2-40B4-BE49-F238E27FC236}">
-                <a16:creationId xmlns:a16="http://schemas.microsoft.com/office/drawing/2014/main" id="{7B08ED8B-8280-4F23-9A67-EC15D8FC54D0}"/>
+                <a16:creationId xmlns:a16="http://schemas.microsoft.com/office/drawing/2014/main" id="{C356F313-FE82-43E6-BA18-16BCCADE583B}"/>
               </a:ext>
             </a:extLst>
           </p:cNvPr>
@@ -18625,7 +18625,7 @@
           <p:cNvPr id="18" name="">
             <a:extLst xmlns:a="http://schemas.openxmlformats.org/drawingml/2006/main">
               <a:ext uri="{FF2B5EF4-FFF2-40B4-BE49-F238E27FC236}">
-                <a16:creationId xmlns:a16="http://schemas.microsoft.com/office/drawing/2014/main" id="{295C3206-E47F-4BE7-B3B3-71D60970D22C}"/>
+                <a16:creationId xmlns:a16="http://schemas.microsoft.com/office/drawing/2014/main" id="{0AAF4D96-CDC3-43B4-AB16-63A113B230D0}"/>
               </a:ext>
             </a:extLst>
           </p:cNvPr>
@@ -18745,7 +18745,7 @@
           <p:cNvPr id="19" name="">
             <a:extLst xmlns:a="http://schemas.openxmlformats.org/drawingml/2006/main">
               <a:ext uri="{FF2B5EF4-FFF2-40B4-BE49-F238E27FC236}">
-                <a16:creationId xmlns:a16="http://schemas.microsoft.com/office/drawing/2014/main" id="{4A6DAE31-2725-4B51-B33B-E4EDFE59ABCA}"/>
+                <a16:creationId xmlns:a16="http://schemas.microsoft.com/office/drawing/2014/main" id="{BB805060-BFE3-44B5-B257-09648DB37B2A}"/>
               </a:ext>
             </a:extLst>
           </p:cNvPr>
@@ -18882,7 +18882,7 @@
           <p:cNvPr id="20" name="">
             <a:extLst xmlns:a="http://schemas.openxmlformats.org/drawingml/2006/main">
               <a:ext uri="{FF2B5EF4-FFF2-40B4-BE49-F238E27FC236}">
-                <a16:creationId xmlns:a16="http://schemas.microsoft.com/office/drawing/2014/main" id="{1D5DFBA6-F8F5-46F4-9276-D0FC9DE4980C}"/>
+                <a16:creationId xmlns:a16="http://schemas.microsoft.com/office/drawing/2014/main" id="{7D9E1DD9-331A-4346-BB33-4EC827D7C4E3}"/>
               </a:ext>
             </a:extLst>
           </p:cNvPr>
@@ -18912,7 +18912,7 @@
           <p:cNvPr id="21" name="">
             <a:extLst xmlns:a="http://schemas.openxmlformats.org/drawingml/2006/main">
               <a:ext uri="{FF2B5EF4-FFF2-40B4-BE49-F238E27FC236}">
-                <a16:creationId xmlns:a16="http://schemas.microsoft.com/office/drawing/2014/main" id="{4678A08F-A02F-4EE9-9833-608376BB1D7F}"/>
+                <a16:creationId xmlns:a16="http://schemas.microsoft.com/office/drawing/2014/main" id="{FB68E66F-7CB9-481C-9D06-DD3E37FF1744}"/>
               </a:ext>
             </a:extLst>
           </p:cNvPr>
@@ -19032,7 +19032,7 @@
           <p:cNvPr id="22" name="">
             <a:extLst xmlns:a="http://schemas.openxmlformats.org/drawingml/2006/main">
               <a:ext uri="{FF2B5EF4-FFF2-40B4-BE49-F238E27FC236}">
-                <a16:creationId xmlns:a16="http://schemas.microsoft.com/office/drawing/2014/main" id="{CE759E14-0027-4393-93B2-0C1756CA5AC0}"/>
+                <a16:creationId xmlns:a16="http://schemas.microsoft.com/office/drawing/2014/main" id="{5CFDE936-2D66-4476-840F-7EE89691B076}"/>
               </a:ext>
             </a:extLst>
           </p:cNvPr>
@@ -19152,7 +19152,7 @@
           <p:cNvPr id="23" name="">
             <a:extLst xmlns:a="http://schemas.openxmlformats.org/drawingml/2006/main">
               <a:ext uri="{FF2B5EF4-FFF2-40B4-BE49-F238E27FC236}">
-                <a16:creationId xmlns:a16="http://schemas.microsoft.com/office/drawing/2014/main" id="{B487BAC7-E260-43AD-9AA5-B5D0B459107F}"/>
+                <a16:creationId xmlns:a16="http://schemas.microsoft.com/office/drawing/2014/main" id="{0CDC25B6-328C-49F1-B604-C3730731CBF2}"/>
               </a:ext>
             </a:extLst>
           </p:cNvPr>
@@ -19289,7 +19289,7 @@
           <p:cNvPr id="24" name="">
             <a:extLst xmlns:a="http://schemas.openxmlformats.org/drawingml/2006/main">
               <a:ext uri="{FF2B5EF4-FFF2-40B4-BE49-F238E27FC236}">
-                <a16:creationId xmlns:a16="http://schemas.microsoft.com/office/drawing/2014/main" id="{A2CD101D-2ADA-4829-B041-31131C4DDF64}"/>
+                <a16:creationId xmlns:a16="http://schemas.microsoft.com/office/drawing/2014/main" id="{6FC664D0-C843-41F2-9F18-EADD4462D467}"/>
               </a:ext>
             </a:extLst>
           </p:cNvPr>
@@ -19319,7 +19319,7 @@
           <p:cNvPr id="25" name="">
             <a:extLst xmlns:a="http://schemas.openxmlformats.org/drawingml/2006/main">
               <a:ext uri="{FF2B5EF4-FFF2-40B4-BE49-F238E27FC236}">
-                <a16:creationId xmlns:a16="http://schemas.microsoft.com/office/drawing/2014/main" id="{7F4ED402-5F84-4290-B4CC-85B134AE8B66}"/>
+                <a16:creationId xmlns:a16="http://schemas.microsoft.com/office/drawing/2014/main" id="{25983389-75FB-4012-B165-E77512CC38A3}"/>
               </a:ext>
             </a:extLst>
           </p:cNvPr>
@@ -19439,7 +19439,7 @@
           <p:cNvPr id="26" name="">
             <a:extLst xmlns:a="http://schemas.openxmlformats.org/drawingml/2006/main">
               <a:ext uri="{FF2B5EF4-FFF2-40B4-BE49-F238E27FC236}">
-                <a16:creationId xmlns:a16="http://schemas.microsoft.com/office/drawing/2014/main" id="{749F7837-438A-406B-A69E-75413A43A225}"/>
+                <a16:creationId xmlns:a16="http://schemas.microsoft.com/office/drawing/2014/main" id="{475AB2EA-A5D1-4D71-8CFC-3E83F190C6A3}"/>
               </a:ext>
             </a:extLst>
           </p:cNvPr>
@@ -19559,7 +19559,7 @@
           <p:cNvPr id="27" name="">
             <a:extLst xmlns:a="http://schemas.openxmlformats.org/drawingml/2006/main">
               <a:ext uri="{FF2B5EF4-FFF2-40B4-BE49-F238E27FC236}">
-                <a16:creationId xmlns:a16="http://schemas.microsoft.com/office/drawing/2014/main" id="{CF2E1C1B-2572-4D60-8F33-9FE778F293E6}"/>
+                <a16:creationId xmlns:a16="http://schemas.microsoft.com/office/drawing/2014/main" id="{FAE2873D-9EC7-49FC-BF3B-F5A8205880A6}"/>
               </a:ext>
             </a:extLst>
           </p:cNvPr>
@@ -19696,7 +19696,7 @@
           <p:cNvPr id="28" name="">
             <a:extLst xmlns:a="http://schemas.openxmlformats.org/drawingml/2006/main">
               <a:ext uri="{FF2B5EF4-FFF2-40B4-BE49-F238E27FC236}">
-                <a16:creationId xmlns:a16="http://schemas.microsoft.com/office/drawing/2014/main" id="{2DB6C570-437F-4BDC-83ED-BDBD60A92088}"/>
+                <a16:creationId xmlns:a16="http://schemas.microsoft.com/office/drawing/2014/main" id="{60536259-5EF3-4757-A6BA-F80E27DFF455}"/>
               </a:ext>
             </a:extLst>
           </p:cNvPr>
@@ -19726,7 +19726,7 @@
           <p:cNvPr id="29" name="">
             <a:extLst xmlns:a="http://schemas.openxmlformats.org/drawingml/2006/main">
               <a:ext uri="{FF2B5EF4-FFF2-40B4-BE49-F238E27FC236}">
-                <a16:creationId xmlns:a16="http://schemas.microsoft.com/office/drawing/2014/main" id="{C0939EDF-FC8F-4A85-82BE-686D0E4AFC76}"/>
+                <a16:creationId xmlns:a16="http://schemas.microsoft.com/office/drawing/2014/main" id="{C956CA98-C4AB-4AF9-A8D7-A1BDD7C61268}"/>
               </a:ext>
             </a:extLst>
           </p:cNvPr>
@@ -19846,7 +19846,7 @@
           <p:cNvPr id="30" name="">
             <a:extLst xmlns:a="http://schemas.openxmlformats.org/drawingml/2006/main">
               <a:ext uri="{FF2B5EF4-FFF2-40B4-BE49-F238E27FC236}">
-                <a16:creationId xmlns:a16="http://schemas.microsoft.com/office/drawing/2014/main" id="{518C1072-6410-4670-87AA-9F96AC411D1A}"/>
+                <a16:creationId xmlns:a16="http://schemas.microsoft.com/office/drawing/2014/main" id="{65C934BB-D234-4879-A0E1-78AC5A08E650}"/>
               </a:ext>
             </a:extLst>
           </p:cNvPr>
@@ -19966,7 +19966,7 @@
           <p:cNvPr id="31" name="">
             <a:extLst xmlns:a="http://schemas.openxmlformats.org/drawingml/2006/main">
               <a:ext uri="{FF2B5EF4-FFF2-40B4-BE49-F238E27FC236}">
-                <a16:creationId xmlns:a16="http://schemas.microsoft.com/office/drawing/2014/main" id="{B6EDB699-FB66-4669-87D9-8689D83DDA7D}"/>
+                <a16:creationId xmlns:a16="http://schemas.microsoft.com/office/drawing/2014/main" id="{B2B81D71-8BC4-4B98-9385-6EB0B611E867}"/>
               </a:ext>
             </a:extLst>
           </p:cNvPr>
@@ -20103,7 +20103,7 @@
           <p:cNvPr id="32" name="">
             <a:extLst xmlns:a="http://schemas.openxmlformats.org/drawingml/2006/main">
               <a:ext uri="{FF2B5EF4-FFF2-40B4-BE49-F238E27FC236}">
-                <a16:creationId xmlns:a16="http://schemas.microsoft.com/office/drawing/2014/main" id="{C231C5F4-5227-4FE3-BB37-2736F77BFED3}"/>
+                <a16:creationId xmlns:a16="http://schemas.microsoft.com/office/drawing/2014/main" id="{638CB789-3BE8-4D43-B0F0-6B97B2C081B6}"/>
               </a:ext>
             </a:extLst>
           </p:cNvPr>
@@ -20223,7 +20223,7 @@
           <p:cNvPr id="33" name="">
             <a:extLst xmlns:a="http://schemas.openxmlformats.org/drawingml/2006/main">
               <a:ext uri="{FF2B5EF4-FFF2-40B4-BE49-F238E27FC236}">
-                <a16:creationId xmlns:a16="http://schemas.microsoft.com/office/drawing/2014/main" id="{F63F69A2-BA44-44BD-AC26-BCC5C95742FB}"/>
+                <a16:creationId xmlns:a16="http://schemas.microsoft.com/office/drawing/2014/main" id="{024C1D1A-BF98-44CF-BF89-097A820EFF86}"/>
               </a:ext>
             </a:extLst>
           </p:cNvPr>
@@ -20341,7 +20341,7 @@
     </p:spTree>
     <p:extLst>
       <p:ext uri="{BB962C8B-B14F-4D97-AF65-F5344CB8AC3E}">
-        <p14:creationId xmlns:p14="http://schemas.microsoft.com/office/powerpoint/2010/main" val="1009029075"/>
+        <p14:creationId xmlns:p14="http://schemas.microsoft.com/office/powerpoint/2010/main" val="897020077"/>
       </p:ext>
     </p:extLst>
   </p:cSld>
@@ -20372,7 +20372,7 @@
           <p:cNvPr id="30" name="">
             <a:extLst xmlns:a="http://schemas.openxmlformats.org/drawingml/2006/main">
               <a:ext uri="{FF2B5EF4-FFF2-40B4-BE49-F238E27FC236}">
-                <a16:creationId xmlns:a16="http://schemas.microsoft.com/office/drawing/2014/main" id="{059721DC-62BC-467E-9462-C0F47796FC5B}"/>
+                <a16:creationId xmlns:a16="http://schemas.microsoft.com/office/drawing/2014/main" id="{D8BAB98F-CAD4-4F4F-B91C-649E0B2F8564}"/>
               </a:ext>
             </a:extLst>
           </p:cNvPr>
@@ -20492,7 +20492,7 @@
           <p:cNvPr id="2" name="">
             <a:extLst xmlns:a="http://schemas.openxmlformats.org/drawingml/2006/main">
               <a:ext uri="{FF2B5EF4-FFF2-40B4-BE49-F238E27FC236}">
-                <a16:creationId xmlns:a16="http://schemas.microsoft.com/office/drawing/2014/main" id="{BFA19F79-67C0-4B1A-ABB0-0E84DE2A5751}"/>
+                <a16:creationId xmlns:a16="http://schemas.microsoft.com/office/drawing/2014/main" id="{9B728309-BAE9-4BC8-8457-1657E1368E3D}"/>
               </a:ext>
             </a:extLst>
           </p:cNvPr>
@@ -20612,7 +20612,7 @@
           <p:cNvPr id="3" name="">
             <a:extLst xmlns:a="http://schemas.openxmlformats.org/drawingml/2006/main">
               <a:ext uri="{FF2B5EF4-FFF2-40B4-BE49-F238E27FC236}">
-                <a16:creationId xmlns:a16="http://schemas.microsoft.com/office/drawing/2014/main" id="{5FA81B5C-5C3E-48C5-BD85-D74C17D9F9D7}"/>
+                <a16:creationId xmlns:a16="http://schemas.microsoft.com/office/drawing/2014/main" id="{60E12BD0-9A60-4711-9B29-81260FF73850}"/>
               </a:ext>
             </a:extLst>
           </p:cNvPr>
@@ -20642,7 +20642,7 @@
           <p:cNvPr id="4" name="">
             <a:extLst xmlns:a="http://schemas.openxmlformats.org/drawingml/2006/main">
               <a:ext uri="{FF2B5EF4-FFF2-40B4-BE49-F238E27FC236}">
-                <a16:creationId xmlns:a16="http://schemas.microsoft.com/office/drawing/2014/main" id="{9ACDF365-D31B-445C-A0F5-A56DC4D8683F}"/>
+                <a16:creationId xmlns:a16="http://schemas.microsoft.com/office/drawing/2014/main" id="{71D17FF5-E5D6-4776-82F8-07A6C893CCCB}"/>
               </a:ext>
             </a:extLst>
           </p:cNvPr>
@@ -20672,7 +20672,7 @@
           <p:cNvPr id="5" name="">
             <a:extLst xmlns:a="http://schemas.openxmlformats.org/drawingml/2006/main">
               <a:ext uri="{FF2B5EF4-FFF2-40B4-BE49-F238E27FC236}">
-                <a16:creationId xmlns:a16="http://schemas.microsoft.com/office/drawing/2014/main" id="{4B9B69A5-FBCA-408C-81A4-8A7D28A8A16A}"/>
+                <a16:creationId xmlns:a16="http://schemas.microsoft.com/office/drawing/2014/main" id="{A92F4921-2F5C-4ABE-8B52-D680989839B4}"/>
               </a:ext>
             </a:extLst>
           </p:cNvPr>
@@ -20792,7 +20792,7 @@
           <p:cNvPr id="6" name="">
             <a:extLst xmlns:a="http://schemas.openxmlformats.org/drawingml/2006/main">
               <a:ext uri="{FF2B5EF4-FFF2-40B4-BE49-F238E27FC236}">
-                <a16:creationId xmlns:a16="http://schemas.microsoft.com/office/drawing/2014/main" id="{F437A0EF-E082-495E-9C2F-34CE3DF7175C}"/>
+                <a16:creationId xmlns:a16="http://schemas.microsoft.com/office/drawing/2014/main" id="{D3C5A769-1002-4370-8189-6A59D0A1CD71}"/>
               </a:ext>
             </a:extLst>
           </p:cNvPr>
@@ -20912,7 +20912,7 @@
           <p:cNvPr id="7" name="">
             <a:extLst xmlns:a="http://schemas.openxmlformats.org/drawingml/2006/main">
               <a:ext uri="{FF2B5EF4-FFF2-40B4-BE49-F238E27FC236}">
-                <a16:creationId xmlns:a16="http://schemas.microsoft.com/office/drawing/2014/main" id="{F10EBFAB-11EE-4653-8315-6349C9E02062}"/>
+                <a16:creationId xmlns:a16="http://schemas.microsoft.com/office/drawing/2014/main" id="{EEEE67D9-BFEE-4864-8C29-36033EBA84FA}"/>
               </a:ext>
             </a:extLst>
           </p:cNvPr>
@@ -21032,7 +21032,7 @@
           <p:cNvPr id="8" name="">
             <a:extLst xmlns:a="http://schemas.openxmlformats.org/drawingml/2006/main">
               <a:ext uri="{FF2B5EF4-FFF2-40B4-BE49-F238E27FC236}">
-                <a16:creationId xmlns:a16="http://schemas.microsoft.com/office/drawing/2014/main" id="{5E3D2D2F-F6A0-40B7-8B70-D820C4FF91A8}"/>
+                <a16:creationId xmlns:a16="http://schemas.microsoft.com/office/drawing/2014/main" id="{4732CCCE-2F5F-4B9E-93DC-A02D607E702C}"/>
               </a:ext>
             </a:extLst>
           </p:cNvPr>
@@ -21062,7 +21062,7 @@
           <p:cNvPr id="9" name="">
             <a:extLst xmlns:a="http://schemas.openxmlformats.org/drawingml/2006/main">
               <a:ext uri="{FF2B5EF4-FFF2-40B4-BE49-F238E27FC236}">
-                <a16:creationId xmlns:a16="http://schemas.microsoft.com/office/drawing/2014/main" id="{FB83670A-E200-4439-B614-195AC12D01CA}"/>
+                <a16:creationId xmlns:a16="http://schemas.microsoft.com/office/drawing/2014/main" id="{35268BD8-A31E-4CB0-BDF1-8E436FA0F3C6}"/>
               </a:ext>
             </a:extLst>
           </p:cNvPr>
@@ -21182,7 +21182,7 @@
           <p:cNvPr id="10" name="">
             <a:extLst xmlns:a="http://schemas.openxmlformats.org/drawingml/2006/main">
               <a:ext uri="{FF2B5EF4-FFF2-40B4-BE49-F238E27FC236}">
-                <a16:creationId xmlns:a16="http://schemas.microsoft.com/office/drawing/2014/main" id="{BCB23053-029C-4210-8748-573E654B8776}"/>
+                <a16:creationId xmlns:a16="http://schemas.microsoft.com/office/drawing/2014/main" id="{74BA983C-2674-4540-8681-A3E3E2AF4E5F}"/>
               </a:ext>
             </a:extLst>
           </p:cNvPr>
@@ -21302,7 +21302,7 @@
           <p:cNvPr id="11" name="">
             <a:extLst xmlns:a="http://schemas.openxmlformats.org/drawingml/2006/main">
               <a:ext uri="{FF2B5EF4-FFF2-40B4-BE49-F238E27FC236}">
-                <a16:creationId xmlns:a16="http://schemas.microsoft.com/office/drawing/2014/main" id="{259066F5-5E9D-43E2-BB4F-6F2C3B94CCEF}"/>
+                <a16:creationId xmlns:a16="http://schemas.microsoft.com/office/drawing/2014/main" id="{43E29E3A-0C41-4403-AEF7-7F2A87ED010F}"/>
               </a:ext>
             </a:extLst>
           </p:cNvPr>
@@ -21422,7 +21422,7 @@
           <p:cNvPr id="12" name="">
             <a:extLst xmlns:a="http://schemas.openxmlformats.org/drawingml/2006/main">
               <a:ext uri="{FF2B5EF4-FFF2-40B4-BE49-F238E27FC236}">
-                <a16:creationId xmlns:a16="http://schemas.microsoft.com/office/drawing/2014/main" id="{912BBB3D-928D-4B42-83FA-DB462B912BD3}"/>
+                <a16:creationId xmlns:a16="http://schemas.microsoft.com/office/drawing/2014/main" id="{E40F0391-801D-4C11-8733-EC5B9CE3BFF2}"/>
               </a:ext>
             </a:extLst>
           </p:cNvPr>
@@ -21452,7 +21452,7 @@
           <p:cNvPr id="13" name="">
             <a:extLst xmlns:a="http://schemas.openxmlformats.org/drawingml/2006/main">
               <a:ext uri="{FF2B5EF4-FFF2-40B4-BE49-F238E27FC236}">
-                <a16:creationId xmlns:a16="http://schemas.microsoft.com/office/drawing/2014/main" id="{02C1F2E6-571D-4047-859F-1C13F7A78FC9}"/>
+                <a16:creationId xmlns:a16="http://schemas.microsoft.com/office/drawing/2014/main" id="{432D8856-F699-408E-AB30-28E3FB013CAB}"/>
               </a:ext>
             </a:extLst>
           </p:cNvPr>
@@ -21572,7 +21572,7 @@
           <p:cNvPr id="14" name="">
             <a:extLst xmlns:a="http://schemas.openxmlformats.org/drawingml/2006/main">
               <a:ext uri="{FF2B5EF4-FFF2-40B4-BE49-F238E27FC236}">
-                <a16:creationId xmlns:a16="http://schemas.microsoft.com/office/drawing/2014/main" id="{CC8D6977-BE6D-4C1C-BC65-3C36B858D77E}"/>
+                <a16:creationId xmlns:a16="http://schemas.microsoft.com/office/drawing/2014/main" id="{C7F58C29-1C28-4545-BC55-71A4430294F8}"/>
               </a:ext>
             </a:extLst>
           </p:cNvPr>
@@ -21692,7 +21692,7 @@
           <p:cNvPr id="15" name="">
             <a:extLst xmlns:a="http://schemas.openxmlformats.org/drawingml/2006/main">
               <a:ext uri="{FF2B5EF4-FFF2-40B4-BE49-F238E27FC236}">
-                <a16:creationId xmlns:a16="http://schemas.microsoft.com/office/drawing/2014/main" id="{58C66EE6-5C40-4C56-9198-9BB4EA7933C9}"/>
+                <a16:creationId xmlns:a16="http://schemas.microsoft.com/office/drawing/2014/main" id="{B95E0D5B-9488-4414-AA27-5DE01C07E148}"/>
               </a:ext>
             </a:extLst>
           </p:cNvPr>
@@ -21812,7 +21812,7 @@
           <p:cNvPr id="16" name="">
             <a:extLst xmlns:a="http://schemas.openxmlformats.org/drawingml/2006/main">
               <a:ext uri="{FF2B5EF4-FFF2-40B4-BE49-F238E27FC236}">
-                <a16:creationId xmlns:a16="http://schemas.microsoft.com/office/drawing/2014/main" id="{8374CE1C-D37E-4CBA-8E8C-6CD1B1AFBEA2}"/>
+                <a16:creationId xmlns:a16="http://schemas.microsoft.com/office/drawing/2014/main" id="{D60AD835-EE58-4FB7-9464-FB04BBA8CFDC}"/>
               </a:ext>
             </a:extLst>
           </p:cNvPr>
@@ -21842,7 +21842,7 @@
           <p:cNvPr id="17" name="">
             <a:extLst xmlns:a="http://schemas.openxmlformats.org/drawingml/2006/main">
               <a:ext uri="{FF2B5EF4-FFF2-40B4-BE49-F238E27FC236}">
-                <a16:creationId xmlns:a16="http://schemas.microsoft.com/office/drawing/2014/main" id="{6851719A-52F5-4D2D-9365-C4C263A12264}"/>
+                <a16:creationId xmlns:a16="http://schemas.microsoft.com/office/drawing/2014/main" id="{EC743B09-81C6-40CB-A5BE-D27A4BDD4695}"/>
               </a:ext>
             </a:extLst>
           </p:cNvPr>
@@ -21962,7 +21962,7 @@
           <p:cNvPr id="18" name="">
             <a:extLst xmlns:a="http://schemas.openxmlformats.org/drawingml/2006/main">
               <a:ext uri="{FF2B5EF4-FFF2-40B4-BE49-F238E27FC236}">
-                <a16:creationId xmlns:a16="http://schemas.microsoft.com/office/drawing/2014/main" id="{E82544F2-9E58-4A4F-A184-EFD48495A2FE}"/>
+                <a16:creationId xmlns:a16="http://schemas.microsoft.com/office/drawing/2014/main" id="{F67A10BB-08EA-46C9-89BF-CACE936AD813}"/>
               </a:ext>
             </a:extLst>
           </p:cNvPr>
@@ -22082,7 +22082,7 @@
           <p:cNvPr id="19" name="">
             <a:extLst xmlns:a="http://schemas.openxmlformats.org/drawingml/2006/main">
               <a:ext uri="{FF2B5EF4-FFF2-40B4-BE49-F238E27FC236}">
-                <a16:creationId xmlns:a16="http://schemas.microsoft.com/office/drawing/2014/main" id="{6E097EFF-BA54-4AB3-8D2A-D38CB2820B58}"/>
+                <a16:creationId xmlns:a16="http://schemas.microsoft.com/office/drawing/2014/main" id="{1E141799-2DBE-40AF-A7E7-AAB7D450B9C5}"/>
               </a:ext>
             </a:extLst>
           </p:cNvPr>
@@ -22202,7 +22202,7 @@
           <p:cNvPr id="20" name="">
             <a:extLst xmlns:a="http://schemas.openxmlformats.org/drawingml/2006/main">
               <a:ext uri="{FF2B5EF4-FFF2-40B4-BE49-F238E27FC236}">
-                <a16:creationId xmlns:a16="http://schemas.microsoft.com/office/drawing/2014/main" id="{DCFAE3F9-4DC1-4585-9BBE-26EBDE461AB6}"/>
+                <a16:creationId xmlns:a16="http://schemas.microsoft.com/office/drawing/2014/main" id="{3B84F3B8-2006-436E-B255-8334681BACA3}"/>
               </a:ext>
             </a:extLst>
           </p:cNvPr>
@@ -22232,7 +22232,7 @@
           <p:cNvPr id="21" name="">
             <a:extLst xmlns:a="http://schemas.openxmlformats.org/drawingml/2006/main">
               <a:ext uri="{FF2B5EF4-FFF2-40B4-BE49-F238E27FC236}">
-                <a16:creationId xmlns:a16="http://schemas.microsoft.com/office/drawing/2014/main" id="{73659A8B-EBB1-4CE8-AB36-DFB149A90666}"/>
+                <a16:creationId xmlns:a16="http://schemas.microsoft.com/office/drawing/2014/main" id="{29F79DF3-31A9-4DFD-9A2F-F6C3A766A14E}"/>
               </a:ext>
             </a:extLst>
           </p:cNvPr>
@@ -22352,7 +22352,7 @@
           <p:cNvPr id="22" name="">
             <a:extLst xmlns:a="http://schemas.openxmlformats.org/drawingml/2006/main">
               <a:ext uri="{FF2B5EF4-FFF2-40B4-BE49-F238E27FC236}">
-                <a16:creationId xmlns:a16="http://schemas.microsoft.com/office/drawing/2014/main" id="{4D36860B-D55C-4DC2-9D7E-A11A39D53581}"/>
+                <a16:creationId xmlns:a16="http://schemas.microsoft.com/office/drawing/2014/main" id="{1BEDE028-4559-4E19-A4A6-2B09B190F2E9}"/>
               </a:ext>
             </a:extLst>
           </p:cNvPr>
@@ -22472,7 +22472,7 @@
           <p:cNvPr id="23" name="">
             <a:extLst xmlns:a="http://schemas.openxmlformats.org/drawingml/2006/main">
               <a:ext uri="{FF2B5EF4-FFF2-40B4-BE49-F238E27FC236}">
-                <a16:creationId xmlns:a16="http://schemas.microsoft.com/office/drawing/2014/main" id="{275A9511-632E-402E-8783-C824409E47E8}"/>
+                <a16:creationId xmlns:a16="http://schemas.microsoft.com/office/drawing/2014/main" id="{79CFCA32-79AC-4C5B-93C6-26C1B2B02516}"/>
               </a:ext>
             </a:extLst>
           </p:cNvPr>
@@ -22592,7 +22592,7 @@
           <p:cNvPr id="24" name="">
             <a:extLst xmlns:a="http://schemas.openxmlformats.org/drawingml/2006/main">
               <a:ext uri="{FF2B5EF4-FFF2-40B4-BE49-F238E27FC236}">
-                <a16:creationId xmlns:a16="http://schemas.microsoft.com/office/drawing/2014/main" id="{5D1E4E26-3160-41A8-ABB1-91875AC07268}"/>
+                <a16:creationId xmlns:a16="http://schemas.microsoft.com/office/drawing/2014/main" id="{8F389A87-82A6-4884-A48F-7D60330B6C82}"/>
               </a:ext>
             </a:extLst>
           </p:cNvPr>
@@ -22622,7 +22622,7 @@
           <p:cNvPr id="25" name="">
             <a:extLst xmlns:a="http://schemas.openxmlformats.org/drawingml/2006/main">
               <a:ext uri="{FF2B5EF4-FFF2-40B4-BE49-F238E27FC236}">
-                <a16:creationId xmlns:a16="http://schemas.microsoft.com/office/drawing/2014/main" id="{1B5302C1-34F3-444D-8118-6D3EE1CAC2D3}"/>
+                <a16:creationId xmlns:a16="http://schemas.microsoft.com/office/drawing/2014/main" id="{5D936409-C948-4E68-A920-B7C3F3526325}"/>
               </a:ext>
             </a:extLst>
           </p:cNvPr>
@@ -22742,7 +22742,7 @@
           <p:cNvPr id="26" name="">
             <a:extLst xmlns:a="http://schemas.openxmlformats.org/drawingml/2006/main">
               <a:ext uri="{FF2B5EF4-FFF2-40B4-BE49-F238E27FC236}">
-                <a16:creationId xmlns:a16="http://schemas.microsoft.com/office/drawing/2014/main" id="{1AAA62FD-695C-4144-86EB-F6811F34C029}"/>
+                <a16:creationId xmlns:a16="http://schemas.microsoft.com/office/drawing/2014/main" id="{96652472-FACC-4C02-A7B8-B564053B4A0E}"/>
               </a:ext>
             </a:extLst>
           </p:cNvPr>
@@ -22862,7 +22862,7 @@
           <p:cNvPr id="27" name="">
             <a:extLst xmlns:a="http://schemas.openxmlformats.org/drawingml/2006/main">
               <a:ext uri="{FF2B5EF4-FFF2-40B4-BE49-F238E27FC236}">
-                <a16:creationId xmlns:a16="http://schemas.microsoft.com/office/drawing/2014/main" id="{0D7C65F2-471D-4A11-9E77-32C6B28ADAD8}"/>
+                <a16:creationId xmlns:a16="http://schemas.microsoft.com/office/drawing/2014/main" id="{B6EABD09-10DD-4B7D-B0CF-126A8ECB1663}"/>
               </a:ext>
             </a:extLst>
           </p:cNvPr>
@@ -22982,7 +22982,7 @@
           <p:cNvPr id="28" name="">
             <a:extLst xmlns:a="http://schemas.openxmlformats.org/drawingml/2006/main">
               <a:ext uri="{FF2B5EF4-FFF2-40B4-BE49-F238E27FC236}">
-                <a16:creationId xmlns:a16="http://schemas.microsoft.com/office/drawing/2014/main" id="{9725098F-A6DB-46A0-B288-239FF00B16FD}"/>
+                <a16:creationId xmlns:a16="http://schemas.microsoft.com/office/drawing/2014/main" id="{7D517D57-F6E1-421D-A9F2-9E310853A599}"/>
               </a:ext>
             </a:extLst>
           </p:cNvPr>
@@ -23102,7 +23102,7 @@
           <p:cNvPr id="29" name="">
             <a:extLst xmlns:a="http://schemas.openxmlformats.org/drawingml/2006/main">
               <a:ext uri="{FF2B5EF4-FFF2-40B4-BE49-F238E27FC236}">
-                <a16:creationId xmlns:a16="http://schemas.microsoft.com/office/drawing/2014/main" id="{1E67D4CE-02DB-4161-98E2-13D0EFD03784}"/>
+                <a16:creationId xmlns:a16="http://schemas.microsoft.com/office/drawing/2014/main" id="{A686852C-AC78-463B-A8BB-AD1950C13D4D}"/>
               </a:ext>
             </a:extLst>
           </p:cNvPr>
@@ -23220,7 +23220,7 @@
     </p:spTree>
     <p:extLst>
       <p:ext uri="{BB962C8B-B14F-4D97-AF65-F5344CB8AC3E}">
-        <p14:creationId xmlns:p14="http://schemas.microsoft.com/office/powerpoint/2010/main" val="1759567320"/>
+        <p14:creationId xmlns:p14="http://schemas.microsoft.com/office/powerpoint/2010/main" val="1744664076"/>
       </p:ext>
     </p:extLst>
   </p:cSld>
@@ -23251,7 +23251,7 @@
           <p:cNvPr id="21" name="">
             <a:extLst xmlns:a="http://schemas.openxmlformats.org/drawingml/2006/main">
               <a:ext uri="{FF2B5EF4-FFF2-40B4-BE49-F238E27FC236}">
-                <a16:creationId xmlns:a16="http://schemas.microsoft.com/office/drawing/2014/main" id="{5920EEE7-08A3-4E47-9BE3-927A151B28EF}"/>
+                <a16:creationId xmlns:a16="http://schemas.microsoft.com/office/drawing/2014/main" id="{1BCD42C5-BF9D-402C-A8A2-BCF66AE75884}"/>
               </a:ext>
             </a:extLst>
           </p:cNvPr>
@@ -23371,7 +23371,7 @@
           <p:cNvPr id="2" name="">
             <a:extLst xmlns:a="http://schemas.openxmlformats.org/drawingml/2006/main">
               <a:ext uri="{FF2B5EF4-FFF2-40B4-BE49-F238E27FC236}">
-                <a16:creationId xmlns:a16="http://schemas.microsoft.com/office/drawing/2014/main" id="{F988BACB-060E-471F-8B3D-A2A26419CDFE}"/>
+                <a16:creationId xmlns:a16="http://schemas.microsoft.com/office/drawing/2014/main" id="{AFFE5C3E-7C59-4655-8F41-169D644CEFE5}"/>
               </a:ext>
             </a:extLst>
           </p:cNvPr>
@@ -23491,7 +23491,7 @@
           <p:cNvPr id="3" name="">
             <a:extLst xmlns:a="http://schemas.openxmlformats.org/drawingml/2006/main">
               <a:ext uri="{FF2B5EF4-FFF2-40B4-BE49-F238E27FC236}">
-                <a16:creationId xmlns:a16="http://schemas.microsoft.com/office/drawing/2014/main" id="{322B9D1E-F715-4D2E-815D-384D70555566}"/>
+                <a16:creationId xmlns:a16="http://schemas.microsoft.com/office/drawing/2014/main" id="{27B1D5A4-C336-4A5E-B1EB-27B5309A571A}"/>
               </a:ext>
             </a:extLst>
           </p:cNvPr>
@@ -23521,7 +23521,7 @@
           <p:cNvPr id="4" name="">
             <a:extLst xmlns:a="http://schemas.openxmlformats.org/drawingml/2006/main">
               <a:ext uri="{FF2B5EF4-FFF2-40B4-BE49-F238E27FC236}">
-                <a16:creationId xmlns:a16="http://schemas.microsoft.com/office/drawing/2014/main" id="{2C766186-3DDA-447A-B489-6BF6717ACEAE}"/>
+                <a16:creationId xmlns:a16="http://schemas.microsoft.com/office/drawing/2014/main" id="{48D4E33C-AB46-4BD5-AE28-B9C704C5A348}"/>
               </a:ext>
             </a:extLst>
           </p:cNvPr>
@@ -23641,7 +23641,7 @@
           <p:cNvPr id="5" name="">
             <a:extLst xmlns:a="http://schemas.openxmlformats.org/drawingml/2006/main">
               <a:ext uri="{FF2B5EF4-FFF2-40B4-BE49-F238E27FC236}">
-                <a16:creationId xmlns:a16="http://schemas.microsoft.com/office/drawing/2014/main" id="{8D50D16C-C731-4567-89C1-524E7BA8D882}"/>
+                <a16:creationId xmlns:a16="http://schemas.microsoft.com/office/drawing/2014/main" id="{4F1824D0-5AFE-4152-A4EF-3D5D4D647A79}"/>
               </a:ext>
             </a:extLst>
           </p:cNvPr>
@@ -23761,7 +23761,7 @@
           <p:cNvPr id="6" name="">
             <a:extLst xmlns:a="http://schemas.openxmlformats.org/drawingml/2006/main">
               <a:ext uri="{FF2B5EF4-FFF2-40B4-BE49-F238E27FC236}">
-                <a16:creationId xmlns:a16="http://schemas.microsoft.com/office/drawing/2014/main" id="{0E1575BF-4321-4EF5-8651-0C332E561DEB}"/>
+                <a16:creationId xmlns:a16="http://schemas.microsoft.com/office/drawing/2014/main" id="{DEBF0F13-75D7-44E7-AB01-506740D6319F}"/>
               </a:ext>
             </a:extLst>
           </p:cNvPr>
@@ -23881,7 +23881,7 @@
           <p:cNvPr id="7" name="">
             <a:extLst xmlns:a="http://schemas.openxmlformats.org/drawingml/2006/main">
               <a:ext uri="{FF2B5EF4-FFF2-40B4-BE49-F238E27FC236}">
-                <a16:creationId xmlns:a16="http://schemas.microsoft.com/office/drawing/2014/main" id="{12376464-FDAB-4C4C-B6B4-E42C18AC114F}"/>
+                <a16:creationId xmlns:a16="http://schemas.microsoft.com/office/drawing/2014/main" id="{9454973C-B937-47B8-8766-3C8256BEDC58}"/>
               </a:ext>
             </a:extLst>
           </p:cNvPr>
@@ -24001,7 +24001,7 @@
           <p:cNvPr id="8" name="">
             <a:extLst xmlns:a="http://schemas.openxmlformats.org/drawingml/2006/main">
               <a:ext uri="{FF2B5EF4-FFF2-40B4-BE49-F238E27FC236}">
-                <a16:creationId xmlns:a16="http://schemas.microsoft.com/office/drawing/2014/main" id="{B2B40DE0-FD04-4032-BEDA-60D44B06D928}"/>
+                <a16:creationId xmlns:a16="http://schemas.microsoft.com/office/drawing/2014/main" id="{97CE3D76-7633-4BAE-96FB-414DB7A01FDB}"/>
               </a:ext>
             </a:extLst>
           </p:cNvPr>
@@ -24121,7 +24121,7 @@
           <p:cNvPr id="9" name="">
             <a:extLst xmlns:a="http://schemas.openxmlformats.org/drawingml/2006/main">
               <a:ext uri="{FF2B5EF4-FFF2-40B4-BE49-F238E27FC236}">
-                <a16:creationId xmlns:a16="http://schemas.microsoft.com/office/drawing/2014/main" id="{E1019C16-AC0B-4B98-8FAA-BA3F1F0D8A3F}"/>
+                <a16:creationId xmlns:a16="http://schemas.microsoft.com/office/drawing/2014/main" id="{8458B26A-2D37-42C7-87CF-8141E026947C}"/>
               </a:ext>
             </a:extLst>
           </p:cNvPr>
@@ -24241,7 +24241,7 @@
           <p:cNvPr id="10" name="">
             <a:extLst xmlns:a="http://schemas.openxmlformats.org/drawingml/2006/main">
               <a:ext uri="{FF2B5EF4-FFF2-40B4-BE49-F238E27FC236}">
-                <a16:creationId xmlns:a16="http://schemas.microsoft.com/office/drawing/2014/main" id="{43A922B3-5A0D-47C0-B3BC-05F34B04DB29}"/>
+                <a16:creationId xmlns:a16="http://schemas.microsoft.com/office/drawing/2014/main" id="{607EDDE0-7D9B-4F60-8423-4093E81D752C}"/>
               </a:ext>
             </a:extLst>
           </p:cNvPr>
@@ -24361,7 +24361,7 @@
           <p:cNvPr id="11" name="">
             <a:extLst xmlns:a="http://schemas.openxmlformats.org/drawingml/2006/main">
               <a:ext uri="{FF2B5EF4-FFF2-40B4-BE49-F238E27FC236}">
-                <a16:creationId xmlns:a16="http://schemas.microsoft.com/office/drawing/2014/main" id="{577B9F8B-6DE1-4F9C-92ED-4EA89EE8D867}"/>
+                <a16:creationId xmlns:a16="http://schemas.microsoft.com/office/drawing/2014/main" id="{0683CC97-9D2C-4738-B0DE-CC47A3E4CB83}"/>
               </a:ext>
             </a:extLst>
           </p:cNvPr>
@@ -24481,7 +24481,7 @@
           <p:cNvPr id="12" name="">
             <a:extLst xmlns:a="http://schemas.openxmlformats.org/drawingml/2006/main">
               <a:ext uri="{FF2B5EF4-FFF2-40B4-BE49-F238E27FC236}">
-                <a16:creationId xmlns:a16="http://schemas.microsoft.com/office/drawing/2014/main" id="{9DB85181-3B1D-494D-9328-18B79D552828}"/>
+                <a16:creationId xmlns:a16="http://schemas.microsoft.com/office/drawing/2014/main" id="{36FB07C8-6870-434A-A594-C4A84D11C997}"/>
               </a:ext>
             </a:extLst>
           </p:cNvPr>
@@ -24601,7 +24601,7 @@
           <p:cNvPr id="13" name="">
             <a:extLst xmlns:a="http://schemas.openxmlformats.org/drawingml/2006/main">
               <a:ext uri="{FF2B5EF4-FFF2-40B4-BE49-F238E27FC236}">
-                <a16:creationId xmlns:a16="http://schemas.microsoft.com/office/drawing/2014/main" id="{8A49CC82-FC03-48EF-91D7-B9794395B80C}"/>
+                <a16:creationId xmlns:a16="http://schemas.microsoft.com/office/drawing/2014/main" id="{350A71D5-763B-46E1-90F9-67DC80349993}"/>
               </a:ext>
             </a:extLst>
           </p:cNvPr>
@@ -24721,7 +24721,7 @@
           <p:cNvPr id="14" name="">
             <a:extLst xmlns:a="http://schemas.openxmlformats.org/drawingml/2006/main">
               <a:ext uri="{FF2B5EF4-FFF2-40B4-BE49-F238E27FC236}">
-                <a16:creationId xmlns:a16="http://schemas.microsoft.com/office/drawing/2014/main" id="{0FADB41F-3D04-4B8E-B6A4-0319D0C1D5C5}"/>
+                <a16:creationId xmlns:a16="http://schemas.microsoft.com/office/drawing/2014/main" id="{92208222-09EF-4719-AF5C-9F403F0077C0}"/>
               </a:ext>
             </a:extLst>
           </p:cNvPr>
@@ -24841,7 +24841,7 @@
           <p:cNvPr id="15" name="">
             <a:extLst xmlns:a="http://schemas.openxmlformats.org/drawingml/2006/main">
               <a:ext uri="{FF2B5EF4-FFF2-40B4-BE49-F238E27FC236}">
-                <a16:creationId xmlns:a16="http://schemas.microsoft.com/office/drawing/2014/main" id="{2E846C77-9C1F-4583-B512-5395A8A3AEC2}"/>
+                <a16:creationId xmlns:a16="http://schemas.microsoft.com/office/drawing/2014/main" id="{3DC6D295-365C-4525-BF9E-9795F7BFFD06}"/>
               </a:ext>
             </a:extLst>
           </p:cNvPr>
@@ -24961,7 +24961,7 @@
           <p:cNvPr id="16" name="">
             <a:extLst xmlns:a="http://schemas.openxmlformats.org/drawingml/2006/main">
               <a:ext uri="{FF2B5EF4-FFF2-40B4-BE49-F238E27FC236}">
-                <a16:creationId xmlns:a16="http://schemas.microsoft.com/office/drawing/2014/main" id="{6DF5AD29-D576-4616-97F9-FA9EF4BB1029}"/>
+                <a16:creationId xmlns:a16="http://schemas.microsoft.com/office/drawing/2014/main" id="{5D1F1871-73E5-49D1-8519-2141324FE72E}"/>
               </a:ext>
             </a:extLst>
           </p:cNvPr>
@@ -25081,7 +25081,7 @@
           <p:cNvPr id="17" name="">
             <a:extLst xmlns:a="http://schemas.openxmlformats.org/drawingml/2006/main">
               <a:ext uri="{FF2B5EF4-FFF2-40B4-BE49-F238E27FC236}">
-                <a16:creationId xmlns:a16="http://schemas.microsoft.com/office/drawing/2014/main" id="{F0E02027-F095-4C3D-8413-68F86276681B}"/>
+                <a16:creationId xmlns:a16="http://schemas.microsoft.com/office/drawing/2014/main" id="{CD11E74A-C6EE-4081-9539-F9447A97AA32}"/>
               </a:ext>
             </a:extLst>
           </p:cNvPr>
@@ -25201,7 +25201,7 @@
           <p:cNvPr id="18" name="">
             <a:extLst xmlns:a="http://schemas.openxmlformats.org/drawingml/2006/main">
               <a:ext uri="{FF2B5EF4-FFF2-40B4-BE49-F238E27FC236}">
-                <a16:creationId xmlns:a16="http://schemas.microsoft.com/office/drawing/2014/main" id="{77EFE355-655A-492C-9961-77BB7B9184EC}"/>
+                <a16:creationId xmlns:a16="http://schemas.microsoft.com/office/drawing/2014/main" id="{BA486E9E-528F-4A7C-A5C5-48294EA1535C}"/>
               </a:ext>
             </a:extLst>
           </p:cNvPr>
@@ -25321,7 +25321,7 @@
           <p:cNvPr id="19" name="">
             <a:extLst xmlns:a="http://schemas.openxmlformats.org/drawingml/2006/main">
               <a:ext uri="{FF2B5EF4-FFF2-40B4-BE49-F238E27FC236}">
-                <a16:creationId xmlns:a16="http://schemas.microsoft.com/office/drawing/2014/main" id="{3D11C883-C8F2-473D-905A-AE6C1AB48A3C}"/>
+                <a16:creationId xmlns:a16="http://schemas.microsoft.com/office/drawing/2014/main" id="{9A57C1EF-C71A-4F90-857E-871178DCAB3A}"/>
               </a:ext>
             </a:extLst>
           </p:cNvPr>
@@ -25441,7 +25441,7 @@
           <p:cNvPr id="20" name="">
             <a:extLst xmlns:a="http://schemas.openxmlformats.org/drawingml/2006/main">
               <a:ext uri="{FF2B5EF4-FFF2-40B4-BE49-F238E27FC236}">
-                <a16:creationId xmlns:a16="http://schemas.microsoft.com/office/drawing/2014/main" id="{197000DE-B78C-4790-848E-58AC294B00DD}"/>
+                <a16:creationId xmlns:a16="http://schemas.microsoft.com/office/drawing/2014/main" id="{B5849552-E65F-4FD7-AD21-42B3247A296B}"/>
               </a:ext>
             </a:extLst>
           </p:cNvPr>
@@ -25559,7 +25559,7 @@
     </p:spTree>
     <p:extLst>
       <p:ext uri="{BB962C8B-B14F-4D97-AF65-F5344CB8AC3E}">
-        <p14:creationId xmlns:p14="http://schemas.microsoft.com/office/powerpoint/2010/main" val="900764433"/>
+        <p14:creationId xmlns:p14="http://schemas.microsoft.com/office/powerpoint/2010/main" val="491148490"/>
       </p:ext>
     </p:extLst>
   </p:cSld>
@@ -25590,7 +25590,7 @@
           <p:cNvPr id="7" name="">
             <a:extLst xmlns:a="http://schemas.openxmlformats.org/drawingml/2006/main">
               <a:ext uri="{FF2B5EF4-FFF2-40B4-BE49-F238E27FC236}">
-                <a16:creationId xmlns:a16="http://schemas.microsoft.com/office/drawing/2014/main" id="{195B1EFE-2FB2-4630-AEE2-68459F4D3E08}"/>
+                <a16:creationId xmlns:a16="http://schemas.microsoft.com/office/drawing/2014/main" id="{359F5EF1-51BA-47BA-B70E-AAC6326FC4FA}"/>
               </a:ext>
             </a:extLst>
           </p:cNvPr>
@@ -25600,7 +25600,7 @@
           <p:nvPr/>
         </p:nvPicPr>
         <p:blipFill>
-          <a:blip xmlns:r="http://schemas.openxmlformats.org/officeDocument/2006/relationships" xmlns:a="http://schemas.openxmlformats.org/drawingml/2006/main" r:embed="R091b05fdd4534973"/>
+          <a:blip xmlns:r="http://schemas.openxmlformats.org/officeDocument/2006/relationships" xmlns:a="http://schemas.openxmlformats.org/drawingml/2006/main" r:embed="Rb777284d512842f3"/>
           <a:stretch xmlns:a="http://schemas.openxmlformats.org/drawingml/2006/main"/>
         </p:blipFill>
         <p:spPr>
@@ -25618,7 +25618,7 @@
           <p:cNvPr id="2" name="">
             <a:extLst xmlns:a="http://schemas.openxmlformats.org/drawingml/2006/main">
               <a:ext uri="{FF2B5EF4-FFF2-40B4-BE49-F238E27FC236}">
-                <a16:creationId xmlns:a16="http://schemas.microsoft.com/office/drawing/2014/main" id="{A093C9C5-FF36-4D93-94BF-756DF6EAB822}"/>
+                <a16:creationId xmlns:a16="http://schemas.microsoft.com/office/drawing/2014/main" id="{410222B4-CEA8-493B-B36C-36DC408594DA}"/>
               </a:ext>
             </a:extLst>
           </p:cNvPr>
@@ -25738,7 +25738,7 @@
           <p:cNvPr id="3" name="">
             <a:extLst xmlns:a="http://schemas.openxmlformats.org/drawingml/2006/main">
               <a:ext uri="{FF2B5EF4-FFF2-40B4-BE49-F238E27FC236}">
-                <a16:creationId xmlns:a16="http://schemas.microsoft.com/office/drawing/2014/main" id="{3DCE4D8D-4F4E-437A-A306-1F384D2F9E69}"/>
+                <a16:creationId xmlns:a16="http://schemas.microsoft.com/office/drawing/2014/main" id="{0D769E8D-E523-4185-B76A-2C84D2BEC6A1}"/>
               </a:ext>
             </a:extLst>
           </p:cNvPr>
@@ -25858,7 +25858,7 @@
           <p:cNvPr id="4" name="">
             <a:extLst xmlns:a="http://schemas.openxmlformats.org/drawingml/2006/main">
               <a:ext uri="{FF2B5EF4-FFF2-40B4-BE49-F238E27FC236}">
-                <a16:creationId xmlns:a16="http://schemas.microsoft.com/office/drawing/2014/main" id="{2638698B-3891-4948-852B-BDCED9083728}"/>
+                <a16:creationId xmlns:a16="http://schemas.microsoft.com/office/drawing/2014/main" id="{86838CE4-B5FF-425C-BF7F-3BEBBC041D75}"/>
               </a:ext>
             </a:extLst>
           </p:cNvPr>
@@ -25978,7 +25978,7 @@
           <p:cNvPr id="5" name="">
             <a:extLst xmlns:a="http://schemas.openxmlformats.org/drawingml/2006/main">
               <a:ext uri="{FF2B5EF4-FFF2-40B4-BE49-F238E27FC236}">
-                <a16:creationId xmlns:a16="http://schemas.microsoft.com/office/drawing/2014/main" id="{59C436C9-67F7-4D07-BD5A-AEF48B61B59A}"/>
+                <a16:creationId xmlns:a16="http://schemas.microsoft.com/office/drawing/2014/main" id="{9DDFF537-3BC5-475C-9385-4B058FC47E01}"/>
               </a:ext>
             </a:extLst>
           </p:cNvPr>
@@ -26149,7 +26149,7 @@
           <p:cNvPr id="6" name="">
             <a:extLst xmlns:a="http://schemas.openxmlformats.org/drawingml/2006/main">
               <a:ext uri="{FF2B5EF4-FFF2-40B4-BE49-F238E27FC236}">
-                <a16:creationId xmlns:a16="http://schemas.microsoft.com/office/drawing/2014/main" id="{27D66562-3206-460C-80B8-5D80431AC78D}"/>
+                <a16:creationId xmlns:a16="http://schemas.microsoft.com/office/drawing/2014/main" id="{CCEC4874-60BB-469C-AD25-FA326A8A4FE5}"/>
               </a:ext>
             </a:extLst>
           </p:cNvPr>
@@ -26267,7 +26267,7 @@
     </p:spTree>
     <p:extLst>
       <p:ext uri="{BB962C8B-B14F-4D97-AF65-F5344CB8AC3E}">
-        <p14:creationId xmlns:p14="http://schemas.microsoft.com/office/powerpoint/2010/main" val="1867432298"/>
+        <p14:creationId xmlns:p14="http://schemas.microsoft.com/office/powerpoint/2010/main" val="534087606"/>
       </p:ext>
     </p:extLst>
   </p:cSld>
@@ -26298,7 +26298,7 @@
           <p:cNvPr id="41" name="">
             <a:extLst xmlns:a="http://schemas.openxmlformats.org/drawingml/2006/main">
               <a:ext uri="{FF2B5EF4-FFF2-40B4-BE49-F238E27FC236}">
-                <a16:creationId xmlns:a16="http://schemas.microsoft.com/office/drawing/2014/main" id="{F0C34250-1CC5-498E-B794-F2CB8BEC69D0}"/>
+                <a16:creationId xmlns:a16="http://schemas.microsoft.com/office/drawing/2014/main" id="{17ED4BCA-70EE-4343-8BD2-D98B474B3550}"/>
               </a:ext>
             </a:extLst>
           </p:cNvPr>
@@ -26418,7 +26418,7 @@
           <p:cNvPr id="2" name="">
             <a:extLst xmlns:a="http://schemas.openxmlformats.org/drawingml/2006/main">
               <a:ext uri="{FF2B5EF4-FFF2-40B4-BE49-F238E27FC236}">
-                <a16:creationId xmlns:a16="http://schemas.microsoft.com/office/drawing/2014/main" id="{D2BCB941-42EC-4E99-9DEE-F9BD77EB1070}"/>
+                <a16:creationId xmlns:a16="http://schemas.microsoft.com/office/drawing/2014/main" id="{E2FF6F98-41ED-4306-89F5-B2B75B41DA0D}"/>
               </a:ext>
             </a:extLst>
           </p:cNvPr>
@@ -26538,7 +26538,7 @@
           <p:cNvPr id="3" name="">
             <a:extLst xmlns:a="http://schemas.openxmlformats.org/drawingml/2006/main">
               <a:ext uri="{FF2B5EF4-FFF2-40B4-BE49-F238E27FC236}">
-                <a16:creationId xmlns:a16="http://schemas.microsoft.com/office/drawing/2014/main" id="{B4179D43-361D-4A62-9EC7-FDBF6D7EC74C}"/>
+                <a16:creationId xmlns:a16="http://schemas.microsoft.com/office/drawing/2014/main" id="{7E35E0B9-6EBC-4E53-A9FA-6DE46C04778C}"/>
               </a:ext>
             </a:extLst>
           </p:cNvPr>
@@ -26568,7 +26568,7 @@
           <p:cNvPr id="4" name="">
             <a:extLst xmlns:a="http://schemas.openxmlformats.org/drawingml/2006/main">
               <a:ext uri="{FF2B5EF4-FFF2-40B4-BE49-F238E27FC236}">
-                <a16:creationId xmlns:a16="http://schemas.microsoft.com/office/drawing/2014/main" id="{1DB8579C-58D2-4E18-B3C1-7B3508A39C63}"/>
+                <a16:creationId xmlns:a16="http://schemas.microsoft.com/office/drawing/2014/main" id="{07BFEDA8-1896-4393-9045-69C99B592063}"/>
               </a:ext>
             </a:extLst>
           </p:cNvPr>
@@ -26598,7 +26598,7 @@
           <p:cNvPr id="5" name="">
             <a:extLst xmlns:a="http://schemas.openxmlformats.org/drawingml/2006/main">
               <a:ext uri="{FF2B5EF4-FFF2-40B4-BE49-F238E27FC236}">
-                <a16:creationId xmlns:a16="http://schemas.microsoft.com/office/drawing/2014/main" id="{96A96992-FEF8-47FD-B641-4AE9F79FE51B}"/>
+                <a16:creationId xmlns:a16="http://schemas.microsoft.com/office/drawing/2014/main" id="{801105D1-2D7A-4E4B-8B35-8588D83FBF75}"/>
               </a:ext>
             </a:extLst>
           </p:cNvPr>
@@ -26718,7 +26718,7 @@
           <p:cNvPr id="6" name="">
             <a:extLst xmlns:a="http://schemas.openxmlformats.org/drawingml/2006/main">
               <a:ext uri="{FF2B5EF4-FFF2-40B4-BE49-F238E27FC236}">
-                <a16:creationId xmlns:a16="http://schemas.microsoft.com/office/drawing/2014/main" id="{A5D11FE9-E395-40A9-9912-11E598C704D4}"/>
+                <a16:creationId xmlns:a16="http://schemas.microsoft.com/office/drawing/2014/main" id="{E233A3E8-BEEB-42D8-AFA5-3FF6893AC299}"/>
               </a:ext>
             </a:extLst>
           </p:cNvPr>
@@ -26838,7 +26838,7 @@
           <p:cNvPr id="7" name="">
             <a:extLst xmlns:a="http://schemas.openxmlformats.org/drawingml/2006/main">
               <a:ext uri="{FF2B5EF4-FFF2-40B4-BE49-F238E27FC236}">
-                <a16:creationId xmlns:a16="http://schemas.microsoft.com/office/drawing/2014/main" id="{479A2553-61CB-4191-B66B-7EDEAF4FB3DD}"/>
+                <a16:creationId xmlns:a16="http://schemas.microsoft.com/office/drawing/2014/main" id="{802F14A8-9E45-455B-A6AF-F66F847ECEF9}"/>
               </a:ext>
             </a:extLst>
           </p:cNvPr>
@@ -26958,7 +26958,7 @@
           <p:cNvPr id="8" name="">
             <a:extLst xmlns:a="http://schemas.openxmlformats.org/drawingml/2006/main">
               <a:ext uri="{FF2B5EF4-FFF2-40B4-BE49-F238E27FC236}">
-                <a16:creationId xmlns:a16="http://schemas.microsoft.com/office/drawing/2014/main" id="{4F42241C-50F5-4368-9AB8-23F70DAD87D9}"/>
+                <a16:creationId xmlns:a16="http://schemas.microsoft.com/office/drawing/2014/main" id="{594948B1-93B6-47DE-9B5C-E76D68FEBCF6}"/>
               </a:ext>
             </a:extLst>
           </p:cNvPr>
@@ -26988,7 +26988,7 @@
           <p:cNvPr id="9" name="">
             <a:extLst xmlns:a="http://schemas.openxmlformats.org/drawingml/2006/main">
               <a:ext uri="{FF2B5EF4-FFF2-40B4-BE49-F238E27FC236}">
-                <a16:creationId xmlns:a16="http://schemas.microsoft.com/office/drawing/2014/main" id="{9800A266-30E5-4795-8609-AB27000F49B0}"/>
+                <a16:creationId xmlns:a16="http://schemas.microsoft.com/office/drawing/2014/main" id="{13CF17B9-BCAD-4CF3-833E-0C011BD9030A}"/>
               </a:ext>
             </a:extLst>
           </p:cNvPr>
@@ -27018,7 +27018,7 @@
           <p:cNvPr id="10" name="">
             <a:extLst xmlns:a="http://schemas.openxmlformats.org/drawingml/2006/main">
               <a:ext uri="{FF2B5EF4-FFF2-40B4-BE49-F238E27FC236}">
-                <a16:creationId xmlns:a16="http://schemas.microsoft.com/office/drawing/2014/main" id="{1311E642-272F-4B3C-9B15-B229DF38A2A8}"/>
+                <a16:creationId xmlns:a16="http://schemas.microsoft.com/office/drawing/2014/main" id="{E955DA5E-B417-4948-A4A2-38196945B018}"/>
               </a:ext>
             </a:extLst>
           </p:cNvPr>
@@ -27138,7 +27138,7 @@
           <p:cNvPr id="11" name="">
             <a:extLst xmlns:a="http://schemas.openxmlformats.org/drawingml/2006/main">
               <a:ext uri="{FF2B5EF4-FFF2-40B4-BE49-F238E27FC236}">
-                <a16:creationId xmlns:a16="http://schemas.microsoft.com/office/drawing/2014/main" id="{35B4C5D8-91CA-4123-AF3C-6408C80AEECF}"/>
+                <a16:creationId xmlns:a16="http://schemas.microsoft.com/office/drawing/2014/main" id="{490A0882-7D6D-4C58-9930-80814EFBC7E8}"/>
               </a:ext>
             </a:extLst>
           </p:cNvPr>
@@ -27258,7 +27258,7 @@
           <p:cNvPr id="12" name="">
             <a:extLst xmlns:a="http://schemas.openxmlformats.org/drawingml/2006/main">
               <a:ext uri="{FF2B5EF4-FFF2-40B4-BE49-F238E27FC236}">
-                <a16:creationId xmlns:a16="http://schemas.microsoft.com/office/drawing/2014/main" id="{A99E335A-80C2-4219-BCEE-10D47B3A283E}"/>
+                <a16:creationId xmlns:a16="http://schemas.microsoft.com/office/drawing/2014/main" id="{3B9A6971-7A36-4990-89B2-23E7684460E9}"/>
               </a:ext>
             </a:extLst>
           </p:cNvPr>
@@ -27378,7 +27378,7 @@
           <p:cNvPr id="13" name="">
             <a:extLst xmlns:a="http://schemas.openxmlformats.org/drawingml/2006/main">
               <a:ext uri="{FF2B5EF4-FFF2-40B4-BE49-F238E27FC236}">
-                <a16:creationId xmlns:a16="http://schemas.microsoft.com/office/drawing/2014/main" id="{D754CA73-C229-4F9F-A607-C8A92BE9645E}"/>
+                <a16:creationId xmlns:a16="http://schemas.microsoft.com/office/drawing/2014/main" id="{8D70F883-293F-4EC8-B2B6-C4052B301C96}"/>
               </a:ext>
             </a:extLst>
           </p:cNvPr>
@@ -27408,7 +27408,7 @@
           <p:cNvPr id="14" name="">
             <a:extLst xmlns:a="http://schemas.openxmlformats.org/drawingml/2006/main">
               <a:ext uri="{FF2B5EF4-FFF2-40B4-BE49-F238E27FC236}">
-                <a16:creationId xmlns:a16="http://schemas.microsoft.com/office/drawing/2014/main" id="{62AB8B08-9934-4ACA-827B-08F4AE0887F1}"/>
+                <a16:creationId xmlns:a16="http://schemas.microsoft.com/office/drawing/2014/main" id="{E63133E7-9AEB-4095-ACCB-A371AE64863A}"/>
               </a:ext>
             </a:extLst>
           </p:cNvPr>
@@ -27438,7 +27438,7 @@
           <p:cNvPr id="15" name="">
             <a:extLst xmlns:a="http://schemas.openxmlformats.org/drawingml/2006/main">
               <a:ext uri="{FF2B5EF4-FFF2-40B4-BE49-F238E27FC236}">
-                <a16:creationId xmlns:a16="http://schemas.microsoft.com/office/drawing/2014/main" id="{3A818B89-ECB0-4590-98FB-A362948F4691}"/>
+                <a16:creationId xmlns:a16="http://schemas.microsoft.com/office/drawing/2014/main" id="{BA01E6BA-2270-4CA8-97A9-5B11FCAD0D6C}"/>
               </a:ext>
             </a:extLst>
           </p:cNvPr>
@@ -27558,7 +27558,7 @@
           <p:cNvPr id="16" name="">
             <a:extLst xmlns:a="http://schemas.openxmlformats.org/drawingml/2006/main">
               <a:ext uri="{FF2B5EF4-FFF2-40B4-BE49-F238E27FC236}">
-                <a16:creationId xmlns:a16="http://schemas.microsoft.com/office/drawing/2014/main" id="{CB16CE21-6F49-4E03-9035-E2D080065569}"/>
+                <a16:creationId xmlns:a16="http://schemas.microsoft.com/office/drawing/2014/main" id="{EB248482-C1BE-4B4A-8F4D-B4F244B93C02}"/>
               </a:ext>
             </a:extLst>
           </p:cNvPr>
@@ -27678,7 +27678,7 @@
           <p:cNvPr id="17" name="">
             <a:extLst xmlns:a="http://schemas.openxmlformats.org/drawingml/2006/main">
               <a:ext uri="{FF2B5EF4-FFF2-40B4-BE49-F238E27FC236}">
-                <a16:creationId xmlns:a16="http://schemas.microsoft.com/office/drawing/2014/main" id="{2807827A-88E2-46E9-ADD7-0C8428DED58A}"/>
+                <a16:creationId xmlns:a16="http://schemas.microsoft.com/office/drawing/2014/main" id="{A6E1701C-9832-431F-B6BB-1A24A54E3365}"/>
               </a:ext>
             </a:extLst>
           </p:cNvPr>
@@ -27798,7 +27798,7 @@
           <p:cNvPr id="18" name="">
             <a:extLst xmlns:a="http://schemas.openxmlformats.org/drawingml/2006/main">
               <a:ext uri="{FF2B5EF4-FFF2-40B4-BE49-F238E27FC236}">
-                <a16:creationId xmlns:a16="http://schemas.microsoft.com/office/drawing/2014/main" id="{70CBFAC9-3DF3-4A4F-A77B-1F07D95D845E}"/>
+                <a16:creationId xmlns:a16="http://schemas.microsoft.com/office/drawing/2014/main" id="{E7F4B1FF-37FD-4871-9931-D05F91EDB304}"/>
               </a:ext>
             </a:extLst>
           </p:cNvPr>
@@ -27828,7 +27828,7 @@
           <p:cNvPr id="19" name="">
             <a:extLst xmlns:a="http://schemas.openxmlformats.org/drawingml/2006/main">
               <a:ext uri="{FF2B5EF4-FFF2-40B4-BE49-F238E27FC236}">
-                <a16:creationId xmlns:a16="http://schemas.microsoft.com/office/drawing/2014/main" id="{E39148D6-AEF3-407D-8671-A4D3237C821E}"/>
+                <a16:creationId xmlns:a16="http://schemas.microsoft.com/office/drawing/2014/main" id="{5431612E-5C64-4B7C-B092-02E2C3C876C8}"/>
               </a:ext>
             </a:extLst>
           </p:cNvPr>
@@ -27858,7 +27858,7 @@
           <p:cNvPr id="20" name="">
             <a:extLst xmlns:a="http://schemas.openxmlformats.org/drawingml/2006/main">
               <a:ext uri="{FF2B5EF4-FFF2-40B4-BE49-F238E27FC236}">
-                <a16:creationId xmlns:a16="http://schemas.microsoft.com/office/drawing/2014/main" id="{ED73C0E2-F81B-48CE-A47C-99B1E5AAD7C0}"/>
+                <a16:creationId xmlns:a16="http://schemas.microsoft.com/office/drawing/2014/main" id="{5C899ED1-48F5-4EB9-A669-D7290DC48C77}"/>
               </a:ext>
             </a:extLst>
           </p:cNvPr>
@@ -27978,7 +27978,7 @@
           <p:cNvPr id="21" name="">
             <a:extLst xmlns:a="http://schemas.openxmlformats.org/drawingml/2006/main">
               <a:ext uri="{FF2B5EF4-FFF2-40B4-BE49-F238E27FC236}">
-                <a16:creationId xmlns:a16="http://schemas.microsoft.com/office/drawing/2014/main" id="{66E8F4E5-DEC9-4874-BFF0-1AB91FB4444A}"/>
+                <a16:creationId xmlns:a16="http://schemas.microsoft.com/office/drawing/2014/main" id="{375267DC-E359-43D8-BC8D-E4881D6F3AC5}"/>
               </a:ext>
             </a:extLst>
           </p:cNvPr>
@@ -28098,7 +28098,7 @@
           <p:cNvPr id="22" name="">
             <a:extLst xmlns:a="http://schemas.openxmlformats.org/drawingml/2006/main">
               <a:ext uri="{FF2B5EF4-FFF2-40B4-BE49-F238E27FC236}">
-                <a16:creationId xmlns:a16="http://schemas.microsoft.com/office/drawing/2014/main" id="{FBAF9466-8E29-472B-B66D-A6DBD5EF4671}"/>
+                <a16:creationId xmlns:a16="http://schemas.microsoft.com/office/drawing/2014/main" id="{60E829B7-B505-424D-894F-BF6D32F0CBB8}"/>
               </a:ext>
             </a:extLst>
           </p:cNvPr>
@@ -28218,7 +28218,7 @@
           <p:cNvPr id="23" name="">
             <a:extLst xmlns:a="http://schemas.openxmlformats.org/drawingml/2006/main">
               <a:ext uri="{FF2B5EF4-FFF2-40B4-BE49-F238E27FC236}">
-                <a16:creationId xmlns:a16="http://schemas.microsoft.com/office/drawing/2014/main" id="{AAFD7E12-052D-4D2C-9849-362E505EDB0D}"/>
+                <a16:creationId xmlns:a16="http://schemas.microsoft.com/office/drawing/2014/main" id="{A4CD5575-62ED-4A5E-B938-C7150B26F1BE}"/>
               </a:ext>
             </a:extLst>
           </p:cNvPr>
@@ -28248,7 +28248,7 @@
           <p:cNvPr id="24" name="">
             <a:extLst xmlns:a="http://schemas.openxmlformats.org/drawingml/2006/main">
               <a:ext uri="{FF2B5EF4-FFF2-40B4-BE49-F238E27FC236}">
-                <a16:creationId xmlns:a16="http://schemas.microsoft.com/office/drawing/2014/main" id="{D8419489-1C39-4D42-9EEA-7CD9F73D5A83}"/>
+                <a16:creationId xmlns:a16="http://schemas.microsoft.com/office/drawing/2014/main" id="{908BC5B1-F27A-4F7C-95AF-3CFD61A4A5AE}"/>
               </a:ext>
             </a:extLst>
           </p:cNvPr>
@@ -28278,7 +28278,7 @@
           <p:cNvPr id="25" name="">
             <a:extLst xmlns:a="http://schemas.openxmlformats.org/drawingml/2006/main">
               <a:ext uri="{FF2B5EF4-FFF2-40B4-BE49-F238E27FC236}">
-                <a16:creationId xmlns:a16="http://schemas.microsoft.com/office/drawing/2014/main" id="{72056A84-62FC-4611-A749-ABB736211198}"/>
+                <a16:creationId xmlns:a16="http://schemas.microsoft.com/office/drawing/2014/main" id="{61748F8D-E413-40CB-9DA9-53CD424D3A11}"/>
               </a:ext>
             </a:extLst>
           </p:cNvPr>
@@ -28398,7 +28398,7 @@
           <p:cNvPr id="26" name="">
             <a:extLst xmlns:a="http://schemas.openxmlformats.org/drawingml/2006/main">
               <a:ext uri="{FF2B5EF4-FFF2-40B4-BE49-F238E27FC236}">
-                <a16:creationId xmlns:a16="http://schemas.microsoft.com/office/drawing/2014/main" id="{475963A3-7A67-4D91-97C3-0ABD0EC8AB04}"/>
+                <a16:creationId xmlns:a16="http://schemas.microsoft.com/office/drawing/2014/main" id="{0C31528C-566B-42C5-94C9-9687B7D7E61D}"/>
               </a:ext>
             </a:extLst>
           </p:cNvPr>
@@ -28518,7 +28518,7 @@
           <p:cNvPr id="27" name="">
             <a:extLst xmlns:a="http://schemas.openxmlformats.org/drawingml/2006/main">
               <a:ext uri="{FF2B5EF4-FFF2-40B4-BE49-F238E27FC236}">
-                <a16:creationId xmlns:a16="http://schemas.microsoft.com/office/drawing/2014/main" id="{D3877B31-705E-4378-B8E0-10EA0C136E5E}"/>
+                <a16:creationId xmlns:a16="http://schemas.microsoft.com/office/drawing/2014/main" id="{EEAB8E31-FEC1-43D5-958B-593C321A710F}"/>
               </a:ext>
             </a:extLst>
           </p:cNvPr>
@@ -28638,7 +28638,7 @@
           <p:cNvPr id="28" name="">
             <a:extLst xmlns:a="http://schemas.openxmlformats.org/drawingml/2006/main">
               <a:ext uri="{FF2B5EF4-FFF2-40B4-BE49-F238E27FC236}">
-                <a16:creationId xmlns:a16="http://schemas.microsoft.com/office/drawing/2014/main" id="{A922C4AC-5FCC-43A4-8434-B3C3D938CBDE}"/>
+                <a16:creationId xmlns:a16="http://schemas.microsoft.com/office/drawing/2014/main" id="{8BC8C406-FD70-4CEE-AC9E-338EAB0B01D1}"/>
               </a:ext>
             </a:extLst>
           </p:cNvPr>
@@ -28668,7 +28668,7 @@
           <p:cNvPr id="29" name="">
             <a:extLst xmlns:a="http://schemas.openxmlformats.org/drawingml/2006/main">
               <a:ext uri="{FF2B5EF4-FFF2-40B4-BE49-F238E27FC236}">
-                <a16:creationId xmlns:a16="http://schemas.microsoft.com/office/drawing/2014/main" id="{7B5AF653-32E0-4A4C-946C-F0CD0C29D0C2}"/>
+                <a16:creationId xmlns:a16="http://schemas.microsoft.com/office/drawing/2014/main" id="{1270CFE4-7B9B-4309-9F99-041F0AB96CC4}"/>
               </a:ext>
             </a:extLst>
           </p:cNvPr>
@@ -28698,7 +28698,7 @@
           <p:cNvPr id="30" name="">
             <a:extLst xmlns:a="http://schemas.openxmlformats.org/drawingml/2006/main">
               <a:ext uri="{FF2B5EF4-FFF2-40B4-BE49-F238E27FC236}">
-                <a16:creationId xmlns:a16="http://schemas.microsoft.com/office/drawing/2014/main" id="{2F7B48A9-BD31-4C3A-9F9F-A0C369BACCFA}"/>
+                <a16:creationId xmlns:a16="http://schemas.microsoft.com/office/drawing/2014/main" id="{EFBD461B-9A69-4E5A-A280-BA4524844E2E}"/>
               </a:ext>
             </a:extLst>
           </p:cNvPr>
@@ -28818,7 +28818,7 @@
           <p:cNvPr id="31" name="">
             <a:extLst xmlns:a="http://schemas.openxmlformats.org/drawingml/2006/main">
               <a:ext uri="{FF2B5EF4-FFF2-40B4-BE49-F238E27FC236}">
-                <a16:creationId xmlns:a16="http://schemas.microsoft.com/office/drawing/2014/main" id="{AA738EEA-BD44-46A7-AF98-D7D4E38F5962}"/>
+                <a16:creationId xmlns:a16="http://schemas.microsoft.com/office/drawing/2014/main" id="{07944971-36CC-419F-A7E3-9D1201418ACA}"/>
               </a:ext>
             </a:extLst>
           </p:cNvPr>
@@ -28938,7 +28938,7 @@
           <p:cNvPr id="32" name="">
             <a:extLst xmlns:a="http://schemas.openxmlformats.org/drawingml/2006/main">
               <a:ext uri="{FF2B5EF4-FFF2-40B4-BE49-F238E27FC236}">
-                <a16:creationId xmlns:a16="http://schemas.microsoft.com/office/drawing/2014/main" id="{DB3838F5-52D5-4242-8F16-8AAB183BCC86}"/>
+                <a16:creationId xmlns:a16="http://schemas.microsoft.com/office/drawing/2014/main" id="{77D93BC5-F81F-4AF5-AF22-DDAB681C8366}"/>
               </a:ext>
             </a:extLst>
           </p:cNvPr>
@@ -29058,7 +29058,7 @@
           <p:cNvPr id="33" name="">
             <a:extLst xmlns:a="http://schemas.openxmlformats.org/drawingml/2006/main">
               <a:ext uri="{FF2B5EF4-FFF2-40B4-BE49-F238E27FC236}">
-                <a16:creationId xmlns:a16="http://schemas.microsoft.com/office/drawing/2014/main" id="{C3E09AF0-5903-4639-A6FA-5A2C81DA4BE7}"/>
+                <a16:creationId xmlns:a16="http://schemas.microsoft.com/office/drawing/2014/main" id="{B722A74D-C7CD-4A77-8802-9056A0D10219}"/>
               </a:ext>
             </a:extLst>
           </p:cNvPr>
@@ -29088,7 +29088,7 @@
           <p:cNvPr id="34" name="">
             <a:extLst xmlns:a="http://schemas.openxmlformats.org/drawingml/2006/main">
               <a:ext uri="{FF2B5EF4-FFF2-40B4-BE49-F238E27FC236}">
-                <a16:creationId xmlns:a16="http://schemas.microsoft.com/office/drawing/2014/main" id="{FF0FA116-C914-4FBA-9CC8-C9B34B30C289}"/>
+                <a16:creationId xmlns:a16="http://schemas.microsoft.com/office/drawing/2014/main" id="{D7D6F994-6999-4409-A119-7D0F395B2013}"/>
               </a:ext>
             </a:extLst>
           </p:cNvPr>
@@ -29118,7 +29118,7 @@
           <p:cNvPr id="35" name="">
             <a:extLst xmlns:a="http://schemas.openxmlformats.org/drawingml/2006/main">
               <a:ext uri="{FF2B5EF4-FFF2-40B4-BE49-F238E27FC236}">
-                <a16:creationId xmlns:a16="http://schemas.microsoft.com/office/drawing/2014/main" id="{E33474AA-ABAB-494A-808D-3EB6B7ACBE16}"/>
+                <a16:creationId xmlns:a16="http://schemas.microsoft.com/office/drawing/2014/main" id="{0CC8C303-E065-46AF-AB7A-BEBD4F1EA601}"/>
               </a:ext>
             </a:extLst>
           </p:cNvPr>
@@ -29238,7 +29238,7 @@
           <p:cNvPr id="36" name="">
             <a:extLst xmlns:a="http://schemas.openxmlformats.org/drawingml/2006/main">
               <a:ext uri="{FF2B5EF4-FFF2-40B4-BE49-F238E27FC236}">
-                <a16:creationId xmlns:a16="http://schemas.microsoft.com/office/drawing/2014/main" id="{A1112C2D-DF14-4A9D-8D3E-91A78225D083}"/>
+                <a16:creationId xmlns:a16="http://schemas.microsoft.com/office/drawing/2014/main" id="{DEB12E85-7F4C-4F29-A0B5-B5FB0166CA17}"/>
               </a:ext>
             </a:extLst>
           </p:cNvPr>
@@ -29358,7 +29358,7 @@
           <p:cNvPr id="37" name="">
             <a:extLst xmlns:a="http://schemas.openxmlformats.org/drawingml/2006/main">
               <a:ext uri="{FF2B5EF4-FFF2-40B4-BE49-F238E27FC236}">
-                <a16:creationId xmlns:a16="http://schemas.microsoft.com/office/drawing/2014/main" id="{5A1FD07C-850A-4E61-B633-4E700420D6C6}"/>
+                <a16:creationId xmlns:a16="http://schemas.microsoft.com/office/drawing/2014/main" id="{197C3C2C-5E08-410B-8BC8-8AA7F0CAFB91}"/>
               </a:ext>
             </a:extLst>
           </p:cNvPr>
@@ -29478,7 +29478,7 @@
           <p:cNvPr id="38" name="">
             <a:extLst xmlns:a="http://schemas.openxmlformats.org/drawingml/2006/main">
               <a:ext uri="{FF2B5EF4-FFF2-40B4-BE49-F238E27FC236}">
-                <a16:creationId xmlns:a16="http://schemas.microsoft.com/office/drawing/2014/main" id="{56645F10-7AD8-4DF6-949A-6CA90139DC43}"/>
+                <a16:creationId xmlns:a16="http://schemas.microsoft.com/office/drawing/2014/main" id="{EF05590A-D5EE-4CC9-B3EC-8A008149A444}"/>
               </a:ext>
             </a:extLst>
           </p:cNvPr>
@@ -29598,7 +29598,7 @@
           <p:cNvPr id="39" name="">
             <a:extLst xmlns:a="http://schemas.openxmlformats.org/drawingml/2006/main">
               <a:ext uri="{FF2B5EF4-FFF2-40B4-BE49-F238E27FC236}">
-                <a16:creationId xmlns:a16="http://schemas.microsoft.com/office/drawing/2014/main" id="{4DCDC0BA-5AC0-43B6-9F4C-B46548F67156}"/>
+                <a16:creationId xmlns:a16="http://schemas.microsoft.com/office/drawing/2014/main" id="{245C9BD7-50D0-4A53-97F6-88D024D8CEBC}"/>
               </a:ext>
             </a:extLst>
           </p:cNvPr>
@@ -29718,7 +29718,7 @@
           <p:cNvPr id="40" name="">
             <a:extLst xmlns:a="http://schemas.openxmlformats.org/drawingml/2006/main">
               <a:ext uri="{FF2B5EF4-FFF2-40B4-BE49-F238E27FC236}">
-                <a16:creationId xmlns:a16="http://schemas.microsoft.com/office/drawing/2014/main" id="{AFAFCB51-E0A7-4C82-BA0E-0166AFDFC61B}"/>
+                <a16:creationId xmlns:a16="http://schemas.microsoft.com/office/drawing/2014/main" id="{EE122B3F-16DA-4AB7-B7BE-2301D5C9A1FA}"/>
               </a:ext>
             </a:extLst>
           </p:cNvPr>
@@ -29836,7 +29836,7 @@
     </p:spTree>
     <p:extLst>
       <p:ext uri="{BB962C8B-B14F-4D97-AF65-F5344CB8AC3E}">
-        <p14:creationId xmlns:p14="http://schemas.microsoft.com/office/powerpoint/2010/main" val="426916543"/>
+        <p14:creationId xmlns:p14="http://schemas.microsoft.com/office/powerpoint/2010/main" val="1845959850"/>
       </p:ext>
     </p:extLst>
   </p:cSld>

</xml_diff>